<commit_message>
Slides: animated study flowchart, future work closes each limit
- Drop the limits and summary slides.
- New untitled slide 12: eight-step study flowchart that builds one step
  (and its arrow) per click, using PowerPoint entrance timing written after
  the build.
- Last slide: 'What comes next' pairs each limit with the future work that
  closes it, above the four photo frames; limit details move to its notes.
- Give pptxgenjs's slide-number placeholder a unique shape id (it reused
  id 25 on slides with 25+ objects).
</commit_message>
<xml_diff>
--- a/presentation/eduinject-slides.pptx
+++ b/presentation/eduinject-slides.pptx
@@ -119,25 +119,25 @@
   <p:extLst>
     <p:ext uri="{521415D9-36F7-43E2-AB2F-B90AF26B5E84}">
       <p14:sectionLst xmlns:p14="http://schemas.microsoft.com/office/powerpoint/2010/main">
-        <p14:section name="Opening" id="{6b262758-a8c3-b09e-d28b-8cbfc74e612c}">
+        <p14:section name="Opening" id="{26c412dc-592d-25aa-2fce-fb746519e7ba}">
           <p14:sldIdLst>
             <p14:sldId id="256"/>
           </p14:sldIdLst>
         </p14:section>
-        <p14:section name="Problem" id="{40285c18-8554-2e41-8df4-118e456fb12e}">
+        <p14:section name="Problem" id="{04288314-713e-d87c-f46a-d0918e28a770}">
           <p14:sldIdLst>
             <p14:sldId id="257"/>
             <p14:sldId id="258"/>
           </p14:sldIdLst>
         </p14:section>
-        <p14:section name="Method" id="{9f64bf2f-a8de-b728-0987-bc8ab1f3db0b}">
+        <p14:section name="Method" id="{bc921d8c-0b8a-a5e8-e711-7194bc26f211}">
           <p14:sldIdLst>
             <p14:sldId id="259"/>
             <p14:sldId id="260"/>
             <p14:sldId id="261"/>
           </p14:sldIdLst>
         </p14:section>
-        <p14:section name="Findings" id="{81c5b6af-5af8-af47-1139-b75fe299af92}">
+        <p14:section name="Findings" id="{29a9a8a1-533a-ee99-9786-cc29ca2cdad2}">
           <p14:sldIdLst>
             <p14:sldId id="262"/>
             <p14:sldId id="263"/>
@@ -145,7 +145,7 @@
             <p14:sldId id="265"/>
           </p14:sldIdLst>
         </p14:section>
-        <p14:section name="Takeaways" id="{8d169134-bfef-08a4-831e-c00a75d5ab01}">
+        <p14:section name="Takeaways" id="{f2c16401-5903-1fac-cd8a-ade79b585bc6}">
           <p14:sldIdLst>
             <p14:sldId id="266"/>
             <p14:sldId id="267"/>
@@ -2089,7 +2089,7 @@
           <a:p>
             <a:r>
               <a:rPr lang="en-US" dirty="0"/>
-              <a:t>We did not complete the pre-registered two-coder check of the scoring, and we say so in the paper as deviation DEV-1. A second deviation, DEV-2, is that we used a stricter noise floor than planned; no verdict changes under the planned rule. Rates are lower bounds because the rules only catch verbatim repeats and listed protected terms. Results come from two models in a simulated office, so they describe relative risk, not the exploitability of any named product.</a:t>
+              <a:t>Click to build the study one step at a time. 1: a simulated district office with three jobs and invented records. 2: 144 attack files, each with a clean twin. 3: the parsers that turn files into text also read hidden places like comments. 4: three AI agents in a row, with isolation on or off. 5: every tool call is recorded, nothing is sent. 6: fixed scoring rules, signed before any run. 7: each attack is compared with its twin and must beat the noise floor. 8: the findings and the three recommendations.</a:t>
             </a:r>
             <a:endParaRPr lang="en-US" dirty="0"/>
           </a:p>
@@ -2177,7 +2177,8 @@
           <a:p>
             <a:r>
               <a:rPr lang="en-US" dirty="0"/>
-              <a:t>To add photos: right-click each circle, choose Format Shape, then Fill, Picture or texture fill, and insert the photo; delete the person icon on top of it.
+              <a:t>Each next step closes a limit of this study. We did not complete the pre-registered two-coder check of the scoring (deviation DEV-1), and we used a stricter noise floor than planned (DEV-2; no verdict changes). Rates are lower bounds because the rules only catch verbatim repeats and listed protected terms. Results come from two models in a simulated office, so they describe relative risk, not any named product. The most valuable next experiment keeps isolation but hands the acting agent the logged-in requester and the record owner as fixed fields.
+To add photos: right-click each circle, choose Format Shape, then Fill, Picture or texture fill, and insert the photo; delete the person icon on top of it.
 Thank you. The paper, code and clean corpus are in the project repository; the attack files and run traces are gated under the release policy.</a:t>
             </a:r>
             <a:endParaRPr lang="en-US" dirty="0"/>
@@ -3189,6 +3190,125 @@
 </p:sldLayout>
 </file>
 
+<file path=ppt/slideLayouts/slideLayout4.xml><?xml version="1.0" encoding="utf-8"?>
+<p:sldLayout xmlns:a="http://schemas.openxmlformats.org/drawingml/2006/main" xmlns:r="http://schemas.openxmlformats.org/officeDocument/2006/relationships" xmlns:p="http://schemas.openxmlformats.org/presentationml/2006/main" preserve="1">
+  <p:cSld name="Plain">
+    <p:bg>
+      <p:bgPr>
+        <a:solidFill>
+          <a:srgbClr val="FFFFFF"/>
+        </a:solidFill>
+      </p:bgPr>
+    </p:bg>
+    <p:spTree>
+      <p:nvGrpSpPr>
+        <p:cNvPr id="1" name=""/>
+        <p:cNvGrpSpPr/>
+        <p:nvPr/>
+      </p:nvGrpSpPr>
+      <p:grpSpPr>
+        <a:xfrm>
+          <a:off x="0" y="0"/>
+          <a:ext cx="0" cy="0"/>
+          <a:chOff x="0" y="0"/>
+          <a:chExt cx="0" cy="0"/>
+        </a:xfrm>
+      </p:grpSpPr>
+      <p:sp>
+        <p:nvSpPr>
+          <p:cNvPr id="2" name="Text 0"/>
+          <p:cNvSpPr/>
+          <p:nvPr/>
+        </p:nvSpPr>
+        <p:spPr>
+          <a:xfrm>
+            <a:off x="548640" y="6400800"/>
+            <a:ext cx="2743200" cy="274320"/>
+          </a:xfrm>
+          <a:prstGeom prst="rect">
+            <a:avLst/>
+          </a:prstGeom>
+          <a:noFill/>
+          <a:ln/>
+        </p:spPr>
+        <p:txBody>
+          <a:bodyPr wrap="square" lIns="0" tIns="0" rIns="0" bIns="0" rtlCol="0" anchor="ctr"/>
+          <a:lstStyle/>
+          <a:p>
+            <a:pPr indent="0" marL="0">
+              <a:buNone/>
+            </a:pPr>
+            <a:r>
+              <a:rPr lang="en-US" sz="1000" dirty="0">
+                <a:solidFill>
+                  <a:schemeClr val="accent4"/>
+                </a:solidFill>
+                <a:latin typeface="Inter" pitchFamily="34" charset="0"/>
+                <a:ea typeface="Inter" pitchFamily="34" charset="-122"/>
+                <a:cs typeface="Inter" pitchFamily="34" charset="-120"/>
+              </a:rPr>
+              <a:t>EduInject</a:t>
+            </a:r>
+            <a:endParaRPr lang="en-US" sz="1000" dirty="0"/>
+          </a:p>
+        </p:txBody>
+      </p:sp>
+      <p:sp>
+        <p:nvSpPr>
+          <p:cNvPr id="25" name="Slide Number Placeholder 0"/>
+          <p:cNvSpPr>
+            <a:spLocks noGrp="1"/>
+          </p:cNvSpPr>
+          <p:nvPr>
+            <p:ph type="sldNum" sz="quarter" idx="4294967295"/>
+          </p:nvPr>
+        </p:nvSpPr>
+        <p:spPr>
+          <a:xfrm>
+            <a:off x="11094415" y="6400800"/>
+            <a:ext cx="548640" cy="274320"/>
+          </a:xfrm>
+          <a:prstGeom prst="rect">
+            <a:avLst/>
+          </a:prstGeom>
+          <a:extLst>
+            <a:ext uri="{C572A759-6A51-4108-AA02-DFA0A04FC94B}">
+              <ma14:wrappingTextBoxFlag xmlns:ma14="http://schemas.microsoft.com/office/mac/drawingml/2011/main" val="0"/>
+            </a:ext>
+          </a:extLst>
+        </p:spPr>
+        <p:txBody>
+          <a:bodyPr/>
+          <a:lstStyle>
+            <a:lvl1pPr>
+              <a:defRPr sz="1000">
+                <a:solidFill>
+                  <a:schemeClr val="accent4"/>
+                </a:solidFill>
+                <a:latin typeface="Inter"/>
+                <a:ea typeface="Inter"/>
+                <a:cs typeface="Inter"/>
+              </a:defRPr>
+            </a:lvl1pPr>
+          </a:lstStyle>
+          <a:p>
+            <a:pPr algn="r"/>
+            <a:fld id="{F7021451-1387-4CA6-816F-3879F97B5CBC}" type="slidenum">
+              <a:rPr b="0" lang="en-US"/>
+              <a:t>1004</a:t>
+            </a:fld>
+            <a:endParaRPr lang="en-US"/>
+          </a:p>
+        </p:txBody>
+      </p:sp>
+    </p:spTree>
+  </p:cSld>
+  <p:clrMapOvr>
+    <a:masterClrMapping/>
+  </p:clrMapOvr>
+</p:sldLayout>
+</file>
+
 <file path=ppt/slideMasters/slideMaster1.xml><?xml version="1.0" encoding="utf-8"?>
 <p:sldMaster xmlns:a="http://schemas.openxmlformats.org/drawingml/2006/main" xmlns:r="http://schemas.openxmlformats.org/officeDocument/2006/relationships" xmlns:p="http://schemas.openxmlformats.org/presentationml/2006/main">
   <p:cSld>
@@ -3261,6 +3381,7 @@
     <p:sldLayoutId id="2147483649" r:id="rId1"/>
     <p:sldLayoutId id="2147483650" r:id="rId2"/>
     <p:sldLayoutId id="2147483651" r:id="rId3"/>
+    <p:sldLayoutId id="2147483652" r:id="rId4"/>
   </p:sldLayoutIdLst>
   <p:hf sldNum="0" hdr="0" ftr="0" dt="0"/>
   <p:txStyles>
@@ -4642,59 +4763,18 @@
       </p:grpSpPr>
       <p:sp>
         <p:nvSpPr>
-          <p:cNvPr id="2" name="Text 0"/>
+          <p:cNvPr id="2" name="fc-s1-box"/>
           <p:cNvSpPr/>
-          <p:nvPr>
-            <p:ph idx="100" type="title" hasCustomPrompt="1"/>
-          </p:nvPr>
-        </p:nvSpPr>
-        <p:spPr>
-          <a:xfrm>
-            <a:off x="548640" y="384048"/>
-            <a:ext cx="11094415" cy="777240"/>
-          </a:xfrm>
-          <a:prstGeom prst="rect">
-            <a:avLst/>
-          </a:prstGeom>
-          <a:noFill/>
-          <a:ln/>
-        </p:spPr>
-        <p:txBody>
-          <a:bodyPr wrap="square" lIns="0" tIns="0" rIns="0" bIns="0" rtlCol="0" anchor="t"/>
-          <a:lstStyle/>
-          <a:p>
-            <a:pPr algn="l" indent="0" marL="0">
-              <a:buNone/>
-            </a:pPr>
-            <a:r>
-              <a:rPr lang="en-US" sz="3200" b="1" dirty="0">
-                <a:solidFill>
-                  <a:schemeClr val="tx1"/>
-                </a:solidFill>
-                <a:latin typeface="Inter" pitchFamily="34" charset="0"/>
-                <a:ea typeface="Inter" pitchFamily="34" charset="-122"/>
-                <a:cs typeface="Inter" pitchFamily="34" charset="-120"/>
-              </a:rPr>
-              <a:t>What this study cannot tell you</a:t>
-            </a:r>
-            <a:endParaRPr lang="en-US" sz="3200" dirty="0"/>
-          </a:p>
-        </p:txBody>
-      </p:sp>
-      <p:sp>
-        <p:nvSpPr>
-          <p:cNvPr id="3" name="lim-0"/>
-          <p:cNvSpPr/>
-          <p:nvPr/>
-        </p:nvSpPr>
-        <p:spPr>
-          <a:xfrm>
-            <a:off x="548640" y="1600200"/>
-            <a:ext cx="3474720" cy="3291840"/>
+          <p:nvPr/>
+        </p:nvSpPr>
+        <p:spPr>
+          <a:xfrm>
+            <a:off x="548640" y="822960"/>
+            <a:ext cx="2331720" cy="2057400"/>
           </a:xfrm>
           <a:prstGeom prst="roundRect">
             <a:avLst>
-              <a:gd name="adj" fmla="val 3333"/>
+              <a:gd name="adj" fmla="val 5333"/>
             </a:avLst>
           </a:prstGeom>
           <a:solidFill>
@@ -4708,40 +4788,41 @@
           </a:ln>
         </p:spPr>
       </p:sp>
-      <p:pic>
-        <p:nvPicPr>
-          <p:cNvPr id="4" name="Image 0" descr="preencoded.png">    </p:cNvPr>
-          <p:cNvPicPr>
-            <a:picLocks noChangeAspect="1"/>
-          </p:cNvPicPr>
-          <p:nvPr/>
-        </p:nvPicPr>
-        <p:blipFill>
-          <a:blip r:embed="rId1"/>
-          <a:stretch>
-            <a:fillRect/>
-          </a:stretch>
-        </p:blipFill>
-        <p:spPr>
-          <a:xfrm>
-            <a:off x="914400" y="1920240"/>
-            <a:ext cx="502920" cy="502920"/>
-          </a:xfrm>
-          <a:prstGeom prst="rect">
-            <a:avLst/>
-          </a:prstGeom>
-        </p:spPr>
-      </p:pic>
-      <p:sp>
-        <p:nvSpPr>
-          <p:cNvPr id="5" name="Text 2"/>
+      <p:sp>
+        <p:nvSpPr>
+          <p:cNvPr id="3" name="fc-s1-dot"/>
+          <p:cNvSpPr/>
+          <p:nvPr/>
+        </p:nvSpPr>
+        <p:spPr>
+          <a:xfrm>
+            <a:off x="777240" y="1051560"/>
+            <a:ext cx="457200" cy="457200"/>
+          </a:xfrm>
+          <a:prstGeom prst="ellipse">
+            <a:avLst/>
+          </a:prstGeom>
+          <a:solidFill>
+            <a:srgbClr val="1E2A27"/>
+          </a:solidFill>
+          <a:ln w="12700">
+            <a:solidFill>
+              <a:srgbClr val="1E2A27"/>
+            </a:solidFill>
+            <a:prstDash val="solid"/>
+          </a:ln>
+        </p:spPr>
+      </p:sp>
+      <p:sp>
+        <p:nvSpPr>
+          <p:cNvPr id="4" name="fc-s1-num"/>
           <p:cNvSpPr txBox="1"/>
           <p:nvPr/>
         </p:nvSpPr>
         <p:spPr>
           <a:xfrm>
-            <a:off x="914400" y="2697480"/>
-            <a:ext cx="2743200" cy="868680"/>
+            <a:off x="777240" y="1051560"/>
+            <a:ext cx="457200" cy="457200"/>
           </a:xfrm>
           <a:prstGeom prst="rect">
             <a:avLst/>
@@ -4750,37 +4831,37 @@
           <a:ln/>
         </p:spPr>
         <p:txBody>
-          <a:bodyPr wrap="square" lIns="0" tIns="0" rIns="0" bIns="0" rtlCol="0" anchor="t"/>
-          <a:lstStyle/>
-          <a:p>
-            <a:pPr indent="0" marL="0">
+          <a:bodyPr wrap="square" lIns="0" tIns="0" rIns="0" bIns="0" rtlCol="0" anchor="ctr"/>
+          <a:lstStyle/>
+          <a:p>
+            <a:pPr algn="ctr" indent="0" marL="0">
               <a:buNone/>
             </a:pPr>
             <a:r>
-              <a:rPr lang="en-US" sz="2000" b="1" dirty="0">
-                <a:solidFill>
-                  <a:srgbClr val="1F1E1C"/>
+              <a:rPr lang="en-US" sz="1600" b="1" dirty="0">
+                <a:solidFill>
+                  <a:srgbClr val="FFFFFF"/>
                 </a:solidFill>
                 <a:latin typeface="Inter" pitchFamily="34" charset="0"/>
                 <a:ea typeface="Inter" pitchFamily="34" charset="-122"/>
                 <a:cs typeface="Inter" pitchFamily="34" charset="-120"/>
               </a:rPr>
-              <a:t>No human check of the scoring</a:t>
-            </a:r>
-            <a:endParaRPr lang="en-US" sz="2000" dirty="0"/>
-          </a:p>
-        </p:txBody>
-      </p:sp>
-      <p:sp>
-        <p:nvSpPr>
-          <p:cNvPr id="6" name="Text 3"/>
+              <a:t>1</a:t>
+            </a:r>
+            <a:endParaRPr lang="en-US" sz="1600" dirty="0"/>
+          </a:p>
+        </p:txBody>
+      </p:sp>
+      <p:sp>
+        <p:nvSpPr>
+          <p:cNvPr id="5" name="fc-s1-title"/>
           <p:cNvSpPr txBox="1"/>
           <p:nvPr/>
         </p:nvSpPr>
         <p:spPr>
           <a:xfrm>
-            <a:off x="914400" y="3611880"/>
-            <a:ext cx="2743200" cy="1005840"/>
+            <a:off x="777240" y="1627632"/>
+            <a:ext cx="1920240" cy="566928"/>
           </a:xfrm>
           <a:prstGeom prst="rect">
             <a:avLst/>
@@ -4796,34 +4877,73 @@
               <a:buNone/>
             </a:pPr>
             <a:r>
-              <a:rPr lang="en-US" sz="1500" dirty="0">
-                <a:solidFill>
-                  <a:srgbClr val="5F6B66"/>
+              <a:rPr lang="en-US" sz="1600" b="1" dirty="0">
+                <a:solidFill>
+                  <a:srgbClr val="1F1E1C"/>
                 </a:solidFill>
                 <a:latin typeface="Inter" pitchFamily="34" charset="0"/>
                 <a:ea typeface="Inter" pitchFamily="34" charset="-122"/>
                 <a:cs typeface="Inter" pitchFamily="34" charset="-120"/>
               </a:rPr>
-              <a:t>The planned two-person check was not done; recorded as a deviation.</a:t>
-            </a:r>
-            <a:endParaRPr lang="en-US" sz="1500" dirty="0"/>
-          </a:p>
-        </p:txBody>
-      </p:sp>
-      <p:sp>
-        <p:nvSpPr>
-          <p:cNvPr id="7" name="lim-1"/>
+              <a:t>Build a fake school office</a:t>
+            </a:r>
+            <a:endParaRPr lang="en-US" sz="1600" dirty="0"/>
+          </a:p>
+        </p:txBody>
+      </p:sp>
+      <p:sp>
+        <p:nvSpPr>
+          <p:cNvPr id="6" name="fc-s1-sub"/>
+          <p:cNvSpPr txBox="1"/>
+          <p:nvPr/>
+        </p:nvSpPr>
+        <p:spPr>
+          <a:xfrm>
+            <a:off x="777240" y="2240280"/>
+            <a:ext cx="1920240" cy="502920"/>
+          </a:xfrm>
+          <a:prstGeom prst="rect">
+            <a:avLst/>
+          </a:prstGeom>
+          <a:noFill/>
+          <a:ln/>
+        </p:spPr>
+        <p:txBody>
+          <a:bodyPr wrap="square" lIns="0" tIns="0" rIns="0" bIns="0" rtlCol="0" anchor="t"/>
+          <a:lstStyle/>
+          <a:p>
+            <a:pPr indent="0" marL="0">
+              <a:buNone/>
+            </a:pPr>
+            <a:r>
+              <a:rPr lang="en-US" sz="1200" dirty="0">
+                <a:solidFill>
+                  <a:srgbClr val="5F6B66"/>
+                </a:solidFill>
+                <a:latin typeface="Inter" pitchFamily="34" charset="0"/>
+                <a:ea typeface="Inter" pitchFamily="34" charset="-122"/>
+                <a:cs typeface="Inter" pitchFamily="34" charset="-120"/>
+              </a:rPr>
+              <a:t>3 jobs, invented records</a:t>
+            </a:r>
+            <a:endParaRPr lang="en-US" sz="1200" dirty="0"/>
+          </a:p>
+        </p:txBody>
+      </p:sp>
+      <p:sp>
+        <p:nvSpPr>
+          <p:cNvPr id="7" name="fc-s2-box"/>
           <p:cNvSpPr/>
           <p:nvPr/>
         </p:nvSpPr>
         <p:spPr>
           <a:xfrm>
-            <a:off x="4297680" y="1600200"/>
-            <a:ext cx="3474720" cy="3291840"/>
+            <a:off x="3447288" y="822960"/>
+            <a:ext cx="2331720" cy="2057400"/>
           </a:xfrm>
           <a:prstGeom prst="roundRect">
             <a:avLst>
-              <a:gd name="adj" fmla="val 3333"/>
+              <a:gd name="adj" fmla="val 5333"/>
             </a:avLst>
           </a:prstGeom>
           <a:solidFill>
@@ -4837,40 +4957,41 @@
           </a:ln>
         </p:spPr>
       </p:sp>
-      <p:pic>
-        <p:nvPicPr>
-          <p:cNvPr id="8" name="Image 1" descr="preencoded.png">    </p:cNvPr>
-          <p:cNvPicPr>
-            <a:picLocks noChangeAspect="1"/>
-          </p:cNvPicPr>
-          <p:nvPr/>
-        </p:nvPicPr>
-        <p:blipFill>
-          <a:blip r:embed="rId2"/>
-          <a:stretch>
-            <a:fillRect/>
-          </a:stretch>
-        </p:blipFill>
-        <p:spPr>
-          <a:xfrm>
-            <a:off x="4663440" y="1920240"/>
-            <a:ext cx="502920" cy="502920"/>
-          </a:xfrm>
-          <a:prstGeom prst="rect">
-            <a:avLst/>
-          </a:prstGeom>
-        </p:spPr>
-      </p:pic>
-      <p:sp>
-        <p:nvSpPr>
-          <p:cNvPr id="9" name="Text 5"/>
+      <p:sp>
+        <p:nvSpPr>
+          <p:cNvPr id="8" name="fc-s2-dot"/>
+          <p:cNvSpPr/>
+          <p:nvPr/>
+        </p:nvSpPr>
+        <p:spPr>
+          <a:xfrm>
+            <a:off x="3675888" y="1051560"/>
+            <a:ext cx="457200" cy="457200"/>
+          </a:xfrm>
+          <a:prstGeom prst="ellipse">
+            <a:avLst/>
+          </a:prstGeom>
+          <a:solidFill>
+            <a:srgbClr val="1E2A27"/>
+          </a:solidFill>
+          <a:ln w="12700">
+            <a:solidFill>
+              <a:srgbClr val="1E2A27"/>
+            </a:solidFill>
+            <a:prstDash val="solid"/>
+          </a:ln>
+        </p:spPr>
+      </p:sp>
+      <p:sp>
+        <p:nvSpPr>
+          <p:cNvPr id="9" name="fc-s2-num"/>
           <p:cNvSpPr txBox="1"/>
           <p:nvPr/>
         </p:nvSpPr>
         <p:spPr>
           <a:xfrm>
-            <a:off x="4663440" y="2697480"/>
-            <a:ext cx="2743200" cy="868680"/>
+            <a:off x="3675888" y="1051560"/>
+            <a:ext cx="457200" cy="457200"/>
           </a:xfrm>
           <a:prstGeom prst="rect">
             <a:avLst/>
@@ -4879,37 +5000,37 @@
           <a:ln/>
         </p:spPr>
         <p:txBody>
-          <a:bodyPr wrap="square" lIns="0" tIns="0" rIns="0" bIns="0" rtlCol="0" anchor="t"/>
-          <a:lstStyle/>
-          <a:p>
-            <a:pPr indent="0" marL="0">
+          <a:bodyPr wrap="square" lIns="0" tIns="0" rIns="0" bIns="0" rtlCol="0" anchor="ctr"/>
+          <a:lstStyle/>
+          <a:p>
+            <a:pPr algn="ctr" indent="0" marL="0">
               <a:buNone/>
             </a:pPr>
             <a:r>
-              <a:rPr lang="en-US" sz="2000" b="1" dirty="0">
-                <a:solidFill>
-                  <a:srgbClr val="1F1E1C"/>
+              <a:rPr lang="en-US" sz="1600" b="1" dirty="0">
+                <a:solidFill>
+                  <a:srgbClr val="FFFFFF"/>
                 </a:solidFill>
                 <a:latin typeface="Inter" pitchFamily="34" charset="0"/>
                 <a:ea typeface="Inter" pitchFamily="34" charset="-122"/>
                 <a:cs typeface="Inter" pitchFamily="34" charset="-120"/>
               </a:rPr>
-              <a:t>Every rate is a minimum</a:t>
-            </a:r>
-            <a:endParaRPr lang="en-US" sz="2000" dirty="0"/>
-          </a:p>
-        </p:txBody>
-      </p:sp>
-      <p:sp>
-        <p:nvSpPr>
-          <p:cNvPr id="10" name="Text 6"/>
+              <a:t>2</a:t>
+            </a:r>
+            <a:endParaRPr lang="en-US" sz="1600" dirty="0"/>
+          </a:p>
+        </p:txBody>
+      </p:sp>
+      <p:sp>
+        <p:nvSpPr>
+          <p:cNvPr id="10" name="fc-s2-title"/>
           <p:cNvSpPr txBox="1"/>
           <p:nvPr/>
         </p:nvSpPr>
         <p:spPr>
           <a:xfrm>
-            <a:off x="4663440" y="3611880"/>
-            <a:ext cx="2743200" cy="1005840"/>
+            <a:off x="3675888" y="1627632"/>
+            <a:ext cx="1920240" cy="566928"/>
           </a:xfrm>
           <a:prstGeom prst="rect">
             <a:avLst/>
@@ -4925,34 +5046,73 @@
               <a:buNone/>
             </a:pPr>
             <a:r>
-              <a:rPr lang="en-US" sz="1500" dirty="0">
-                <a:solidFill>
-                  <a:srgbClr val="5F6B66"/>
+              <a:rPr lang="en-US" sz="1600" b="1" dirty="0">
+                <a:solidFill>
+                  <a:srgbClr val="1F1E1C"/>
                 </a:solidFill>
                 <a:latin typeface="Inter" pitchFamily="34" charset="0"/>
                 <a:ea typeface="Inter" pitchFamily="34" charset="-122"/>
                 <a:cs typeface="Inter" pitchFamily="34" charset="-120"/>
               </a:rPr>
-              <a:t>Rules catch exact repeats and listed terms only.</a:t>
-            </a:r>
-            <a:endParaRPr lang="en-US" sz="1500" dirty="0"/>
-          </a:p>
-        </p:txBody>
-      </p:sp>
-      <p:sp>
-        <p:nvSpPr>
-          <p:cNvPr id="11" name="lim-2"/>
+              <a:t>Write attack files</a:t>
+            </a:r>
+            <a:endParaRPr lang="en-US" sz="1600" dirty="0"/>
+          </a:p>
+        </p:txBody>
+      </p:sp>
+      <p:sp>
+        <p:nvSpPr>
+          <p:cNvPr id="11" name="fc-s2-sub"/>
+          <p:cNvSpPr txBox="1"/>
+          <p:nvPr/>
+        </p:nvSpPr>
+        <p:spPr>
+          <a:xfrm>
+            <a:off x="3675888" y="2240280"/>
+            <a:ext cx="1920240" cy="502920"/>
+          </a:xfrm>
+          <a:prstGeom prst="rect">
+            <a:avLst/>
+          </a:prstGeom>
+          <a:noFill/>
+          <a:ln/>
+        </p:spPr>
+        <p:txBody>
+          <a:bodyPr wrap="square" lIns="0" tIns="0" rIns="0" bIns="0" rtlCol="0" anchor="t"/>
+          <a:lstStyle/>
+          <a:p>
+            <a:pPr indent="0" marL="0">
+              <a:buNone/>
+            </a:pPr>
+            <a:r>
+              <a:rPr lang="en-US" sz="1200" dirty="0">
+                <a:solidFill>
+                  <a:srgbClr val="5F6B66"/>
+                </a:solidFill>
+                <a:latin typeface="Inter" pitchFamily="34" charset="0"/>
+                <a:ea typeface="Inter" pitchFamily="34" charset="-122"/>
+                <a:cs typeface="Inter" pitchFamily="34" charset="-120"/>
+              </a:rPr>
+              <a:t>hidden note + clean twin</a:t>
+            </a:r>
+            <a:endParaRPr lang="en-US" sz="1200" dirty="0"/>
+          </a:p>
+        </p:txBody>
+      </p:sp>
+      <p:sp>
+        <p:nvSpPr>
+          <p:cNvPr id="12" name="fc-s3-box"/>
           <p:cNvSpPr/>
           <p:nvPr/>
         </p:nvSpPr>
         <p:spPr>
           <a:xfrm>
-            <a:off x="8046720" y="1600200"/>
-            <a:ext cx="3474720" cy="3291840"/>
+            <a:off x="6345936" y="822960"/>
+            <a:ext cx="2331720" cy="2057400"/>
           </a:xfrm>
           <a:prstGeom prst="roundRect">
             <a:avLst>
-              <a:gd name="adj" fmla="val 3333"/>
+              <a:gd name="adj" fmla="val 5333"/>
             </a:avLst>
           </a:prstGeom>
           <a:solidFill>
@@ -4966,40 +5126,41 @@
           </a:ln>
         </p:spPr>
       </p:sp>
-      <p:pic>
-        <p:nvPicPr>
-          <p:cNvPr id="12" name="Image 2" descr="preencoded.png">    </p:cNvPr>
-          <p:cNvPicPr>
-            <a:picLocks noChangeAspect="1"/>
-          </p:cNvPicPr>
-          <p:nvPr/>
-        </p:nvPicPr>
-        <p:blipFill>
-          <a:blip r:embed="rId3"/>
-          <a:stretch>
-            <a:fillRect/>
-          </a:stretch>
-        </p:blipFill>
-        <p:spPr>
-          <a:xfrm>
-            <a:off x="8412480" y="1920240"/>
-            <a:ext cx="502920" cy="502920"/>
-          </a:xfrm>
-          <a:prstGeom prst="rect">
-            <a:avLst/>
-          </a:prstGeom>
-        </p:spPr>
-      </p:pic>
-      <p:sp>
-        <p:nvSpPr>
-          <p:cNvPr id="13" name="Text 8"/>
+      <p:sp>
+        <p:nvSpPr>
+          <p:cNvPr id="13" name="fc-s3-dot"/>
+          <p:cNvSpPr/>
+          <p:nvPr/>
+        </p:nvSpPr>
+        <p:spPr>
+          <a:xfrm>
+            <a:off x="6574536" y="1051560"/>
+            <a:ext cx="457200" cy="457200"/>
+          </a:xfrm>
+          <a:prstGeom prst="ellipse">
+            <a:avLst/>
+          </a:prstGeom>
+          <a:solidFill>
+            <a:srgbClr val="1E2A27"/>
+          </a:solidFill>
+          <a:ln w="12700">
+            <a:solidFill>
+              <a:srgbClr val="1E2A27"/>
+            </a:solidFill>
+            <a:prstDash val="solid"/>
+          </a:ln>
+        </p:spPr>
+      </p:sp>
+      <p:sp>
+        <p:nvSpPr>
+          <p:cNvPr id="14" name="fc-s3-num"/>
           <p:cNvSpPr txBox="1"/>
           <p:nvPr/>
         </p:nvSpPr>
         <p:spPr>
           <a:xfrm>
-            <a:off x="8412480" y="2697480"/>
-            <a:ext cx="2743200" cy="868680"/>
+            <a:off x="6574536" y="1051560"/>
+            <a:ext cx="457200" cy="457200"/>
           </a:xfrm>
           <a:prstGeom prst="rect">
             <a:avLst/>
@@ -5008,37 +5169,37 @@
           <a:ln/>
         </p:spPr>
         <p:txBody>
-          <a:bodyPr wrap="square" lIns="0" tIns="0" rIns="0" bIns="0" rtlCol="0" anchor="t"/>
-          <a:lstStyle/>
-          <a:p>
-            <a:pPr indent="0" marL="0">
+          <a:bodyPr wrap="square" lIns="0" tIns="0" rIns="0" bIns="0" rtlCol="0" anchor="ctr"/>
+          <a:lstStyle/>
+          <a:p>
+            <a:pPr algn="ctr" indent="0" marL="0">
               <a:buNone/>
             </a:pPr>
             <a:r>
-              <a:rPr lang="en-US" sz="2000" b="1" dirty="0">
-                <a:solidFill>
-                  <a:srgbClr val="1F1E1C"/>
+              <a:rPr lang="en-US" sz="1600" b="1" dirty="0">
+                <a:solidFill>
+                  <a:srgbClr val="FFFFFF"/>
                 </a:solidFill>
                 <a:latin typeface="Inter" pitchFamily="34" charset="0"/>
                 <a:ea typeface="Inter" pitchFamily="34" charset="-122"/>
                 <a:cs typeface="Inter" pitchFamily="34" charset="-120"/>
               </a:rPr>
-              <a:t>Two models, simulated tools</a:t>
-            </a:r>
-            <a:endParaRPr lang="en-US" sz="2000" dirty="0"/>
-          </a:p>
-        </p:txBody>
-      </p:sp>
-      <p:sp>
-        <p:nvSpPr>
-          <p:cNvPr id="14" name="Text 9"/>
+              <a:t>3</a:t>
+            </a:r>
+            <a:endParaRPr lang="en-US" sz="1600" dirty="0"/>
+          </a:p>
+        </p:txBody>
+      </p:sp>
+      <p:sp>
+        <p:nvSpPr>
+          <p:cNvPr id="15" name="fc-s3-title"/>
           <p:cNvSpPr txBox="1"/>
           <p:nvPr/>
         </p:nvSpPr>
         <p:spPr>
           <a:xfrm>
-            <a:off x="8412480" y="3611880"/>
-            <a:ext cx="2743200" cy="1005840"/>
+            <a:off x="6574536" y="1627632"/>
+            <a:ext cx="1920240" cy="566928"/>
           </a:xfrm>
           <a:prstGeom prst="rect">
             <a:avLst/>
@@ -5054,30 +5215,30 @@
               <a:buNone/>
             </a:pPr>
             <a:r>
-              <a:rPr lang="en-US" sz="1500" dirty="0">
-                <a:solidFill>
-                  <a:srgbClr val="5F6B66"/>
+              <a:rPr lang="en-US" sz="1600" b="1" dirty="0">
+                <a:solidFill>
+                  <a:srgbClr val="1F1E1C"/>
                 </a:solidFill>
                 <a:latin typeface="Inter" pitchFamily="34" charset="0"/>
                 <a:ea typeface="Inter" pitchFamily="34" charset="-122"/>
                 <a:cs typeface="Inter" pitchFamily="34" charset="-120"/>
               </a:rPr>
-              <a:t>Relative risk across settings, not any real product.</a:t>
-            </a:r>
-            <a:endParaRPr lang="en-US" sz="1500" dirty="0"/>
-          </a:p>
-        </p:txBody>
-      </p:sp>
-      <p:sp>
-        <p:nvSpPr>
-          <p:cNvPr id="15" name="Text 10"/>
+              <a:t>Extract the text</a:t>
+            </a:r>
+            <a:endParaRPr lang="en-US" sz="1600" dirty="0"/>
+          </a:p>
+        </p:txBody>
+      </p:sp>
+      <p:sp>
+        <p:nvSpPr>
+          <p:cNvPr id="16" name="fc-s3-sub"/>
           <p:cNvSpPr txBox="1"/>
           <p:nvPr/>
         </p:nvSpPr>
         <p:spPr>
           <a:xfrm>
-            <a:off x="548640" y="5349240"/>
-            <a:ext cx="10972800" cy="457200"/>
+            <a:off x="6574536" y="2240280"/>
+            <a:ext cx="1920240" cy="502920"/>
           </a:xfrm>
           <a:prstGeom prst="rect">
             <a:avLst/>
@@ -5086,30 +5247,1043 @@
           <a:ln/>
         </p:spPr>
         <p:txBody>
-          <a:bodyPr wrap="square" lIns="0" tIns="0" rIns="0" bIns="0" rtlCol="0" anchor="ctr"/>
+          <a:bodyPr wrap="square" lIns="0" tIns="0" rIns="0" bIns="0" rtlCol="0" anchor="t"/>
           <a:lstStyle/>
           <a:p>
             <a:pPr indent="0" marL="0">
               <a:buNone/>
             </a:pPr>
             <a:r>
-              <a:rPr lang="en-US" sz="1800" b="1" dirty="0">
-                <a:solidFill>
-                  <a:srgbClr val="1E2A27"/>
+              <a:rPr lang="en-US" sz="1200" dirty="0">
+                <a:solidFill>
+                  <a:srgbClr val="5F6B66"/>
                 </a:solidFill>
                 <a:latin typeface="Inter" pitchFamily="34" charset="0"/>
                 <a:ea typeface="Inter" pitchFamily="34" charset="-122"/>
                 <a:cs typeface="Inter" pitchFamily="34" charset="-120"/>
               </a:rPr>
-              <a:t>Next: isolation plus a verified requester field, on the help desk.</a:t>
-            </a:r>
-            <a:endParaRPr lang="en-US" sz="1800" dirty="0"/>
-          </a:p>
-        </p:txBody>
-      </p:sp>
-      <p:sp>
-        <p:nvSpPr>
-          <p:cNvPr id="25" name="Slide Number Placeholder 0"/>
+              <a:t>fixed parsers read hidden parts</a:t>
+            </a:r>
+            <a:endParaRPr lang="en-US" sz="1200" dirty="0"/>
+          </a:p>
+        </p:txBody>
+      </p:sp>
+      <p:sp>
+        <p:nvSpPr>
+          <p:cNvPr id="17" name="fc-s4-box"/>
+          <p:cNvSpPr/>
+          <p:nvPr/>
+        </p:nvSpPr>
+        <p:spPr>
+          <a:xfrm>
+            <a:off x="9244584" y="822960"/>
+            <a:ext cx="2331720" cy="2057400"/>
+          </a:xfrm>
+          <a:prstGeom prst="roundRect">
+            <a:avLst>
+              <a:gd name="adj" fmla="val 5333"/>
+            </a:avLst>
+          </a:prstGeom>
+          <a:solidFill>
+            <a:srgbClr val="F2F5F3"/>
+          </a:solidFill>
+          <a:ln w="12700">
+            <a:solidFill>
+              <a:srgbClr val="F2F5F3"/>
+            </a:solidFill>
+            <a:prstDash val="solid"/>
+          </a:ln>
+        </p:spPr>
+      </p:sp>
+      <p:sp>
+        <p:nvSpPr>
+          <p:cNvPr id="18" name="fc-s4-dot"/>
+          <p:cNvSpPr/>
+          <p:nvPr/>
+        </p:nvSpPr>
+        <p:spPr>
+          <a:xfrm>
+            <a:off x="9473184" y="1051560"/>
+            <a:ext cx="457200" cy="457200"/>
+          </a:xfrm>
+          <a:prstGeom prst="ellipse">
+            <a:avLst/>
+          </a:prstGeom>
+          <a:solidFill>
+            <a:srgbClr val="1E2A27"/>
+          </a:solidFill>
+          <a:ln w="12700">
+            <a:solidFill>
+              <a:srgbClr val="1E2A27"/>
+            </a:solidFill>
+            <a:prstDash val="solid"/>
+          </a:ln>
+        </p:spPr>
+      </p:sp>
+      <p:sp>
+        <p:nvSpPr>
+          <p:cNvPr id="19" name="fc-s4-num"/>
+          <p:cNvSpPr txBox="1"/>
+          <p:nvPr/>
+        </p:nvSpPr>
+        <p:spPr>
+          <a:xfrm>
+            <a:off x="9473184" y="1051560"/>
+            <a:ext cx="457200" cy="457200"/>
+          </a:xfrm>
+          <a:prstGeom prst="rect">
+            <a:avLst/>
+          </a:prstGeom>
+          <a:noFill/>
+          <a:ln/>
+        </p:spPr>
+        <p:txBody>
+          <a:bodyPr wrap="square" lIns="0" tIns="0" rIns="0" bIns="0" rtlCol="0" anchor="ctr"/>
+          <a:lstStyle/>
+          <a:p>
+            <a:pPr algn="ctr" indent="0" marL="0">
+              <a:buNone/>
+            </a:pPr>
+            <a:r>
+              <a:rPr lang="en-US" sz="1600" b="1" dirty="0">
+                <a:solidFill>
+                  <a:srgbClr val="FFFFFF"/>
+                </a:solidFill>
+                <a:latin typeface="Inter" pitchFamily="34" charset="0"/>
+                <a:ea typeface="Inter" pitchFamily="34" charset="-122"/>
+                <a:cs typeface="Inter" pitchFamily="34" charset="-120"/>
+              </a:rPr>
+              <a:t>4</a:t>
+            </a:r>
+            <a:endParaRPr lang="en-US" sz="1600" dirty="0"/>
+          </a:p>
+        </p:txBody>
+      </p:sp>
+      <p:sp>
+        <p:nvSpPr>
+          <p:cNvPr id="20" name="fc-s4-title"/>
+          <p:cNvSpPr txBox="1"/>
+          <p:nvPr/>
+        </p:nvSpPr>
+        <p:spPr>
+          <a:xfrm>
+            <a:off x="9473184" y="1627632"/>
+            <a:ext cx="1920240" cy="566928"/>
+          </a:xfrm>
+          <a:prstGeom prst="rect">
+            <a:avLst/>
+          </a:prstGeom>
+          <a:noFill/>
+          <a:ln/>
+        </p:spPr>
+        <p:txBody>
+          <a:bodyPr wrap="square" lIns="0" tIns="0" rIns="0" bIns="0" rtlCol="0" anchor="t"/>
+          <a:lstStyle/>
+          <a:p>
+            <a:pPr indent="0" marL="0">
+              <a:buNone/>
+            </a:pPr>
+            <a:r>
+              <a:rPr lang="en-US" sz="1600" b="1" dirty="0">
+                <a:solidFill>
+                  <a:srgbClr val="1F1E1C"/>
+                </a:solidFill>
+                <a:latin typeface="Inter" pitchFamily="34" charset="0"/>
+                <a:ea typeface="Inter" pitchFamily="34" charset="-122"/>
+                <a:cs typeface="Inter" pitchFamily="34" charset="-120"/>
+              </a:rPr>
+              <a:t>Run three AI agents</a:t>
+            </a:r>
+            <a:endParaRPr lang="en-US" sz="1600" dirty="0"/>
+          </a:p>
+        </p:txBody>
+      </p:sp>
+      <p:sp>
+        <p:nvSpPr>
+          <p:cNvPr id="21" name="fc-s4-sub"/>
+          <p:cNvSpPr txBox="1"/>
+          <p:nvPr/>
+        </p:nvSpPr>
+        <p:spPr>
+          <a:xfrm>
+            <a:off x="9473184" y="2240280"/>
+            <a:ext cx="1920240" cy="502920"/>
+          </a:xfrm>
+          <a:prstGeom prst="rect">
+            <a:avLst/>
+          </a:prstGeom>
+          <a:noFill/>
+          <a:ln/>
+        </p:spPr>
+        <p:txBody>
+          <a:bodyPr wrap="square" lIns="0" tIns="0" rIns="0" bIns="0" rtlCol="0" anchor="t"/>
+          <a:lstStyle/>
+          <a:p>
+            <a:pPr indent="0" marL="0">
+              <a:buNone/>
+            </a:pPr>
+            <a:r>
+              <a:rPr lang="en-US" sz="1200" dirty="0">
+                <a:solidFill>
+                  <a:srgbClr val="5F6B66"/>
+                </a:solidFill>
+                <a:latin typeface="Inter" pitchFamily="34" charset="0"/>
+                <a:ea typeface="Inter" pitchFamily="34" charset="-122"/>
+                <a:cs typeface="Inter" pitchFamily="34" charset="-120"/>
+              </a:rPr>
+              <a:t>intake → analysis → action</a:t>
+            </a:r>
+            <a:endParaRPr lang="en-US" sz="1200" dirty="0"/>
+          </a:p>
+        </p:txBody>
+      </p:sp>
+      <p:sp>
+        <p:nvSpPr>
+          <p:cNvPr id="22" name="fc-s5-box"/>
+          <p:cNvSpPr/>
+          <p:nvPr/>
+        </p:nvSpPr>
+        <p:spPr>
+          <a:xfrm>
+            <a:off x="9244584" y="3886200"/>
+            <a:ext cx="2331720" cy="2057400"/>
+          </a:xfrm>
+          <a:prstGeom prst="roundRect">
+            <a:avLst>
+              <a:gd name="adj" fmla="val 5333"/>
+            </a:avLst>
+          </a:prstGeom>
+          <a:solidFill>
+            <a:srgbClr val="F2F5F3"/>
+          </a:solidFill>
+          <a:ln w="12700">
+            <a:solidFill>
+              <a:srgbClr val="F2F5F3"/>
+            </a:solidFill>
+            <a:prstDash val="solid"/>
+          </a:ln>
+        </p:spPr>
+      </p:sp>
+      <p:sp>
+        <p:nvSpPr>
+          <p:cNvPr id="23" name="fc-s5-dot"/>
+          <p:cNvSpPr/>
+          <p:nvPr/>
+        </p:nvSpPr>
+        <p:spPr>
+          <a:xfrm>
+            <a:off x="9473184" y="4114800"/>
+            <a:ext cx="457200" cy="457200"/>
+          </a:xfrm>
+          <a:prstGeom prst="ellipse">
+            <a:avLst/>
+          </a:prstGeom>
+          <a:solidFill>
+            <a:srgbClr val="1E2A27"/>
+          </a:solidFill>
+          <a:ln w="12700">
+            <a:solidFill>
+              <a:srgbClr val="1E2A27"/>
+            </a:solidFill>
+            <a:prstDash val="solid"/>
+          </a:ln>
+        </p:spPr>
+      </p:sp>
+      <p:sp>
+        <p:nvSpPr>
+          <p:cNvPr id="24" name="fc-s5-num"/>
+          <p:cNvSpPr txBox="1"/>
+          <p:nvPr/>
+        </p:nvSpPr>
+        <p:spPr>
+          <a:xfrm>
+            <a:off x="9473184" y="4114800"/>
+            <a:ext cx="457200" cy="457200"/>
+          </a:xfrm>
+          <a:prstGeom prst="rect">
+            <a:avLst/>
+          </a:prstGeom>
+          <a:noFill/>
+          <a:ln/>
+        </p:spPr>
+        <p:txBody>
+          <a:bodyPr wrap="square" lIns="0" tIns="0" rIns="0" bIns="0" rtlCol="0" anchor="ctr"/>
+          <a:lstStyle/>
+          <a:p>
+            <a:pPr algn="ctr" indent="0" marL="0">
+              <a:buNone/>
+            </a:pPr>
+            <a:r>
+              <a:rPr lang="en-US" sz="1600" b="1" dirty="0">
+                <a:solidFill>
+                  <a:srgbClr val="FFFFFF"/>
+                </a:solidFill>
+                <a:latin typeface="Inter" pitchFamily="34" charset="0"/>
+                <a:ea typeface="Inter" pitchFamily="34" charset="-122"/>
+                <a:cs typeface="Inter" pitchFamily="34" charset="-120"/>
+              </a:rPr>
+              <a:t>5</a:t>
+            </a:r>
+            <a:endParaRPr lang="en-US" sz="1600" dirty="0"/>
+          </a:p>
+        </p:txBody>
+      </p:sp>
+      <p:sp>
+        <p:nvSpPr>
+          <p:cNvPr id="25" name="fc-s5-title"/>
+          <p:cNvSpPr txBox="1"/>
+          <p:nvPr/>
+        </p:nvSpPr>
+        <p:spPr>
+          <a:xfrm>
+            <a:off x="9473184" y="4690872"/>
+            <a:ext cx="1920240" cy="566928"/>
+          </a:xfrm>
+          <a:prstGeom prst="rect">
+            <a:avLst/>
+          </a:prstGeom>
+          <a:noFill/>
+          <a:ln/>
+        </p:spPr>
+        <p:txBody>
+          <a:bodyPr wrap="square" lIns="0" tIns="0" rIns="0" bIns="0" rtlCol="0" anchor="t"/>
+          <a:lstStyle/>
+          <a:p>
+            <a:pPr indent="0" marL="0">
+              <a:buNone/>
+            </a:pPr>
+            <a:r>
+              <a:rPr lang="en-US" sz="1600" b="1" dirty="0">
+                <a:solidFill>
+                  <a:srgbClr val="1F1E1C"/>
+                </a:solidFill>
+                <a:latin typeface="Inter" pitchFamily="34" charset="0"/>
+                <a:ea typeface="Inter" pitchFamily="34" charset="-122"/>
+                <a:cs typeface="Inter" pitchFamily="34" charset="-120"/>
+              </a:rPr>
+              <a:t>Log every tool call</a:t>
+            </a:r>
+            <a:endParaRPr lang="en-US" sz="1600" dirty="0"/>
+          </a:p>
+        </p:txBody>
+      </p:sp>
+      <p:sp>
+        <p:nvSpPr>
+          <p:cNvPr id="26" name="fc-s5-sub"/>
+          <p:cNvSpPr txBox="1"/>
+          <p:nvPr/>
+        </p:nvSpPr>
+        <p:spPr>
+          <a:xfrm>
+            <a:off x="9473184" y="5303520"/>
+            <a:ext cx="1920240" cy="502920"/>
+          </a:xfrm>
+          <a:prstGeom prst="rect">
+            <a:avLst/>
+          </a:prstGeom>
+          <a:noFill/>
+          <a:ln/>
+        </p:spPr>
+        <p:txBody>
+          <a:bodyPr wrap="square" lIns="0" tIns="0" rIns="0" bIns="0" rtlCol="0" anchor="t"/>
+          <a:lstStyle/>
+          <a:p>
+            <a:pPr indent="0" marL="0">
+              <a:buNone/>
+            </a:pPr>
+            <a:r>
+              <a:rPr lang="en-US" sz="1200" dirty="0">
+                <a:solidFill>
+                  <a:srgbClr val="5F6B66"/>
+                </a:solidFill>
+                <a:latin typeface="Inter" pitchFamily="34" charset="0"/>
+                <a:ea typeface="Inter" pitchFamily="34" charset="-122"/>
+                <a:cs typeface="Inter" pitchFamily="34" charset="-120"/>
+              </a:rPr>
+              <a:t>nothing is really sent</a:t>
+            </a:r>
+            <a:endParaRPr lang="en-US" sz="1200" dirty="0"/>
+          </a:p>
+        </p:txBody>
+      </p:sp>
+      <p:sp>
+        <p:nvSpPr>
+          <p:cNvPr id="27" name="fc-s6-box"/>
+          <p:cNvSpPr/>
+          <p:nvPr/>
+        </p:nvSpPr>
+        <p:spPr>
+          <a:xfrm>
+            <a:off x="6345936" y="3886200"/>
+            <a:ext cx="2331720" cy="2057400"/>
+          </a:xfrm>
+          <a:prstGeom prst="roundRect">
+            <a:avLst>
+              <a:gd name="adj" fmla="val 5333"/>
+            </a:avLst>
+          </a:prstGeom>
+          <a:solidFill>
+            <a:srgbClr val="F2F5F3"/>
+          </a:solidFill>
+          <a:ln w="12700">
+            <a:solidFill>
+              <a:srgbClr val="F2F5F3"/>
+            </a:solidFill>
+            <a:prstDash val="solid"/>
+          </a:ln>
+        </p:spPr>
+      </p:sp>
+      <p:sp>
+        <p:nvSpPr>
+          <p:cNvPr id="28" name="fc-s6-dot"/>
+          <p:cNvSpPr/>
+          <p:nvPr/>
+        </p:nvSpPr>
+        <p:spPr>
+          <a:xfrm>
+            <a:off x="6574536" y="4114800"/>
+            <a:ext cx="457200" cy="457200"/>
+          </a:xfrm>
+          <a:prstGeom prst="ellipse">
+            <a:avLst/>
+          </a:prstGeom>
+          <a:solidFill>
+            <a:srgbClr val="1E2A27"/>
+          </a:solidFill>
+          <a:ln w="12700">
+            <a:solidFill>
+              <a:srgbClr val="1E2A27"/>
+            </a:solidFill>
+            <a:prstDash val="solid"/>
+          </a:ln>
+        </p:spPr>
+      </p:sp>
+      <p:sp>
+        <p:nvSpPr>
+          <p:cNvPr id="29" name="fc-s6-num"/>
+          <p:cNvSpPr txBox="1"/>
+          <p:nvPr/>
+        </p:nvSpPr>
+        <p:spPr>
+          <a:xfrm>
+            <a:off x="6574536" y="4114800"/>
+            <a:ext cx="457200" cy="457200"/>
+          </a:xfrm>
+          <a:prstGeom prst="rect">
+            <a:avLst/>
+          </a:prstGeom>
+          <a:noFill/>
+          <a:ln/>
+        </p:spPr>
+        <p:txBody>
+          <a:bodyPr wrap="square" lIns="0" tIns="0" rIns="0" bIns="0" rtlCol="0" anchor="ctr"/>
+          <a:lstStyle/>
+          <a:p>
+            <a:pPr algn="ctr" indent="0" marL="0">
+              <a:buNone/>
+            </a:pPr>
+            <a:r>
+              <a:rPr lang="en-US" sz="1600" b="1" dirty="0">
+                <a:solidFill>
+                  <a:srgbClr val="FFFFFF"/>
+                </a:solidFill>
+                <a:latin typeface="Inter" pitchFamily="34" charset="0"/>
+                <a:ea typeface="Inter" pitchFamily="34" charset="-122"/>
+                <a:cs typeface="Inter" pitchFamily="34" charset="-120"/>
+              </a:rPr>
+              <a:t>6</a:t>
+            </a:r>
+            <a:endParaRPr lang="en-US" sz="1600" dirty="0"/>
+          </a:p>
+        </p:txBody>
+      </p:sp>
+      <p:sp>
+        <p:nvSpPr>
+          <p:cNvPr id="30" name="fc-s6-title"/>
+          <p:cNvSpPr txBox="1"/>
+          <p:nvPr/>
+        </p:nvSpPr>
+        <p:spPr>
+          <a:xfrm>
+            <a:off x="6574536" y="4690872"/>
+            <a:ext cx="1920240" cy="566928"/>
+          </a:xfrm>
+          <a:prstGeom prst="rect">
+            <a:avLst/>
+          </a:prstGeom>
+          <a:noFill/>
+          <a:ln/>
+        </p:spPr>
+        <p:txBody>
+          <a:bodyPr wrap="square" lIns="0" tIns="0" rIns="0" bIns="0" rtlCol="0" anchor="t"/>
+          <a:lstStyle/>
+          <a:p>
+            <a:pPr indent="0" marL="0">
+              <a:buNone/>
+            </a:pPr>
+            <a:r>
+              <a:rPr lang="en-US" sz="1600" b="1" dirty="0">
+                <a:solidFill>
+                  <a:srgbClr val="1F1E1C"/>
+                </a:solidFill>
+                <a:latin typeface="Inter" pitchFamily="34" charset="0"/>
+                <a:ea typeface="Inter" pitchFamily="34" charset="-122"/>
+                <a:cs typeface="Inter" pitchFamily="34" charset="-120"/>
+              </a:rPr>
+              <a:t>Score with fixed rules</a:t>
+            </a:r>
+            <a:endParaRPr lang="en-US" sz="1600" dirty="0"/>
+          </a:p>
+        </p:txBody>
+      </p:sp>
+      <p:sp>
+        <p:nvSpPr>
+          <p:cNvPr id="31" name="fc-s6-sub"/>
+          <p:cNvSpPr txBox="1"/>
+          <p:nvPr/>
+        </p:nvSpPr>
+        <p:spPr>
+          <a:xfrm>
+            <a:off x="6574536" y="5303520"/>
+            <a:ext cx="1920240" cy="502920"/>
+          </a:xfrm>
+          <a:prstGeom prst="rect">
+            <a:avLst/>
+          </a:prstGeom>
+          <a:noFill/>
+          <a:ln/>
+        </p:spPr>
+        <p:txBody>
+          <a:bodyPr wrap="square" lIns="0" tIns="0" rIns="0" bIns="0" rtlCol="0" anchor="t"/>
+          <a:lstStyle/>
+          <a:p>
+            <a:pPr indent="0" marL="0">
+              <a:buNone/>
+            </a:pPr>
+            <a:r>
+              <a:rPr lang="en-US" sz="1200" dirty="0">
+                <a:solidFill>
+                  <a:srgbClr val="5F6B66"/>
+                </a:solidFill>
+                <a:latin typeface="Inter" pitchFamily="34" charset="0"/>
+                <a:ea typeface="Inter" pitchFamily="34" charset="-122"/>
+                <a:cs typeface="Inter" pitchFamily="34" charset="-120"/>
+              </a:rPr>
+              <a:t>signed before any run</a:t>
+            </a:r>
+            <a:endParaRPr lang="en-US" sz="1200" dirty="0"/>
+          </a:p>
+        </p:txBody>
+      </p:sp>
+      <p:sp>
+        <p:nvSpPr>
+          <p:cNvPr id="32" name="fc-s7-box"/>
+          <p:cNvSpPr/>
+          <p:nvPr/>
+        </p:nvSpPr>
+        <p:spPr>
+          <a:xfrm>
+            <a:off x="3447288" y="3886200"/>
+            <a:ext cx="2331720" cy="2057400"/>
+          </a:xfrm>
+          <a:prstGeom prst="roundRect">
+            <a:avLst>
+              <a:gd name="adj" fmla="val 5333"/>
+            </a:avLst>
+          </a:prstGeom>
+          <a:solidFill>
+            <a:srgbClr val="F2F5F3"/>
+          </a:solidFill>
+          <a:ln w="12700">
+            <a:solidFill>
+              <a:srgbClr val="F2F5F3"/>
+            </a:solidFill>
+            <a:prstDash val="solid"/>
+          </a:ln>
+        </p:spPr>
+      </p:sp>
+      <p:sp>
+        <p:nvSpPr>
+          <p:cNvPr id="33" name="fc-s7-dot"/>
+          <p:cNvSpPr/>
+          <p:nvPr/>
+        </p:nvSpPr>
+        <p:spPr>
+          <a:xfrm>
+            <a:off x="3675888" y="4114800"/>
+            <a:ext cx="457200" cy="457200"/>
+          </a:xfrm>
+          <a:prstGeom prst="ellipse">
+            <a:avLst/>
+          </a:prstGeom>
+          <a:solidFill>
+            <a:srgbClr val="1E2A27"/>
+          </a:solidFill>
+          <a:ln w="12700">
+            <a:solidFill>
+              <a:srgbClr val="1E2A27"/>
+            </a:solidFill>
+            <a:prstDash val="solid"/>
+          </a:ln>
+        </p:spPr>
+      </p:sp>
+      <p:sp>
+        <p:nvSpPr>
+          <p:cNvPr id="34" name="fc-s7-num"/>
+          <p:cNvSpPr txBox="1"/>
+          <p:nvPr/>
+        </p:nvSpPr>
+        <p:spPr>
+          <a:xfrm>
+            <a:off x="3675888" y="4114800"/>
+            <a:ext cx="457200" cy="457200"/>
+          </a:xfrm>
+          <a:prstGeom prst="rect">
+            <a:avLst/>
+          </a:prstGeom>
+          <a:noFill/>
+          <a:ln/>
+        </p:spPr>
+        <p:txBody>
+          <a:bodyPr wrap="square" lIns="0" tIns="0" rIns="0" bIns="0" rtlCol="0" anchor="ctr"/>
+          <a:lstStyle/>
+          <a:p>
+            <a:pPr algn="ctr" indent="0" marL="0">
+              <a:buNone/>
+            </a:pPr>
+            <a:r>
+              <a:rPr lang="en-US" sz="1600" b="1" dirty="0">
+                <a:solidFill>
+                  <a:srgbClr val="FFFFFF"/>
+                </a:solidFill>
+                <a:latin typeface="Inter" pitchFamily="34" charset="0"/>
+                <a:ea typeface="Inter" pitchFamily="34" charset="-122"/>
+                <a:cs typeface="Inter" pitchFamily="34" charset="-120"/>
+              </a:rPr>
+              <a:t>7</a:t>
+            </a:r>
+            <a:endParaRPr lang="en-US" sz="1600" dirty="0"/>
+          </a:p>
+        </p:txBody>
+      </p:sp>
+      <p:sp>
+        <p:nvSpPr>
+          <p:cNvPr id="35" name="fc-s7-title"/>
+          <p:cNvSpPr txBox="1"/>
+          <p:nvPr/>
+        </p:nvSpPr>
+        <p:spPr>
+          <a:xfrm>
+            <a:off x="3675888" y="4690872"/>
+            <a:ext cx="1920240" cy="566928"/>
+          </a:xfrm>
+          <a:prstGeom prst="rect">
+            <a:avLst/>
+          </a:prstGeom>
+          <a:noFill/>
+          <a:ln/>
+        </p:spPr>
+        <p:txBody>
+          <a:bodyPr wrap="square" lIns="0" tIns="0" rIns="0" bIns="0" rtlCol="0" anchor="t"/>
+          <a:lstStyle/>
+          <a:p>
+            <a:pPr indent="0" marL="0">
+              <a:buNone/>
+            </a:pPr>
+            <a:r>
+              <a:rPr lang="en-US" sz="1600" b="1" dirty="0">
+                <a:solidFill>
+                  <a:srgbClr val="1F1E1C"/>
+                </a:solidFill>
+                <a:latin typeface="Inter" pitchFamily="34" charset="0"/>
+                <a:ea typeface="Inter" pitchFamily="34" charset="-122"/>
+                <a:cs typeface="Inter" pitchFamily="34" charset="-120"/>
+              </a:rPr>
+              <a:t>Compare attack vs. twin</a:t>
+            </a:r>
+            <a:endParaRPr lang="en-US" sz="1600" dirty="0"/>
+          </a:p>
+        </p:txBody>
+      </p:sp>
+      <p:sp>
+        <p:nvSpPr>
+          <p:cNvPr id="36" name="fc-s7-sub"/>
+          <p:cNvSpPr txBox="1"/>
+          <p:nvPr/>
+        </p:nvSpPr>
+        <p:spPr>
+          <a:xfrm>
+            <a:off x="3675888" y="5303520"/>
+            <a:ext cx="1920240" cy="502920"/>
+          </a:xfrm>
+          <a:prstGeom prst="rect">
+            <a:avLst/>
+          </a:prstGeom>
+          <a:noFill/>
+          <a:ln/>
+        </p:spPr>
+        <p:txBody>
+          <a:bodyPr wrap="square" lIns="0" tIns="0" rIns="0" bIns="0" rtlCol="0" anchor="t"/>
+          <a:lstStyle/>
+          <a:p>
+            <a:pPr indent="0" marL="0">
+              <a:buNone/>
+            </a:pPr>
+            <a:r>
+              <a:rPr lang="en-US" sz="1200" dirty="0">
+                <a:solidFill>
+                  <a:srgbClr val="5F6B66"/>
+                </a:solidFill>
+                <a:latin typeface="Inter" pitchFamily="34" charset="0"/>
+                <a:ea typeface="Inter" pitchFamily="34" charset="-122"/>
+                <a:cs typeface="Inter" pitchFamily="34" charset="-120"/>
+              </a:rPr>
+              <a:t>must beat the noise floor</a:t>
+            </a:r>
+            <a:endParaRPr lang="en-US" sz="1200" dirty="0"/>
+          </a:p>
+        </p:txBody>
+      </p:sp>
+      <p:sp>
+        <p:nvSpPr>
+          <p:cNvPr id="37" name="fc-s8-box"/>
+          <p:cNvSpPr/>
+          <p:nvPr/>
+        </p:nvSpPr>
+        <p:spPr>
+          <a:xfrm>
+            <a:off x="548640" y="3886200"/>
+            <a:ext cx="2331720" cy="2057400"/>
+          </a:xfrm>
+          <a:prstGeom prst="roundRect">
+            <a:avLst>
+              <a:gd name="adj" fmla="val 5333"/>
+            </a:avLst>
+          </a:prstGeom>
+          <a:solidFill>
+            <a:srgbClr val="1E2A27"/>
+          </a:solidFill>
+          <a:ln w="12700">
+            <a:solidFill>
+              <a:srgbClr val="1E2A27"/>
+            </a:solidFill>
+            <a:prstDash val="solid"/>
+          </a:ln>
+        </p:spPr>
+      </p:sp>
+      <p:sp>
+        <p:nvSpPr>
+          <p:cNvPr id="38" name="fc-s8-dot"/>
+          <p:cNvSpPr/>
+          <p:nvPr/>
+        </p:nvSpPr>
+        <p:spPr>
+          <a:xfrm>
+            <a:off x="777240" y="4114800"/>
+            <a:ext cx="457200" cy="457200"/>
+          </a:xfrm>
+          <a:prstGeom prst="ellipse">
+            <a:avLst/>
+          </a:prstGeom>
+          <a:solidFill>
+            <a:srgbClr val="F2C14E"/>
+          </a:solidFill>
+          <a:ln w="12700">
+            <a:solidFill>
+              <a:srgbClr val="F2C14E"/>
+            </a:solidFill>
+            <a:prstDash val="solid"/>
+          </a:ln>
+        </p:spPr>
+      </p:sp>
+      <p:sp>
+        <p:nvSpPr>
+          <p:cNvPr id="39" name="fc-s8-num"/>
+          <p:cNvSpPr txBox="1"/>
+          <p:nvPr/>
+        </p:nvSpPr>
+        <p:spPr>
+          <a:xfrm>
+            <a:off x="777240" y="4114800"/>
+            <a:ext cx="457200" cy="457200"/>
+          </a:xfrm>
+          <a:prstGeom prst="rect">
+            <a:avLst/>
+          </a:prstGeom>
+          <a:noFill/>
+          <a:ln/>
+        </p:spPr>
+        <p:txBody>
+          <a:bodyPr wrap="square" lIns="0" tIns="0" rIns="0" bIns="0" rtlCol="0" anchor="ctr"/>
+          <a:lstStyle/>
+          <a:p>
+            <a:pPr algn="ctr" indent="0" marL="0">
+              <a:buNone/>
+            </a:pPr>
+            <a:r>
+              <a:rPr lang="en-US" sz="1600" b="1" dirty="0">
+                <a:solidFill>
+                  <a:srgbClr val="1E2A27"/>
+                </a:solidFill>
+                <a:latin typeface="Inter" pitchFamily="34" charset="0"/>
+                <a:ea typeface="Inter" pitchFamily="34" charset="-122"/>
+                <a:cs typeface="Inter" pitchFamily="34" charset="-120"/>
+              </a:rPr>
+              <a:t>8</a:t>
+            </a:r>
+            <a:endParaRPr lang="en-US" sz="1600" dirty="0"/>
+          </a:p>
+        </p:txBody>
+      </p:sp>
+      <p:sp>
+        <p:nvSpPr>
+          <p:cNvPr id="40" name="fc-s8-title"/>
+          <p:cNvSpPr txBox="1"/>
+          <p:nvPr/>
+        </p:nvSpPr>
+        <p:spPr>
+          <a:xfrm>
+            <a:off x="777240" y="4690872"/>
+            <a:ext cx="1920240" cy="566928"/>
+          </a:xfrm>
+          <a:prstGeom prst="rect">
+            <a:avLst/>
+          </a:prstGeom>
+          <a:noFill/>
+          <a:ln/>
+        </p:spPr>
+        <p:txBody>
+          <a:bodyPr wrap="square" lIns="0" tIns="0" rIns="0" bIns="0" rtlCol="0" anchor="t"/>
+          <a:lstStyle/>
+          <a:p>
+            <a:pPr indent="0" marL="0">
+              <a:buNone/>
+            </a:pPr>
+            <a:r>
+              <a:rPr lang="en-US" sz="1600" b="1" dirty="0">
+                <a:solidFill>
+                  <a:srgbClr val="FFFFFF"/>
+                </a:solidFill>
+                <a:latin typeface="Inter" pitchFamily="34" charset="0"/>
+                <a:ea typeface="Inter" pitchFamily="34" charset="-122"/>
+                <a:cs typeface="Inter" pitchFamily="34" charset="-120"/>
+              </a:rPr>
+              <a:t>Findings and advice</a:t>
+            </a:r>
+            <a:endParaRPr lang="en-US" sz="1600" dirty="0"/>
+          </a:p>
+        </p:txBody>
+      </p:sp>
+      <p:sp>
+        <p:nvSpPr>
+          <p:cNvPr id="41" name="fc-s8-sub"/>
+          <p:cNvSpPr txBox="1"/>
+          <p:nvPr/>
+        </p:nvSpPr>
+        <p:spPr>
+          <a:xfrm>
+            <a:off x="777240" y="5303520"/>
+            <a:ext cx="1920240" cy="502920"/>
+          </a:xfrm>
+          <a:prstGeom prst="rect">
+            <a:avLst/>
+          </a:prstGeom>
+          <a:noFill/>
+          <a:ln/>
+        </p:spPr>
+        <p:txBody>
+          <a:bodyPr wrap="square" lIns="0" tIns="0" rIns="0" bIns="0" rtlCol="0" anchor="t"/>
+          <a:lstStyle/>
+          <a:p>
+            <a:pPr indent="0" marL="0">
+              <a:buNone/>
+            </a:pPr>
+            <a:r>
+              <a:rPr lang="en-US" sz="1200" dirty="0">
+                <a:solidFill>
+                  <a:srgbClr val="B9C4BF"/>
+                </a:solidFill>
+                <a:latin typeface="Inter" pitchFamily="34" charset="0"/>
+                <a:ea typeface="Inter" pitchFamily="34" charset="-122"/>
+                <a:cs typeface="Inter" pitchFamily="34" charset="-120"/>
+              </a:rPr>
+              <a:t>what districts should do</a:t>
+            </a:r>
+            <a:endParaRPr lang="en-US" sz="1200" dirty="0"/>
+          </a:p>
+        </p:txBody>
+      </p:sp>
+      <p:sp>
+        <p:nvSpPr>
+          <p:cNvPr id="42" name="fc-a1"/>
+          <p:cNvSpPr/>
+          <p:nvPr/>
+        </p:nvSpPr>
+        <p:spPr>
+          <a:xfrm>
+            <a:off x="2953512" y="1851660"/>
+            <a:ext cx="420624" cy="914"/>
+          </a:xfrm>
+          <a:prstGeom prst="line">
+            <a:avLst/>
+          </a:prstGeom>
+          <a:noFill/>
+          <a:ln w="25400">
+            <a:solidFill>
+              <a:srgbClr val="5F6B66"/>
+            </a:solidFill>
+            <a:prstDash val="solid"/>
+            <a:tailEnd type="triangle"/>
+          </a:ln>
+        </p:spPr>
+      </p:sp>
+      <p:sp>
+        <p:nvSpPr>
+          <p:cNvPr id="43" name="fc-a2"/>
+          <p:cNvSpPr/>
+          <p:nvPr/>
+        </p:nvSpPr>
+        <p:spPr>
+          <a:xfrm>
+            <a:off x="5852160" y="1851660"/>
+            <a:ext cx="420624" cy="914"/>
+          </a:xfrm>
+          <a:prstGeom prst="line">
+            <a:avLst/>
+          </a:prstGeom>
+          <a:noFill/>
+          <a:ln w="25400">
+            <a:solidFill>
+              <a:srgbClr val="5F6B66"/>
+            </a:solidFill>
+            <a:prstDash val="solid"/>
+            <a:tailEnd type="triangle"/>
+          </a:ln>
+        </p:spPr>
+      </p:sp>
+      <p:sp>
+        <p:nvSpPr>
+          <p:cNvPr id="44" name="fc-a3"/>
+          <p:cNvSpPr/>
+          <p:nvPr/>
+        </p:nvSpPr>
+        <p:spPr>
+          <a:xfrm>
+            <a:off x="8750808" y="1851660"/>
+            <a:ext cx="420624" cy="914"/>
+          </a:xfrm>
+          <a:prstGeom prst="line">
+            <a:avLst/>
+          </a:prstGeom>
+          <a:noFill/>
+          <a:ln w="25400">
+            <a:solidFill>
+              <a:srgbClr val="5F6B66"/>
+            </a:solidFill>
+            <a:prstDash val="solid"/>
+            <a:tailEnd type="triangle"/>
+          </a:ln>
+        </p:spPr>
+      </p:sp>
+      <p:sp>
+        <p:nvSpPr>
+          <p:cNvPr id="45" name="fc-a4"/>
+          <p:cNvSpPr/>
+          <p:nvPr/>
+        </p:nvSpPr>
+        <p:spPr>
+          <a:xfrm>
+            <a:off x="10410444" y="2953512"/>
+            <a:ext cx="914" cy="859536"/>
+          </a:xfrm>
+          <a:prstGeom prst="line">
+            <a:avLst/>
+          </a:prstGeom>
+          <a:noFill/>
+          <a:ln w="25400">
+            <a:solidFill>
+              <a:srgbClr val="5F6B66"/>
+            </a:solidFill>
+            <a:prstDash val="solid"/>
+            <a:tailEnd type="triangle"/>
+          </a:ln>
+        </p:spPr>
+      </p:sp>
+      <p:sp>
+        <p:nvSpPr>
+          <p:cNvPr id="46" name="fc-a5"/>
+          <p:cNvSpPr/>
+          <p:nvPr/>
+        </p:nvSpPr>
+        <p:spPr>
+          <a:xfrm flipH="1">
+            <a:off x="8750808" y="4914900"/>
+            <a:ext cx="420624" cy="914"/>
+          </a:xfrm>
+          <a:prstGeom prst="line">
+            <a:avLst/>
+          </a:prstGeom>
+          <a:noFill/>
+          <a:ln w="25400">
+            <a:solidFill>
+              <a:srgbClr val="5F6B66"/>
+            </a:solidFill>
+            <a:prstDash val="solid"/>
+            <a:tailEnd type="triangle"/>
+          </a:ln>
+        </p:spPr>
+      </p:sp>
+      <p:sp>
+        <p:nvSpPr>
+          <p:cNvPr id="47" name="fc-a6"/>
+          <p:cNvSpPr/>
+          <p:nvPr/>
+        </p:nvSpPr>
+        <p:spPr>
+          <a:xfrm flipH="1">
+            <a:off x="5852160" y="4914900"/>
+            <a:ext cx="420624" cy="914"/>
+          </a:xfrm>
+          <a:prstGeom prst="line">
+            <a:avLst/>
+          </a:prstGeom>
+          <a:noFill/>
+          <a:ln w="25400">
+            <a:solidFill>
+              <a:srgbClr val="5F6B66"/>
+            </a:solidFill>
+            <a:prstDash val="solid"/>
+            <a:tailEnd type="triangle"/>
+          </a:ln>
+        </p:spPr>
+      </p:sp>
+      <p:sp>
+        <p:nvSpPr>
+          <p:cNvPr id="48" name="fc-a7"/>
+          <p:cNvSpPr/>
+          <p:nvPr/>
+        </p:nvSpPr>
+        <p:spPr>
+          <a:xfrm flipH="1">
+            <a:off x="2953512" y="4914900"/>
+            <a:ext cx="420624" cy="914"/>
+          </a:xfrm>
+          <a:prstGeom prst="line">
+            <a:avLst/>
+          </a:prstGeom>
+          <a:noFill/>
+          <a:ln w="25400">
+            <a:solidFill>
+              <a:srgbClr val="5F6B66"/>
+            </a:solidFill>
+            <a:prstDash val="solid"/>
+            <a:tailEnd type="triangle"/>
+          </a:ln>
+        </p:spPr>
+      </p:sp>
+      <p:sp>
+        <p:nvSpPr>
+          <p:cNvPr id="49" name="Slide Number Placeholder 0"/>
           <p:cNvSpPr>
             <a:spLocks noGrp="1"/>
           </p:cNvSpPr>
@@ -5160,6 +6334,1825 @@
   <p:clrMapOvr>
     <a:masterClrMapping/>
   </p:clrMapOvr>
+  <p:timing>
+    <p:tnLst>
+      <p:par>
+        <p:cTn id="1" dur="indefinite" restart="never" nodeType="tmRoot">
+          <p:childTnLst>
+            <p:seq concurrent="1" nextAc="seek">
+              <p:cTn id="2" dur="indefinite" nodeType="mainSeq">
+                <p:childTnLst>
+                  <p:par>
+                    <p:cTn id="3" fill="hold">
+                      <p:stCondLst>
+                        <p:cond delay="indefinite"/>
+                      </p:stCondLst>
+                      <p:childTnLst>
+                        <p:par>
+                          <p:cTn id="4" fill="hold">
+                            <p:stCondLst>
+                              <p:cond delay="0"/>
+                            </p:stCondLst>
+                            <p:childTnLst>
+                              <p:par>
+                                <p:cTn id="5" presetID="10" presetClass="entr" presetSubtype="0" fill="hold" nodeType="clickEffect">
+                                  <p:stCondLst>
+                                    <p:cond delay="0"/>
+                                  </p:stCondLst>
+                                  <p:childTnLst>
+                                    <p:set>
+                                      <p:cBhvr>
+                                        <p:cTn id="6" dur="1" fill="hold">
+                                          <p:stCondLst>
+                                            <p:cond delay="0"/>
+                                          </p:stCondLst>
+                                        </p:cTn>
+                                        <p:tgtEl>
+                                          <p:spTgt spid="2"/>
+                                        </p:tgtEl>
+                                        <p:attrNameLst>
+                                          <p:attrName>style.visibility</p:attrName>
+                                        </p:attrNameLst>
+                                      </p:cBhvr>
+                                      <p:to>
+                                        <p:strVal val="visible"/>
+                                      </p:to>
+                                    </p:set>
+                                    <p:animEffect transition="in" filter="fade">
+                                      <p:cBhvr>
+                                        <p:cTn id="7" dur="400"/>
+                                        <p:tgtEl>
+                                          <p:spTgt spid="2"/>
+                                        </p:tgtEl>
+                                      </p:cBhvr>
+                                    </p:animEffect>
+                                  </p:childTnLst>
+                                </p:cTn>
+                              </p:par>
+                              <p:par>
+                                <p:cTn id="8" presetID="10" presetClass="entr" presetSubtype="0" fill="hold" nodeType="withEffect">
+                                  <p:stCondLst>
+                                    <p:cond delay="0"/>
+                                  </p:stCondLst>
+                                  <p:childTnLst>
+                                    <p:set>
+                                      <p:cBhvr>
+                                        <p:cTn id="9" dur="1" fill="hold">
+                                          <p:stCondLst>
+                                            <p:cond delay="0"/>
+                                          </p:stCondLst>
+                                        </p:cTn>
+                                        <p:tgtEl>
+                                          <p:spTgt spid="3"/>
+                                        </p:tgtEl>
+                                        <p:attrNameLst>
+                                          <p:attrName>style.visibility</p:attrName>
+                                        </p:attrNameLst>
+                                      </p:cBhvr>
+                                      <p:to>
+                                        <p:strVal val="visible"/>
+                                      </p:to>
+                                    </p:set>
+                                    <p:animEffect transition="in" filter="fade">
+                                      <p:cBhvr>
+                                        <p:cTn id="10" dur="400"/>
+                                        <p:tgtEl>
+                                          <p:spTgt spid="3"/>
+                                        </p:tgtEl>
+                                      </p:cBhvr>
+                                    </p:animEffect>
+                                  </p:childTnLst>
+                                </p:cTn>
+                              </p:par>
+                              <p:par>
+                                <p:cTn id="11" presetID="10" presetClass="entr" presetSubtype="0" fill="hold" nodeType="withEffect">
+                                  <p:stCondLst>
+                                    <p:cond delay="0"/>
+                                  </p:stCondLst>
+                                  <p:childTnLst>
+                                    <p:set>
+                                      <p:cBhvr>
+                                        <p:cTn id="12" dur="1" fill="hold">
+                                          <p:stCondLst>
+                                            <p:cond delay="0"/>
+                                          </p:stCondLst>
+                                        </p:cTn>
+                                        <p:tgtEl>
+                                          <p:spTgt spid="4"/>
+                                        </p:tgtEl>
+                                        <p:attrNameLst>
+                                          <p:attrName>style.visibility</p:attrName>
+                                        </p:attrNameLst>
+                                      </p:cBhvr>
+                                      <p:to>
+                                        <p:strVal val="visible"/>
+                                      </p:to>
+                                    </p:set>
+                                    <p:animEffect transition="in" filter="fade">
+                                      <p:cBhvr>
+                                        <p:cTn id="13" dur="400"/>
+                                        <p:tgtEl>
+                                          <p:spTgt spid="4"/>
+                                        </p:tgtEl>
+                                      </p:cBhvr>
+                                    </p:animEffect>
+                                  </p:childTnLst>
+                                </p:cTn>
+                              </p:par>
+                              <p:par>
+                                <p:cTn id="14" presetID="10" presetClass="entr" presetSubtype="0" fill="hold" nodeType="withEffect">
+                                  <p:stCondLst>
+                                    <p:cond delay="0"/>
+                                  </p:stCondLst>
+                                  <p:childTnLst>
+                                    <p:set>
+                                      <p:cBhvr>
+                                        <p:cTn id="15" dur="1" fill="hold">
+                                          <p:stCondLst>
+                                            <p:cond delay="0"/>
+                                          </p:stCondLst>
+                                        </p:cTn>
+                                        <p:tgtEl>
+                                          <p:spTgt spid="5"/>
+                                        </p:tgtEl>
+                                        <p:attrNameLst>
+                                          <p:attrName>style.visibility</p:attrName>
+                                        </p:attrNameLst>
+                                      </p:cBhvr>
+                                      <p:to>
+                                        <p:strVal val="visible"/>
+                                      </p:to>
+                                    </p:set>
+                                    <p:animEffect transition="in" filter="fade">
+                                      <p:cBhvr>
+                                        <p:cTn id="16" dur="400"/>
+                                        <p:tgtEl>
+                                          <p:spTgt spid="5"/>
+                                        </p:tgtEl>
+                                      </p:cBhvr>
+                                    </p:animEffect>
+                                  </p:childTnLst>
+                                </p:cTn>
+                              </p:par>
+                              <p:par>
+                                <p:cTn id="17" presetID="10" presetClass="entr" presetSubtype="0" fill="hold" nodeType="withEffect">
+                                  <p:stCondLst>
+                                    <p:cond delay="0"/>
+                                  </p:stCondLst>
+                                  <p:childTnLst>
+                                    <p:set>
+                                      <p:cBhvr>
+                                        <p:cTn id="18" dur="1" fill="hold">
+                                          <p:stCondLst>
+                                            <p:cond delay="0"/>
+                                          </p:stCondLst>
+                                        </p:cTn>
+                                        <p:tgtEl>
+                                          <p:spTgt spid="6"/>
+                                        </p:tgtEl>
+                                        <p:attrNameLst>
+                                          <p:attrName>style.visibility</p:attrName>
+                                        </p:attrNameLst>
+                                      </p:cBhvr>
+                                      <p:to>
+                                        <p:strVal val="visible"/>
+                                      </p:to>
+                                    </p:set>
+                                    <p:animEffect transition="in" filter="fade">
+                                      <p:cBhvr>
+                                        <p:cTn id="19" dur="400"/>
+                                        <p:tgtEl>
+                                          <p:spTgt spid="6"/>
+                                        </p:tgtEl>
+                                      </p:cBhvr>
+                                    </p:animEffect>
+                                  </p:childTnLst>
+                                </p:cTn>
+                              </p:par>
+                            </p:childTnLst>
+                          </p:cTn>
+                        </p:par>
+                      </p:childTnLst>
+                    </p:cTn>
+                  </p:par>
+                  <p:par>
+                    <p:cTn id="20" fill="hold">
+                      <p:stCondLst>
+                        <p:cond delay="indefinite"/>
+                      </p:stCondLst>
+                      <p:childTnLst>
+                        <p:par>
+                          <p:cTn id="21" fill="hold">
+                            <p:stCondLst>
+                              <p:cond delay="0"/>
+                            </p:stCondLst>
+                            <p:childTnLst>
+                              <p:par>
+                                <p:cTn id="22" presetID="10" presetClass="entr" presetSubtype="0" fill="hold" nodeType="clickEffect">
+                                  <p:stCondLst>
+                                    <p:cond delay="0"/>
+                                  </p:stCondLst>
+                                  <p:childTnLst>
+                                    <p:set>
+                                      <p:cBhvr>
+                                        <p:cTn id="23" dur="1" fill="hold">
+                                          <p:stCondLst>
+                                            <p:cond delay="0"/>
+                                          </p:stCondLst>
+                                        </p:cTn>
+                                        <p:tgtEl>
+                                          <p:spTgt spid="42"/>
+                                        </p:tgtEl>
+                                        <p:attrNameLst>
+                                          <p:attrName>style.visibility</p:attrName>
+                                        </p:attrNameLst>
+                                      </p:cBhvr>
+                                      <p:to>
+                                        <p:strVal val="visible"/>
+                                      </p:to>
+                                    </p:set>
+                                    <p:animEffect transition="in" filter="fade">
+                                      <p:cBhvr>
+                                        <p:cTn id="24" dur="400"/>
+                                        <p:tgtEl>
+                                          <p:spTgt spid="42"/>
+                                        </p:tgtEl>
+                                      </p:cBhvr>
+                                    </p:animEffect>
+                                  </p:childTnLst>
+                                </p:cTn>
+                              </p:par>
+                              <p:par>
+                                <p:cTn id="25" presetID="10" presetClass="entr" presetSubtype="0" fill="hold" nodeType="withEffect">
+                                  <p:stCondLst>
+                                    <p:cond delay="250"/>
+                                  </p:stCondLst>
+                                  <p:childTnLst>
+                                    <p:set>
+                                      <p:cBhvr>
+                                        <p:cTn id="26" dur="1" fill="hold">
+                                          <p:stCondLst>
+                                            <p:cond delay="0"/>
+                                          </p:stCondLst>
+                                        </p:cTn>
+                                        <p:tgtEl>
+                                          <p:spTgt spid="7"/>
+                                        </p:tgtEl>
+                                        <p:attrNameLst>
+                                          <p:attrName>style.visibility</p:attrName>
+                                        </p:attrNameLst>
+                                      </p:cBhvr>
+                                      <p:to>
+                                        <p:strVal val="visible"/>
+                                      </p:to>
+                                    </p:set>
+                                    <p:animEffect transition="in" filter="fade">
+                                      <p:cBhvr>
+                                        <p:cTn id="27" dur="400"/>
+                                        <p:tgtEl>
+                                          <p:spTgt spid="7"/>
+                                        </p:tgtEl>
+                                      </p:cBhvr>
+                                    </p:animEffect>
+                                  </p:childTnLst>
+                                </p:cTn>
+                              </p:par>
+                              <p:par>
+                                <p:cTn id="28" presetID="10" presetClass="entr" presetSubtype="0" fill="hold" nodeType="withEffect">
+                                  <p:stCondLst>
+                                    <p:cond delay="250"/>
+                                  </p:stCondLst>
+                                  <p:childTnLst>
+                                    <p:set>
+                                      <p:cBhvr>
+                                        <p:cTn id="29" dur="1" fill="hold">
+                                          <p:stCondLst>
+                                            <p:cond delay="0"/>
+                                          </p:stCondLst>
+                                        </p:cTn>
+                                        <p:tgtEl>
+                                          <p:spTgt spid="8"/>
+                                        </p:tgtEl>
+                                        <p:attrNameLst>
+                                          <p:attrName>style.visibility</p:attrName>
+                                        </p:attrNameLst>
+                                      </p:cBhvr>
+                                      <p:to>
+                                        <p:strVal val="visible"/>
+                                      </p:to>
+                                    </p:set>
+                                    <p:animEffect transition="in" filter="fade">
+                                      <p:cBhvr>
+                                        <p:cTn id="30" dur="400"/>
+                                        <p:tgtEl>
+                                          <p:spTgt spid="8"/>
+                                        </p:tgtEl>
+                                      </p:cBhvr>
+                                    </p:animEffect>
+                                  </p:childTnLst>
+                                </p:cTn>
+                              </p:par>
+                              <p:par>
+                                <p:cTn id="31" presetID="10" presetClass="entr" presetSubtype="0" fill="hold" nodeType="withEffect">
+                                  <p:stCondLst>
+                                    <p:cond delay="250"/>
+                                  </p:stCondLst>
+                                  <p:childTnLst>
+                                    <p:set>
+                                      <p:cBhvr>
+                                        <p:cTn id="32" dur="1" fill="hold">
+                                          <p:stCondLst>
+                                            <p:cond delay="0"/>
+                                          </p:stCondLst>
+                                        </p:cTn>
+                                        <p:tgtEl>
+                                          <p:spTgt spid="9"/>
+                                        </p:tgtEl>
+                                        <p:attrNameLst>
+                                          <p:attrName>style.visibility</p:attrName>
+                                        </p:attrNameLst>
+                                      </p:cBhvr>
+                                      <p:to>
+                                        <p:strVal val="visible"/>
+                                      </p:to>
+                                    </p:set>
+                                    <p:animEffect transition="in" filter="fade">
+                                      <p:cBhvr>
+                                        <p:cTn id="33" dur="400"/>
+                                        <p:tgtEl>
+                                          <p:spTgt spid="9"/>
+                                        </p:tgtEl>
+                                      </p:cBhvr>
+                                    </p:animEffect>
+                                  </p:childTnLst>
+                                </p:cTn>
+                              </p:par>
+                              <p:par>
+                                <p:cTn id="34" presetID="10" presetClass="entr" presetSubtype="0" fill="hold" nodeType="withEffect">
+                                  <p:stCondLst>
+                                    <p:cond delay="250"/>
+                                  </p:stCondLst>
+                                  <p:childTnLst>
+                                    <p:set>
+                                      <p:cBhvr>
+                                        <p:cTn id="35" dur="1" fill="hold">
+                                          <p:stCondLst>
+                                            <p:cond delay="0"/>
+                                          </p:stCondLst>
+                                        </p:cTn>
+                                        <p:tgtEl>
+                                          <p:spTgt spid="10"/>
+                                        </p:tgtEl>
+                                        <p:attrNameLst>
+                                          <p:attrName>style.visibility</p:attrName>
+                                        </p:attrNameLst>
+                                      </p:cBhvr>
+                                      <p:to>
+                                        <p:strVal val="visible"/>
+                                      </p:to>
+                                    </p:set>
+                                    <p:animEffect transition="in" filter="fade">
+                                      <p:cBhvr>
+                                        <p:cTn id="36" dur="400"/>
+                                        <p:tgtEl>
+                                          <p:spTgt spid="10"/>
+                                        </p:tgtEl>
+                                      </p:cBhvr>
+                                    </p:animEffect>
+                                  </p:childTnLst>
+                                </p:cTn>
+                              </p:par>
+                              <p:par>
+                                <p:cTn id="37" presetID="10" presetClass="entr" presetSubtype="0" fill="hold" nodeType="withEffect">
+                                  <p:stCondLst>
+                                    <p:cond delay="250"/>
+                                  </p:stCondLst>
+                                  <p:childTnLst>
+                                    <p:set>
+                                      <p:cBhvr>
+                                        <p:cTn id="38" dur="1" fill="hold">
+                                          <p:stCondLst>
+                                            <p:cond delay="0"/>
+                                          </p:stCondLst>
+                                        </p:cTn>
+                                        <p:tgtEl>
+                                          <p:spTgt spid="11"/>
+                                        </p:tgtEl>
+                                        <p:attrNameLst>
+                                          <p:attrName>style.visibility</p:attrName>
+                                        </p:attrNameLst>
+                                      </p:cBhvr>
+                                      <p:to>
+                                        <p:strVal val="visible"/>
+                                      </p:to>
+                                    </p:set>
+                                    <p:animEffect transition="in" filter="fade">
+                                      <p:cBhvr>
+                                        <p:cTn id="39" dur="400"/>
+                                        <p:tgtEl>
+                                          <p:spTgt spid="11"/>
+                                        </p:tgtEl>
+                                      </p:cBhvr>
+                                    </p:animEffect>
+                                  </p:childTnLst>
+                                </p:cTn>
+                              </p:par>
+                            </p:childTnLst>
+                          </p:cTn>
+                        </p:par>
+                      </p:childTnLst>
+                    </p:cTn>
+                  </p:par>
+                  <p:par>
+                    <p:cTn id="40" fill="hold">
+                      <p:stCondLst>
+                        <p:cond delay="indefinite"/>
+                      </p:stCondLst>
+                      <p:childTnLst>
+                        <p:par>
+                          <p:cTn id="41" fill="hold">
+                            <p:stCondLst>
+                              <p:cond delay="0"/>
+                            </p:stCondLst>
+                            <p:childTnLst>
+                              <p:par>
+                                <p:cTn id="42" presetID="10" presetClass="entr" presetSubtype="0" fill="hold" nodeType="clickEffect">
+                                  <p:stCondLst>
+                                    <p:cond delay="0"/>
+                                  </p:stCondLst>
+                                  <p:childTnLst>
+                                    <p:set>
+                                      <p:cBhvr>
+                                        <p:cTn id="43" dur="1" fill="hold">
+                                          <p:stCondLst>
+                                            <p:cond delay="0"/>
+                                          </p:stCondLst>
+                                        </p:cTn>
+                                        <p:tgtEl>
+                                          <p:spTgt spid="43"/>
+                                        </p:tgtEl>
+                                        <p:attrNameLst>
+                                          <p:attrName>style.visibility</p:attrName>
+                                        </p:attrNameLst>
+                                      </p:cBhvr>
+                                      <p:to>
+                                        <p:strVal val="visible"/>
+                                      </p:to>
+                                    </p:set>
+                                    <p:animEffect transition="in" filter="fade">
+                                      <p:cBhvr>
+                                        <p:cTn id="44" dur="400"/>
+                                        <p:tgtEl>
+                                          <p:spTgt spid="43"/>
+                                        </p:tgtEl>
+                                      </p:cBhvr>
+                                    </p:animEffect>
+                                  </p:childTnLst>
+                                </p:cTn>
+                              </p:par>
+                              <p:par>
+                                <p:cTn id="45" presetID="10" presetClass="entr" presetSubtype="0" fill="hold" nodeType="withEffect">
+                                  <p:stCondLst>
+                                    <p:cond delay="250"/>
+                                  </p:stCondLst>
+                                  <p:childTnLst>
+                                    <p:set>
+                                      <p:cBhvr>
+                                        <p:cTn id="46" dur="1" fill="hold">
+                                          <p:stCondLst>
+                                            <p:cond delay="0"/>
+                                          </p:stCondLst>
+                                        </p:cTn>
+                                        <p:tgtEl>
+                                          <p:spTgt spid="12"/>
+                                        </p:tgtEl>
+                                        <p:attrNameLst>
+                                          <p:attrName>style.visibility</p:attrName>
+                                        </p:attrNameLst>
+                                      </p:cBhvr>
+                                      <p:to>
+                                        <p:strVal val="visible"/>
+                                      </p:to>
+                                    </p:set>
+                                    <p:animEffect transition="in" filter="fade">
+                                      <p:cBhvr>
+                                        <p:cTn id="47" dur="400"/>
+                                        <p:tgtEl>
+                                          <p:spTgt spid="12"/>
+                                        </p:tgtEl>
+                                      </p:cBhvr>
+                                    </p:animEffect>
+                                  </p:childTnLst>
+                                </p:cTn>
+                              </p:par>
+                              <p:par>
+                                <p:cTn id="48" presetID="10" presetClass="entr" presetSubtype="0" fill="hold" nodeType="withEffect">
+                                  <p:stCondLst>
+                                    <p:cond delay="250"/>
+                                  </p:stCondLst>
+                                  <p:childTnLst>
+                                    <p:set>
+                                      <p:cBhvr>
+                                        <p:cTn id="49" dur="1" fill="hold">
+                                          <p:stCondLst>
+                                            <p:cond delay="0"/>
+                                          </p:stCondLst>
+                                        </p:cTn>
+                                        <p:tgtEl>
+                                          <p:spTgt spid="13"/>
+                                        </p:tgtEl>
+                                        <p:attrNameLst>
+                                          <p:attrName>style.visibility</p:attrName>
+                                        </p:attrNameLst>
+                                      </p:cBhvr>
+                                      <p:to>
+                                        <p:strVal val="visible"/>
+                                      </p:to>
+                                    </p:set>
+                                    <p:animEffect transition="in" filter="fade">
+                                      <p:cBhvr>
+                                        <p:cTn id="50" dur="400"/>
+                                        <p:tgtEl>
+                                          <p:spTgt spid="13"/>
+                                        </p:tgtEl>
+                                      </p:cBhvr>
+                                    </p:animEffect>
+                                  </p:childTnLst>
+                                </p:cTn>
+                              </p:par>
+                              <p:par>
+                                <p:cTn id="51" presetID="10" presetClass="entr" presetSubtype="0" fill="hold" nodeType="withEffect">
+                                  <p:stCondLst>
+                                    <p:cond delay="250"/>
+                                  </p:stCondLst>
+                                  <p:childTnLst>
+                                    <p:set>
+                                      <p:cBhvr>
+                                        <p:cTn id="52" dur="1" fill="hold">
+                                          <p:stCondLst>
+                                            <p:cond delay="0"/>
+                                          </p:stCondLst>
+                                        </p:cTn>
+                                        <p:tgtEl>
+                                          <p:spTgt spid="14"/>
+                                        </p:tgtEl>
+                                        <p:attrNameLst>
+                                          <p:attrName>style.visibility</p:attrName>
+                                        </p:attrNameLst>
+                                      </p:cBhvr>
+                                      <p:to>
+                                        <p:strVal val="visible"/>
+                                      </p:to>
+                                    </p:set>
+                                    <p:animEffect transition="in" filter="fade">
+                                      <p:cBhvr>
+                                        <p:cTn id="53" dur="400"/>
+                                        <p:tgtEl>
+                                          <p:spTgt spid="14"/>
+                                        </p:tgtEl>
+                                      </p:cBhvr>
+                                    </p:animEffect>
+                                  </p:childTnLst>
+                                </p:cTn>
+                              </p:par>
+                              <p:par>
+                                <p:cTn id="54" presetID="10" presetClass="entr" presetSubtype="0" fill="hold" nodeType="withEffect">
+                                  <p:stCondLst>
+                                    <p:cond delay="250"/>
+                                  </p:stCondLst>
+                                  <p:childTnLst>
+                                    <p:set>
+                                      <p:cBhvr>
+                                        <p:cTn id="55" dur="1" fill="hold">
+                                          <p:stCondLst>
+                                            <p:cond delay="0"/>
+                                          </p:stCondLst>
+                                        </p:cTn>
+                                        <p:tgtEl>
+                                          <p:spTgt spid="15"/>
+                                        </p:tgtEl>
+                                        <p:attrNameLst>
+                                          <p:attrName>style.visibility</p:attrName>
+                                        </p:attrNameLst>
+                                      </p:cBhvr>
+                                      <p:to>
+                                        <p:strVal val="visible"/>
+                                      </p:to>
+                                    </p:set>
+                                    <p:animEffect transition="in" filter="fade">
+                                      <p:cBhvr>
+                                        <p:cTn id="56" dur="400"/>
+                                        <p:tgtEl>
+                                          <p:spTgt spid="15"/>
+                                        </p:tgtEl>
+                                      </p:cBhvr>
+                                    </p:animEffect>
+                                  </p:childTnLst>
+                                </p:cTn>
+                              </p:par>
+                              <p:par>
+                                <p:cTn id="57" presetID="10" presetClass="entr" presetSubtype="0" fill="hold" nodeType="withEffect">
+                                  <p:stCondLst>
+                                    <p:cond delay="250"/>
+                                  </p:stCondLst>
+                                  <p:childTnLst>
+                                    <p:set>
+                                      <p:cBhvr>
+                                        <p:cTn id="58" dur="1" fill="hold">
+                                          <p:stCondLst>
+                                            <p:cond delay="0"/>
+                                          </p:stCondLst>
+                                        </p:cTn>
+                                        <p:tgtEl>
+                                          <p:spTgt spid="16"/>
+                                        </p:tgtEl>
+                                        <p:attrNameLst>
+                                          <p:attrName>style.visibility</p:attrName>
+                                        </p:attrNameLst>
+                                      </p:cBhvr>
+                                      <p:to>
+                                        <p:strVal val="visible"/>
+                                      </p:to>
+                                    </p:set>
+                                    <p:animEffect transition="in" filter="fade">
+                                      <p:cBhvr>
+                                        <p:cTn id="59" dur="400"/>
+                                        <p:tgtEl>
+                                          <p:spTgt spid="16"/>
+                                        </p:tgtEl>
+                                      </p:cBhvr>
+                                    </p:animEffect>
+                                  </p:childTnLst>
+                                </p:cTn>
+                              </p:par>
+                            </p:childTnLst>
+                          </p:cTn>
+                        </p:par>
+                      </p:childTnLst>
+                    </p:cTn>
+                  </p:par>
+                  <p:par>
+                    <p:cTn id="60" fill="hold">
+                      <p:stCondLst>
+                        <p:cond delay="indefinite"/>
+                      </p:stCondLst>
+                      <p:childTnLst>
+                        <p:par>
+                          <p:cTn id="61" fill="hold">
+                            <p:stCondLst>
+                              <p:cond delay="0"/>
+                            </p:stCondLst>
+                            <p:childTnLst>
+                              <p:par>
+                                <p:cTn id="62" presetID="10" presetClass="entr" presetSubtype="0" fill="hold" nodeType="clickEffect">
+                                  <p:stCondLst>
+                                    <p:cond delay="0"/>
+                                  </p:stCondLst>
+                                  <p:childTnLst>
+                                    <p:set>
+                                      <p:cBhvr>
+                                        <p:cTn id="63" dur="1" fill="hold">
+                                          <p:stCondLst>
+                                            <p:cond delay="0"/>
+                                          </p:stCondLst>
+                                        </p:cTn>
+                                        <p:tgtEl>
+                                          <p:spTgt spid="44"/>
+                                        </p:tgtEl>
+                                        <p:attrNameLst>
+                                          <p:attrName>style.visibility</p:attrName>
+                                        </p:attrNameLst>
+                                      </p:cBhvr>
+                                      <p:to>
+                                        <p:strVal val="visible"/>
+                                      </p:to>
+                                    </p:set>
+                                    <p:animEffect transition="in" filter="fade">
+                                      <p:cBhvr>
+                                        <p:cTn id="64" dur="400"/>
+                                        <p:tgtEl>
+                                          <p:spTgt spid="44"/>
+                                        </p:tgtEl>
+                                      </p:cBhvr>
+                                    </p:animEffect>
+                                  </p:childTnLst>
+                                </p:cTn>
+                              </p:par>
+                              <p:par>
+                                <p:cTn id="65" presetID="10" presetClass="entr" presetSubtype="0" fill="hold" nodeType="withEffect">
+                                  <p:stCondLst>
+                                    <p:cond delay="250"/>
+                                  </p:stCondLst>
+                                  <p:childTnLst>
+                                    <p:set>
+                                      <p:cBhvr>
+                                        <p:cTn id="66" dur="1" fill="hold">
+                                          <p:stCondLst>
+                                            <p:cond delay="0"/>
+                                          </p:stCondLst>
+                                        </p:cTn>
+                                        <p:tgtEl>
+                                          <p:spTgt spid="17"/>
+                                        </p:tgtEl>
+                                        <p:attrNameLst>
+                                          <p:attrName>style.visibility</p:attrName>
+                                        </p:attrNameLst>
+                                      </p:cBhvr>
+                                      <p:to>
+                                        <p:strVal val="visible"/>
+                                      </p:to>
+                                    </p:set>
+                                    <p:animEffect transition="in" filter="fade">
+                                      <p:cBhvr>
+                                        <p:cTn id="67" dur="400"/>
+                                        <p:tgtEl>
+                                          <p:spTgt spid="17"/>
+                                        </p:tgtEl>
+                                      </p:cBhvr>
+                                    </p:animEffect>
+                                  </p:childTnLst>
+                                </p:cTn>
+                              </p:par>
+                              <p:par>
+                                <p:cTn id="68" presetID="10" presetClass="entr" presetSubtype="0" fill="hold" nodeType="withEffect">
+                                  <p:stCondLst>
+                                    <p:cond delay="250"/>
+                                  </p:stCondLst>
+                                  <p:childTnLst>
+                                    <p:set>
+                                      <p:cBhvr>
+                                        <p:cTn id="69" dur="1" fill="hold">
+                                          <p:stCondLst>
+                                            <p:cond delay="0"/>
+                                          </p:stCondLst>
+                                        </p:cTn>
+                                        <p:tgtEl>
+                                          <p:spTgt spid="18"/>
+                                        </p:tgtEl>
+                                        <p:attrNameLst>
+                                          <p:attrName>style.visibility</p:attrName>
+                                        </p:attrNameLst>
+                                      </p:cBhvr>
+                                      <p:to>
+                                        <p:strVal val="visible"/>
+                                      </p:to>
+                                    </p:set>
+                                    <p:animEffect transition="in" filter="fade">
+                                      <p:cBhvr>
+                                        <p:cTn id="70" dur="400"/>
+                                        <p:tgtEl>
+                                          <p:spTgt spid="18"/>
+                                        </p:tgtEl>
+                                      </p:cBhvr>
+                                    </p:animEffect>
+                                  </p:childTnLst>
+                                </p:cTn>
+                              </p:par>
+                              <p:par>
+                                <p:cTn id="71" presetID="10" presetClass="entr" presetSubtype="0" fill="hold" nodeType="withEffect">
+                                  <p:stCondLst>
+                                    <p:cond delay="250"/>
+                                  </p:stCondLst>
+                                  <p:childTnLst>
+                                    <p:set>
+                                      <p:cBhvr>
+                                        <p:cTn id="72" dur="1" fill="hold">
+                                          <p:stCondLst>
+                                            <p:cond delay="0"/>
+                                          </p:stCondLst>
+                                        </p:cTn>
+                                        <p:tgtEl>
+                                          <p:spTgt spid="19"/>
+                                        </p:tgtEl>
+                                        <p:attrNameLst>
+                                          <p:attrName>style.visibility</p:attrName>
+                                        </p:attrNameLst>
+                                      </p:cBhvr>
+                                      <p:to>
+                                        <p:strVal val="visible"/>
+                                      </p:to>
+                                    </p:set>
+                                    <p:animEffect transition="in" filter="fade">
+                                      <p:cBhvr>
+                                        <p:cTn id="73" dur="400"/>
+                                        <p:tgtEl>
+                                          <p:spTgt spid="19"/>
+                                        </p:tgtEl>
+                                      </p:cBhvr>
+                                    </p:animEffect>
+                                  </p:childTnLst>
+                                </p:cTn>
+                              </p:par>
+                              <p:par>
+                                <p:cTn id="74" presetID="10" presetClass="entr" presetSubtype="0" fill="hold" nodeType="withEffect">
+                                  <p:stCondLst>
+                                    <p:cond delay="250"/>
+                                  </p:stCondLst>
+                                  <p:childTnLst>
+                                    <p:set>
+                                      <p:cBhvr>
+                                        <p:cTn id="75" dur="1" fill="hold">
+                                          <p:stCondLst>
+                                            <p:cond delay="0"/>
+                                          </p:stCondLst>
+                                        </p:cTn>
+                                        <p:tgtEl>
+                                          <p:spTgt spid="20"/>
+                                        </p:tgtEl>
+                                        <p:attrNameLst>
+                                          <p:attrName>style.visibility</p:attrName>
+                                        </p:attrNameLst>
+                                      </p:cBhvr>
+                                      <p:to>
+                                        <p:strVal val="visible"/>
+                                      </p:to>
+                                    </p:set>
+                                    <p:animEffect transition="in" filter="fade">
+                                      <p:cBhvr>
+                                        <p:cTn id="76" dur="400"/>
+                                        <p:tgtEl>
+                                          <p:spTgt spid="20"/>
+                                        </p:tgtEl>
+                                      </p:cBhvr>
+                                    </p:animEffect>
+                                  </p:childTnLst>
+                                </p:cTn>
+                              </p:par>
+                              <p:par>
+                                <p:cTn id="77" presetID="10" presetClass="entr" presetSubtype="0" fill="hold" nodeType="withEffect">
+                                  <p:stCondLst>
+                                    <p:cond delay="250"/>
+                                  </p:stCondLst>
+                                  <p:childTnLst>
+                                    <p:set>
+                                      <p:cBhvr>
+                                        <p:cTn id="78" dur="1" fill="hold">
+                                          <p:stCondLst>
+                                            <p:cond delay="0"/>
+                                          </p:stCondLst>
+                                        </p:cTn>
+                                        <p:tgtEl>
+                                          <p:spTgt spid="21"/>
+                                        </p:tgtEl>
+                                        <p:attrNameLst>
+                                          <p:attrName>style.visibility</p:attrName>
+                                        </p:attrNameLst>
+                                      </p:cBhvr>
+                                      <p:to>
+                                        <p:strVal val="visible"/>
+                                      </p:to>
+                                    </p:set>
+                                    <p:animEffect transition="in" filter="fade">
+                                      <p:cBhvr>
+                                        <p:cTn id="79" dur="400"/>
+                                        <p:tgtEl>
+                                          <p:spTgt spid="21"/>
+                                        </p:tgtEl>
+                                      </p:cBhvr>
+                                    </p:animEffect>
+                                  </p:childTnLst>
+                                </p:cTn>
+                              </p:par>
+                            </p:childTnLst>
+                          </p:cTn>
+                        </p:par>
+                      </p:childTnLst>
+                    </p:cTn>
+                  </p:par>
+                  <p:par>
+                    <p:cTn id="80" fill="hold">
+                      <p:stCondLst>
+                        <p:cond delay="indefinite"/>
+                      </p:stCondLst>
+                      <p:childTnLst>
+                        <p:par>
+                          <p:cTn id="81" fill="hold">
+                            <p:stCondLst>
+                              <p:cond delay="0"/>
+                            </p:stCondLst>
+                            <p:childTnLst>
+                              <p:par>
+                                <p:cTn id="82" presetID="10" presetClass="entr" presetSubtype="0" fill="hold" nodeType="clickEffect">
+                                  <p:stCondLst>
+                                    <p:cond delay="0"/>
+                                  </p:stCondLst>
+                                  <p:childTnLst>
+                                    <p:set>
+                                      <p:cBhvr>
+                                        <p:cTn id="83" dur="1" fill="hold">
+                                          <p:stCondLst>
+                                            <p:cond delay="0"/>
+                                          </p:stCondLst>
+                                        </p:cTn>
+                                        <p:tgtEl>
+                                          <p:spTgt spid="45"/>
+                                        </p:tgtEl>
+                                        <p:attrNameLst>
+                                          <p:attrName>style.visibility</p:attrName>
+                                        </p:attrNameLst>
+                                      </p:cBhvr>
+                                      <p:to>
+                                        <p:strVal val="visible"/>
+                                      </p:to>
+                                    </p:set>
+                                    <p:animEffect transition="in" filter="fade">
+                                      <p:cBhvr>
+                                        <p:cTn id="84" dur="400"/>
+                                        <p:tgtEl>
+                                          <p:spTgt spid="45"/>
+                                        </p:tgtEl>
+                                      </p:cBhvr>
+                                    </p:animEffect>
+                                  </p:childTnLst>
+                                </p:cTn>
+                              </p:par>
+                              <p:par>
+                                <p:cTn id="85" presetID="10" presetClass="entr" presetSubtype="0" fill="hold" nodeType="withEffect">
+                                  <p:stCondLst>
+                                    <p:cond delay="250"/>
+                                  </p:stCondLst>
+                                  <p:childTnLst>
+                                    <p:set>
+                                      <p:cBhvr>
+                                        <p:cTn id="86" dur="1" fill="hold">
+                                          <p:stCondLst>
+                                            <p:cond delay="0"/>
+                                          </p:stCondLst>
+                                        </p:cTn>
+                                        <p:tgtEl>
+                                          <p:spTgt spid="22"/>
+                                        </p:tgtEl>
+                                        <p:attrNameLst>
+                                          <p:attrName>style.visibility</p:attrName>
+                                        </p:attrNameLst>
+                                      </p:cBhvr>
+                                      <p:to>
+                                        <p:strVal val="visible"/>
+                                      </p:to>
+                                    </p:set>
+                                    <p:animEffect transition="in" filter="fade">
+                                      <p:cBhvr>
+                                        <p:cTn id="87" dur="400"/>
+                                        <p:tgtEl>
+                                          <p:spTgt spid="22"/>
+                                        </p:tgtEl>
+                                      </p:cBhvr>
+                                    </p:animEffect>
+                                  </p:childTnLst>
+                                </p:cTn>
+                              </p:par>
+                              <p:par>
+                                <p:cTn id="88" presetID="10" presetClass="entr" presetSubtype="0" fill="hold" nodeType="withEffect">
+                                  <p:stCondLst>
+                                    <p:cond delay="250"/>
+                                  </p:stCondLst>
+                                  <p:childTnLst>
+                                    <p:set>
+                                      <p:cBhvr>
+                                        <p:cTn id="89" dur="1" fill="hold">
+                                          <p:stCondLst>
+                                            <p:cond delay="0"/>
+                                          </p:stCondLst>
+                                        </p:cTn>
+                                        <p:tgtEl>
+                                          <p:spTgt spid="23"/>
+                                        </p:tgtEl>
+                                        <p:attrNameLst>
+                                          <p:attrName>style.visibility</p:attrName>
+                                        </p:attrNameLst>
+                                      </p:cBhvr>
+                                      <p:to>
+                                        <p:strVal val="visible"/>
+                                      </p:to>
+                                    </p:set>
+                                    <p:animEffect transition="in" filter="fade">
+                                      <p:cBhvr>
+                                        <p:cTn id="90" dur="400"/>
+                                        <p:tgtEl>
+                                          <p:spTgt spid="23"/>
+                                        </p:tgtEl>
+                                      </p:cBhvr>
+                                    </p:animEffect>
+                                  </p:childTnLst>
+                                </p:cTn>
+                              </p:par>
+                              <p:par>
+                                <p:cTn id="91" presetID="10" presetClass="entr" presetSubtype="0" fill="hold" nodeType="withEffect">
+                                  <p:stCondLst>
+                                    <p:cond delay="250"/>
+                                  </p:stCondLst>
+                                  <p:childTnLst>
+                                    <p:set>
+                                      <p:cBhvr>
+                                        <p:cTn id="92" dur="1" fill="hold">
+                                          <p:stCondLst>
+                                            <p:cond delay="0"/>
+                                          </p:stCondLst>
+                                        </p:cTn>
+                                        <p:tgtEl>
+                                          <p:spTgt spid="24"/>
+                                        </p:tgtEl>
+                                        <p:attrNameLst>
+                                          <p:attrName>style.visibility</p:attrName>
+                                        </p:attrNameLst>
+                                      </p:cBhvr>
+                                      <p:to>
+                                        <p:strVal val="visible"/>
+                                      </p:to>
+                                    </p:set>
+                                    <p:animEffect transition="in" filter="fade">
+                                      <p:cBhvr>
+                                        <p:cTn id="93" dur="400"/>
+                                        <p:tgtEl>
+                                          <p:spTgt spid="24"/>
+                                        </p:tgtEl>
+                                      </p:cBhvr>
+                                    </p:animEffect>
+                                  </p:childTnLst>
+                                </p:cTn>
+                              </p:par>
+                              <p:par>
+                                <p:cTn id="94" presetID="10" presetClass="entr" presetSubtype="0" fill="hold" nodeType="withEffect">
+                                  <p:stCondLst>
+                                    <p:cond delay="250"/>
+                                  </p:stCondLst>
+                                  <p:childTnLst>
+                                    <p:set>
+                                      <p:cBhvr>
+                                        <p:cTn id="95" dur="1" fill="hold">
+                                          <p:stCondLst>
+                                            <p:cond delay="0"/>
+                                          </p:stCondLst>
+                                        </p:cTn>
+                                        <p:tgtEl>
+                                          <p:spTgt spid="25"/>
+                                        </p:tgtEl>
+                                        <p:attrNameLst>
+                                          <p:attrName>style.visibility</p:attrName>
+                                        </p:attrNameLst>
+                                      </p:cBhvr>
+                                      <p:to>
+                                        <p:strVal val="visible"/>
+                                      </p:to>
+                                    </p:set>
+                                    <p:animEffect transition="in" filter="fade">
+                                      <p:cBhvr>
+                                        <p:cTn id="96" dur="400"/>
+                                        <p:tgtEl>
+                                          <p:spTgt spid="25"/>
+                                        </p:tgtEl>
+                                      </p:cBhvr>
+                                    </p:animEffect>
+                                  </p:childTnLst>
+                                </p:cTn>
+                              </p:par>
+                              <p:par>
+                                <p:cTn id="97" presetID="10" presetClass="entr" presetSubtype="0" fill="hold" nodeType="withEffect">
+                                  <p:stCondLst>
+                                    <p:cond delay="250"/>
+                                  </p:stCondLst>
+                                  <p:childTnLst>
+                                    <p:set>
+                                      <p:cBhvr>
+                                        <p:cTn id="98" dur="1" fill="hold">
+                                          <p:stCondLst>
+                                            <p:cond delay="0"/>
+                                          </p:stCondLst>
+                                        </p:cTn>
+                                        <p:tgtEl>
+                                          <p:spTgt spid="26"/>
+                                        </p:tgtEl>
+                                        <p:attrNameLst>
+                                          <p:attrName>style.visibility</p:attrName>
+                                        </p:attrNameLst>
+                                      </p:cBhvr>
+                                      <p:to>
+                                        <p:strVal val="visible"/>
+                                      </p:to>
+                                    </p:set>
+                                    <p:animEffect transition="in" filter="fade">
+                                      <p:cBhvr>
+                                        <p:cTn id="99" dur="400"/>
+                                        <p:tgtEl>
+                                          <p:spTgt spid="26"/>
+                                        </p:tgtEl>
+                                      </p:cBhvr>
+                                    </p:animEffect>
+                                  </p:childTnLst>
+                                </p:cTn>
+                              </p:par>
+                            </p:childTnLst>
+                          </p:cTn>
+                        </p:par>
+                      </p:childTnLst>
+                    </p:cTn>
+                  </p:par>
+                  <p:par>
+                    <p:cTn id="100" fill="hold">
+                      <p:stCondLst>
+                        <p:cond delay="indefinite"/>
+                      </p:stCondLst>
+                      <p:childTnLst>
+                        <p:par>
+                          <p:cTn id="101" fill="hold">
+                            <p:stCondLst>
+                              <p:cond delay="0"/>
+                            </p:stCondLst>
+                            <p:childTnLst>
+                              <p:par>
+                                <p:cTn id="102" presetID="10" presetClass="entr" presetSubtype="0" fill="hold" nodeType="clickEffect">
+                                  <p:stCondLst>
+                                    <p:cond delay="0"/>
+                                  </p:stCondLst>
+                                  <p:childTnLst>
+                                    <p:set>
+                                      <p:cBhvr>
+                                        <p:cTn id="103" dur="1" fill="hold">
+                                          <p:stCondLst>
+                                            <p:cond delay="0"/>
+                                          </p:stCondLst>
+                                        </p:cTn>
+                                        <p:tgtEl>
+                                          <p:spTgt spid="46"/>
+                                        </p:tgtEl>
+                                        <p:attrNameLst>
+                                          <p:attrName>style.visibility</p:attrName>
+                                        </p:attrNameLst>
+                                      </p:cBhvr>
+                                      <p:to>
+                                        <p:strVal val="visible"/>
+                                      </p:to>
+                                    </p:set>
+                                    <p:animEffect transition="in" filter="fade">
+                                      <p:cBhvr>
+                                        <p:cTn id="104" dur="400"/>
+                                        <p:tgtEl>
+                                          <p:spTgt spid="46"/>
+                                        </p:tgtEl>
+                                      </p:cBhvr>
+                                    </p:animEffect>
+                                  </p:childTnLst>
+                                </p:cTn>
+                              </p:par>
+                              <p:par>
+                                <p:cTn id="105" presetID="10" presetClass="entr" presetSubtype="0" fill="hold" nodeType="withEffect">
+                                  <p:stCondLst>
+                                    <p:cond delay="250"/>
+                                  </p:stCondLst>
+                                  <p:childTnLst>
+                                    <p:set>
+                                      <p:cBhvr>
+                                        <p:cTn id="106" dur="1" fill="hold">
+                                          <p:stCondLst>
+                                            <p:cond delay="0"/>
+                                          </p:stCondLst>
+                                        </p:cTn>
+                                        <p:tgtEl>
+                                          <p:spTgt spid="27"/>
+                                        </p:tgtEl>
+                                        <p:attrNameLst>
+                                          <p:attrName>style.visibility</p:attrName>
+                                        </p:attrNameLst>
+                                      </p:cBhvr>
+                                      <p:to>
+                                        <p:strVal val="visible"/>
+                                      </p:to>
+                                    </p:set>
+                                    <p:animEffect transition="in" filter="fade">
+                                      <p:cBhvr>
+                                        <p:cTn id="107" dur="400"/>
+                                        <p:tgtEl>
+                                          <p:spTgt spid="27"/>
+                                        </p:tgtEl>
+                                      </p:cBhvr>
+                                    </p:animEffect>
+                                  </p:childTnLst>
+                                </p:cTn>
+                              </p:par>
+                              <p:par>
+                                <p:cTn id="108" presetID="10" presetClass="entr" presetSubtype="0" fill="hold" nodeType="withEffect">
+                                  <p:stCondLst>
+                                    <p:cond delay="250"/>
+                                  </p:stCondLst>
+                                  <p:childTnLst>
+                                    <p:set>
+                                      <p:cBhvr>
+                                        <p:cTn id="109" dur="1" fill="hold">
+                                          <p:stCondLst>
+                                            <p:cond delay="0"/>
+                                          </p:stCondLst>
+                                        </p:cTn>
+                                        <p:tgtEl>
+                                          <p:spTgt spid="28"/>
+                                        </p:tgtEl>
+                                        <p:attrNameLst>
+                                          <p:attrName>style.visibility</p:attrName>
+                                        </p:attrNameLst>
+                                      </p:cBhvr>
+                                      <p:to>
+                                        <p:strVal val="visible"/>
+                                      </p:to>
+                                    </p:set>
+                                    <p:animEffect transition="in" filter="fade">
+                                      <p:cBhvr>
+                                        <p:cTn id="110" dur="400"/>
+                                        <p:tgtEl>
+                                          <p:spTgt spid="28"/>
+                                        </p:tgtEl>
+                                      </p:cBhvr>
+                                    </p:animEffect>
+                                  </p:childTnLst>
+                                </p:cTn>
+                              </p:par>
+                              <p:par>
+                                <p:cTn id="111" presetID="10" presetClass="entr" presetSubtype="0" fill="hold" nodeType="withEffect">
+                                  <p:stCondLst>
+                                    <p:cond delay="250"/>
+                                  </p:stCondLst>
+                                  <p:childTnLst>
+                                    <p:set>
+                                      <p:cBhvr>
+                                        <p:cTn id="112" dur="1" fill="hold">
+                                          <p:stCondLst>
+                                            <p:cond delay="0"/>
+                                          </p:stCondLst>
+                                        </p:cTn>
+                                        <p:tgtEl>
+                                          <p:spTgt spid="29"/>
+                                        </p:tgtEl>
+                                        <p:attrNameLst>
+                                          <p:attrName>style.visibility</p:attrName>
+                                        </p:attrNameLst>
+                                      </p:cBhvr>
+                                      <p:to>
+                                        <p:strVal val="visible"/>
+                                      </p:to>
+                                    </p:set>
+                                    <p:animEffect transition="in" filter="fade">
+                                      <p:cBhvr>
+                                        <p:cTn id="113" dur="400"/>
+                                        <p:tgtEl>
+                                          <p:spTgt spid="29"/>
+                                        </p:tgtEl>
+                                      </p:cBhvr>
+                                    </p:animEffect>
+                                  </p:childTnLst>
+                                </p:cTn>
+                              </p:par>
+                              <p:par>
+                                <p:cTn id="114" presetID="10" presetClass="entr" presetSubtype="0" fill="hold" nodeType="withEffect">
+                                  <p:stCondLst>
+                                    <p:cond delay="250"/>
+                                  </p:stCondLst>
+                                  <p:childTnLst>
+                                    <p:set>
+                                      <p:cBhvr>
+                                        <p:cTn id="115" dur="1" fill="hold">
+                                          <p:stCondLst>
+                                            <p:cond delay="0"/>
+                                          </p:stCondLst>
+                                        </p:cTn>
+                                        <p:tgtEl>
+                                          <p:spTgt spid="30"/>
+                                        </p:tgtEl>
+                                        <p:attrNameLst>
+                                          <p:attrName>style.visibility</p:attrName>
+                                        </p:attrNameLst>
+                                      </p:cBhvr>
+                                      <p:to>
+                                        <p:strVal val="visible"/>
+                                      </p:to>
+                                    </p:set>
+                                    <p:animEffect transition="in" filter="fade">
+                                      <p:cBhvr>
+                                        <p:cTn id="116" dur="400"/>
+                                        <p:tgtEl>
+                                          <p:spTgt spid="30"/>
+                                        </p:tgtEl>
+                                      </p:cBhvr>
+                                    </p:animEffect>
+                                  </p:childTnLst>
+                                </p:cTn>
+                              </p:par>
+                              <p:par>
+                                <p:cTn id="117" presetID="10" presetClass="entr" presetSubtype="0" fill="hold" nodeType="withEffect">
+                                  <p:stCondLst>
+                                    <p:cond delay="250"/>
+                                  </p:stCondLst>
+                                  <p:childTnLst>
+                                    <p:set>
+                                      <p:cBhvr>
+                                        <p:cTn id="118" dur="1" fill="hold">
+                                          <p:stCondLst>
+                                            <p:cond delay="0"/>
+                                          </p:stCondLst>
+                                        </p:cTn>
+                                        <p:tgtEl>
+                                          <p:spTgt spid="31"/>
+                                        </p:tgtEl>
+                                        <p:attrNameLst>
+                                          <p:attrName>style.visibility</p:attrName>
+                                        </p:attrNameLst>
+                                      </p:cBhvr>
+                                      <p:to>
+                                        <p:strVal val="visible"/>
+                                      </p:to>
+                                    </p:set>
+                                    <p:animEffect transition="in" filter="fade">
+                                      <p:cBhvr>
+                                        <p:cTn id="119" dur="400"/>
+                                        <p:tgtEl>
+                                          <p:spTgt spid="31"/>
+                                        </p:tgtEl>
+                                      </p:cBhvr>
+                                    </p:animEffect>
+                                  </p:childTnLst>
+                                </p:cTn>
+                              </p:par>
+                            </p:childTnLst>
+                          </p:cTn>
+                        </p:par>
+                      </p:childTnLst>
+                    </p:cTn>
+                  </p:par>
+                  <p:par>
+                    <p:cTn id="120" fill="hold">
+                      <p:stCondLst>
+                        <p:cond delay="indefinite"/>
+                      </p:stCondLst>
+                      <p:childTnLst>
+                        <p:par>
+                          <p:cTn id="121" fill="hold">
+                            <p:stCondLst>
+                              <p:cond delay="0"/>
+                            </p:stCondLst>
+                            <p:childTnLst>
+                              <p:par>
+                                <p:cTn id="122" presetID="10" presetClass="entr" presetSubtype="0" fill="hold" nodeType="clickEffect">
+                                  <p:stCondLst>
+                                    <p:cond delay="0"/>
+                                  </p:stCondLst>
+                                  <p:childTnLst>
+                                    <p:set>
+                                      <p:cBhvr>
+                                        <p:cTn id="123" dur="1" fill="hold">
+                                          <p:stCondLst>
+                                            <p:cond delay="0"/>
+                                          </p:stCondLst>
+                                        </p:cTn>
+                                        <p:tgtEl>
+                                          <p:spTgt spid="47"/>
+                                        </p:tgtEl>
+                                        <p:attrNameLst>
+                                          <p:attrName>style.visibility</p:attrName>
+                                        </p:attrNameLst>
+                                      </p:cBhvr>
+                                      <p:to>
+                                        <p:strVal val="visible"/>
+                                      </p:to>
+                                    </p:set>
+                                    <p:animEffect transition="in" filter="fade">
+                                      <p:cBhvr>
+                                        <p:cTn id="124" dur="400"/>
+                                        <p:tgtEl>
+                                          <p:spTgt spid="47"/>
+                                        </p:tgtEl>
+                                      </p:cBhvr>
+                                    </p:animEffect>
+                                  </p:childTnLst>
+                                </p:cTn>
+                              </p:par>
+                              <p:par>
+                                <p:cTn id="125" presetID="10" presetClass="entr" presetSubtype="0" fill="hold" nodeType="withEffect">
+                                  <p:stCondLst>
+                                    <p:cond delay="250"/>
+                                  </p:stCondLst>
+                                  <p:childTnLst>
+                                    <p:set>
+                                      <p:cBhvr>
+                                        <p:cTn id="126" dur="1" fill="hold">
+                                          <p:stCondLst>
+                                            <p:cond delay="0"/>
+                                          </p:stCondLst>
+                                        </p:cTn>
+                                        <p:tgtEl>
+                                          <p:spTgt spid="32"/>
+                                        </p:tgtEl>
+                                        <p:attrNameLst>
+                                          <p:attrName>style.visibility</p:attrName>
+                                        </p:attrNameLst>
+                                      </p:cBhvr>
+                                      <p:to>
+                                        <p:strVal val="visible"/>
+                                      </p:to>
+                                    </p:set>
+                                    <p:animEffect transition="in" filter="fade">
+                                      <p:cBhvr>
+                                        <p:cTn id="127" dur="400"/>
+                                        <p:tgtEl>
+                                          <p:spTgt spid="32"/>
+                                        </p:tgtEl>
+                                      </p:cBhvr>
+                                    </p:animEffect>
+                                  </p:childTnLst>
+                                </p:cTn>
+                              </p:par>
+                              <p:par>
+                                <p:cTn id="128" presetID="10" presetClass="entr" presetSubtype="0" fill="hold" nodeType="withEffect">
+                                  <p:stCondLst>
+                                    <p:cond delay="250"/>
+                                  </p:stCondLst>
+                                  <p:childTnLst>
+                                    <p:set>
+                                      <p:cBhvr>
+                                        <p:cTn id="129" dur="1" fill="hold">
+                                          <p:stCondLst>
+                                            <p:cond delay="0"/>
+                                          </p:stCondLst>
+                                        </p:cTn>
+                                        <p:tgtEl>
+                                          <p:spTgt spid="33"/>
+                                        </p:tgtEl>
+                                        <p:attrNameLst>
+                                          <p:attrName>style.visibility</p:attrName>
+                                        </p:attrNameLst>
+                                      </p:cBhvr>
+                                      <p:to>
+                                        <p:strVal val="visible"/>
+                                      </p:to>
+                                    </p:set>
+                                    <p:animEffect transition="in" filter="fade">
+                                      <p:cBhvr>
+                                        <p:cTn id="130" dur="400"/>
+                                        <p:tgtEl>
+                                          <p:spTgt spid="33"/>
+                                        </p:tgtEl>
+                                      </p:cBhvr>
+                                    </p:animEffect>
+                                  </p:childTnLst>
+                                </p:cTn>
+                              </p:par>
+                              <p:par>
+                                <p:cTn id="131" presetID="10" presetClass="entr" presetSubtype="0" fill="hold" nodeType="withEffect">
+                                  <p:stCondLst>
+                                    <p:cond delay="250"/>
+                                  </p:stCondLst>
+                                  <p:childTnLst>
+                                    <p:set>
+                                      <p:cBhvr>
+                                        <p:cTn id="132" dur="1" fill="hold">
+                                          <p:stCondLst>
+                                            <p:cond delay="0"/>
+                                          </p:stCondLst>
+                                        </p:cTn>
+                                        <p:tgtEl>
+                                          <p:spTgt spid="34"/>
+                                        </p:tgtEl>
+                                        <p:attrNameLst>
+                                          <p:attrName>style.visibility</p:attrName>
+                                        </p:attrNameLst>
+                                      </p:cBhvr>
+                                      <p:to>
+                                        <p:strVal val="visible"/>
+                                      </p:to>
+                                    </p:set>
+                                    <p:animEffect transition="in" filter="fade">
+                                      <p:cBhvr>
+                                        <p:cTn id="133" dur="400"/>
+                                        <p:tgtEl>
+                                          <p:spTgt spid="34"/>
+                                        </p:tgtEl>
+                                      </p:cBhvr>
+                                    </p:animEffect>
+                                  </p:childTnLst>
+                                </p:cTn>
+                              </p:par>
+                              <p:par>
+                                <p:cTn id="134" presetID="10" presetClass="entr" presetSubtype="0" fill="hold" nodeType="withEffect">
+                                  <p:stCondLst>
+                                    <p:cond delay="250"/>
+                                  </p:stCondLst>
+                                  <p:childTnLst>
+                                    <p:set>
+                                      <p:cBhvr>
+                                        <p:cTn id="135" dur="1" fill="hold">
+                                          <p:stCondLst>
+                                            <p:cond delay="0"/>
+                                          </p:stCondLst>
+                                        </p:cTn>
+                                        <p:tgtEl>
+                                          <p:spTgt spid="35"/>
+                                        </p:tgtEl>
+                                        <p:attrNameLst>
+                                          <p:attrName>style.visibility</p:attrName>
+                                        </p:attrNameLst>
+                                      </p:cBhvr>
+                                      <p:to>
+                                        <p:strVal val="visible"/>
+                                      </p:to>
+                                    </p:set>
+                                    <p:animEffect transition="in" filter="fade">
+                                      <p:cBhvr>
+                                        <p:cTn id="136" dur="400"/>
+                                        <p:tgtEl>
+                                          <p:spTgt spid="35"/>
+                                        </p:tgtEl>
+                                      </p:cBhvr>
+                                    </p:animEffect>
+                                  </p:childTnLst>
+                                </p:cTn>
+                              </p:par>
+                              <p:par>
+                                <p:cTn id="137" presetID="10" presetClass="entr" presetSubtype="0" fill="hold" nodeType="withEffect">
+                                  <p:stCondLst>
+                                    <p:cond delay="250"/>
+                                  </p:stCondLst>
+                                  <p:childTnLst>
+                                    <p:set>
+                                      <p:cBhvr>
+                                        <p:cTn id="138" dur="1" fill="hold">
+                                          <p:stCondLst>
+                                            <p:cond delay="0"/>
+                                          </p:stCondLst>
+                                        </p:cTn>
+                                        <p:tgtEl>
+                                          <p:spTgt spid="36"/>
+                                        </p:tgtEl>
+                                        <p:attrNameLst>
+                                          <p:attrName>style.visibility</p:attrName>
+                                        </p:attrNameLst>
+                                      </p:cBhvr>
+                                      <p:to>
+                                        <p:strVal val="visible"/>
+                                      </p:to>
+                                    </p:set>
+                                    <p:animEffect transition="in" filter="fade">
+                                      <p:cBhvr>
+                                        <p:cTn id="139" dur="400"/>
+                                        <p:tgtEl>
+                                          <p:spTgt spid="36"/>
+                                        </p:tgtEl>
+                                      </p:cBhvr>
+                                    </p:animEffect>
+                                  </p:childTnLst>
+                                </p:cTn>
+                              </p:par>
+                            </p:childTnLst>
+                          </p:cTn>
+                        </p:par>
+                      </p:childTnLst>
+                    </p:cTn>
+                  </p:par>
+                  <p:par>
+                    <p:cTn id="140" fill="hold">
+                      <p:stCondLst>
+                        <p:cond delay="indefinite"/>
+                      </p:stCondLst>
+                      <p:childTnLst>
+                        <p:par>
+                          <p:cTn id="141" fill="hold">
+                            <p:stCondLst>
+                              <p:cond delay="0"/>
+                            </p:stCondLst>
+                            <p:childTnLst>
+                              <p:par>
+                                <p:cTn id="142" presetID="10" presetClass="entr" presetSubtype="0" fill="hold" nodeType="clickEffect">
+                                  <p:stCondLst>
+                                    <p:cond delay="0"/>
+                                  </p:stCondLst>
+                                  <p:childTnLst>
+                                    <p:set>
+                                      <p:cBhvr>
+                                        <p:cTn id="143" dur="1" fill="hold">
+                                          <p:stCondLst>
+                                            <p:cond delay="0"/>
+                                          </p:stCondLst>
+                                        </p:cTn>
+                                        <p:tgtEl>
+                                          <p:spTgt spid="48"/>
+                                        </p:tgtEl>
+                                        <p:attrNameLst>
+                                          <p:attrName>style.visibility</p:attrName>
+                                        </p:attrNameLst>
+                                      </p:cBhvr>
+                                      <p:to>
+                                        <p:strVal val="visible"/>
+                                      </p:to>
+                                    </p:set>
+                                    <p:animEffect transition="in" filter="fade">
+                                      <p:cBhvr>
+                                        <p:cTn id="144" dur="400"/>
+                                        <p:tgtEl>
+                                          <p:spTgt spid="48"/>
+                                        </p:tgtEl>
+                                      </p:cBhvr>
+                                    </p:animEffect>
+                                  </p:childTnLst>
+                                </p:cTn>
+                              </p:par>
+                              <p:par>
+                                <p:cTn id="145" presetID="10" presetClass="entr" presetSubtype="0" fill="hold" nodeType="withEffect">
+                                  <p:stCondLst>
+                                    <p:cond delay="250"/>
+                                  </p:stCondLst>
+                                  <p:childTnLst>
+                                    <p:set>
+                                      <p:cBhvr>
+                                        <p:cTn id="146" dur="1" fill="hold">
+                                          <p:stCondLst>
+                                            <p:cond delay="0"/>
+                                          </p:stCondLst>
+                                        </p:cTn>
+                                        <p:tgtEl>
+                                          <p:spTgt spid="37"/>
+                                        </p:tgtEl>
+                                        <p:attrNameLst>
+                                          <p:attrName>style.visibility</p:attrName>
+                                        </p:attrNameLst>
+                                      </p:cBhvr>
+                                      <p:to>
+                                        <p:strVal val="visible"/>
+                                      </p:to>
+                                    </p:set>
+                                    <p:animEffect transition="in" filter="fade">
+                                      <p:cBhvr>
+                                        <p:cTn id="147" dur="400"/>
+                                        <p:tgtEl>
+                                          <p:spTgt spid="37"/>
+                                        </p:tgtEl>
+                                      </p:cBhvr>
+                                    </p:animEffect>
+                                  </p:childTnLst>
+                                </p:cTn>
+                              </p:par>
+                              <p:par>
+                                <p:cTn id="148" presetID="10" presetClass="entr" presetSubtype="0" fill="hold" nodeType="withEffect">
+                                  <p:stCondLst>
+                                    <p:cond delay="250"/>
+                                  </p:stCondLst>
+                                  <p:childTnLst>
+                                    <p:set>
+                                      <p:cBhvr>
+                                        <p:cTn id="149" dur="1" fill="hold">
+                                          <p:stCondLst>
+                                            <p:cond delay="0"/>
+                                          </p:stCondLst>
+                                        </p:cTn>
+                                        <p:tgtEl>
+                                          <p:spTgt spid="38"/>
+                                        </p:tgtEl>
+                                        <p:attrNameLst>
+                                          <p:attrName>style.visibility</p:attrName>
+                                        </p:attrNameLst>
+                                      </p:cBhvr>
+                                      <p:to>
+                                        <p:strVal val="visible"/>
+                                      </p:to>
+                                    </p:set>
+                                    <p:animEffect transition="in" filter="fade">
+                                      <p:cBhvr>
+                                        <p:cTn id="150" dur="400"/>
+                                        <p:tgtEl>
+                                          <p:spTgt spid="38"/>
+                                        </p:tgtEl>
+                                      </p:cBhvr>
+                                    </p:animEffect>
+                                  </p:childTnLst>
+                                </p:cTn>
+                              </p:par>
+                              <p:par>
+                                <p:cTn id="151" presetID="10" presetClass="entr" presetSubtype="0" fill="hold" nodeType="withEffect">
+                                  <p:stCondLst>
+                                    <p:cond delay="250"/>
+                                  </p:stCondLst>
+                                  <p:childTnLst>
+                                    <p:set>
+                                      <p:cBhvr>
+                                        <p:cTn id="152" dur="1" fill="hold">
+                                          <p:stCondLst>
+                                            <p:cond delay="0"/>
+                                          </p:stCondLst>
+                                        </p:cTn>
+                                        <p:tgtEl>
+                                          <p:spTgt spid="39"/>
+                                        </p:tgtEl>
+                                        <p:attrNameLst>
+                                          <p:attrName>style.visibility</p:attrName>
+                                        </p:attrNameLst>
+                                      </p:cBhvr>
+                                      <p:to>
+                                        <p:strVal val="visible"/>
+                                      </p:to>
+                                    </p:set>
+                                    <p:animEffect transition="in" filter="fade">
+                                      <p:cBhvr>
+                                        <p:cTn id="153" dur="400"/>
+                                        <p:tgtEl>
+                                          <p:spTgt spid="39"/>
+                                        </p:tgtEl>
+                                      </p:cBhvr>
+                                    </p:animEffect>
+                                  </p:childTnLst>
+                                </p:cTn>
+                              </p:par>
+                              <p:par>
+                                <p:cTn id="154" presetID="10" presetClass="entr" presetSubtype="0" fill="hold" nodeType="withEffect">
+                                  <p:stCondLst>
+                                    <p:cond delay="250"/>
+                                  </p:stCondLst>
+                                  <p:childTnLst>
+                                    <p:set>
+                                      <p:cBhvr>
+                                        <p:cTn id="155" dur="1" fill="hold">
+                                          <p:stCondLst>
+                                            <p:cond delay="0"/>
+                                          </p:stCondLst>
+                                        </p:cTn>
+                                        <p:tgtEl>
+                                          <p:spTgt spid="40"/>
+                                        </p:tgtEl>
+                                        <p:attrNameLst>
+                                          <p:attrName>style.visibility</p:attrName>
+                                        </p:attrNameLst>
+                                      </p:cBhvr>
+                                      <p:to>
+                                        <p:strVal val="visible"/>
+                                      </p:to>
+                                    </p:set>
+                                    <p:animEffect transition="in" filter="fade">
+                                      <p:cBhvr>
+                                        <p:cTn id="156" dur="400"/>
+                                        <p:tgtEl>
+                                          <p:spTgt spid="40"/>
+                                        </p:tgtEl>
+                                      </p:cBhvr>
+                                    </p:animEffect>
+                                  </p:childTnLst>
+                                </p:cTn>
+                              </p:par>
+                              <p:par>
+                                <p:cTn id="157" presetID="10" presetClass="entr" presetSubtype="0" fill="hold" nodeType="withEffect">
+                                  <p:stCondLst>
+                                    <p:cond delay="250"/>
+                                  </p:stCondLst>
+                                  <p:childTnLst>
+                                    <p:set>
+                                      <p:cBhvr>
+                                        <p:cTn id="158" dur="1" fill="hold">
+                                          <p:stCondLst>
+                                            <p:cond delay="0"/>
+                                          </p:stCondLst>
+                                        </p:cTn>
+                                        <p:tgtEl>
+                                          <p:spTgt spid="41"/>
+                                        </p:tgtEl>
+                                        <p:attrNameLst>
+                                          <p:attrName>style.visibility</p:attrName>
+                                        </p:attrNameLst>
+                                      </p:cBhvr>
+                                      <p:to>
+                                        <p:strVal val="visible"/>
+                                      </p:to>
+                                    </p:set>
+                                    <p:animEffect transition="in" filter="fade">
+                                      <p:cBhvr>
+                                        <p:cTn id="159" dur="400"/>
+                                        <p:tgtEl>
+                                          <p:spTgt spid="41"/>
+                                        </p:tgtEl>
+                                      </p:cBhvr>
+                                    </p:animEffect>
+                                  </p:childTnLst>
+                                </p:cTn>
+                              </p:par>
+                            </p:childTnLst>
+                          </p:cTn>
+                        </p:par>
+                      </p:childTnLst>
+                    </p:cTn>
+                  </p:par>
+                </p:childTnLst>
+              </p:cTn>
+              <p:prevCondLst>
+                <p:cond evt="onPrev" delay="0">
+                  <p:tgtEl>
+                    <p:sldTgt/>
+                  </p:tgtEl>
+                </p:cond>
+              </p:prevCondLst>
+              <p:nextCondLst>
+                <p:cond evt="onNext" delay="0">
+                  <p:tgtEl>
+                    <p:sldTgt/>
+                  </p:tgtEl>
+                </p:cond>
+              </p:nextCondLst>
+            </p:seq>
+          </p:childTnLst>
+        </p:cTn>
+      </p:par>
+    </p:tnLst>
+  </p:timing>
 </p:sld>
 </file>
 
@@ -5188,8 +8181,8 @@
         </p:nvSpPr>
         <p:spPr>
           <a:xfrm>
-            <a:off x="548640" y="502920"/>
-            <a:ext cx="5486400" cy="731520"/>
+            <a:off x="548640" y="457200"/>
+            <a:ext cx="7315200" cy="731520"/>
           </a:xfrm>
           <a:prstGeom prst="rect">
             <a:avLst/>
@@ -5205,7 +8198,7 @@
               <a:buNone/>
             </a:pPr>
             <a:r>
-              <a:rPr lang="en-US" sz="4000" b="1" dirty="0">
+              <a:rPr lang="en-US" sz="3600" b="1" dirty="0">
                 <a:solidFill>
                   <a:srgbClr val="FFFFFF"/>
                 </a:solidFill>
@@ -5213,9 +8206,9 @@
                 <a:ea typeface="Inter" pitchFamily="34" charset="-122"/>
                 <a:cs typeface="Inter" pitchFamily="34" charset="-120"/>
               </a:rPr>
-              <a:t>Summary</a:t>
-            </a:r>
-            <a:endParaRPr lang="en-US" sz="4000" dirty="0"/>
+              <a:t>What comes next</a:t>
+            </a:r>
+            <a:endParaRPr lang="en-US" sz="3600" dirty="0"/>
           </a:p>
         </p:txBody>
       </p:sp>
@@ -5227,8 +8220,8 @@
         </p:nvSpPr>
         <p:spPr>
           <a:xfrm>
-            <a:off x="548640" y="1463040"/>
-            <a:ext cx="10972800" cy="1828800"/>
+            <a:off x="548640" y="1325880"/>
+            <a:ext cx="4754880" cy="320040"/>
           </a:xfrm>
           <a:prstGeom prst="rect">
             <a:avLst/>
@@ -5237,83 +8230,382 @@
           <a:ln/>
         </p:spPr>
         <p:txBody>
-          <a:bodyPr wrap="square" lIns="0" tIns="0" rIns="0" bIns="0" rtlCol="0" anchor="t"/>
-          <a:lstStyle/>
-          <a:p>
-            <a:pPr marL="342900" indent="-342900">
-              <a:spcAft>
-                <a:spcPts val="1400"/>
-              </a:spcAft>
-              <a:buSzPct val="100000"/>
-              <a:buChar char="•"/>
-            </a:pPr>
-            <a:r>
-              <a:rPr lang="en-US" sz="2200" dirty="0">
-                <a:solidFill>
-                  <a:srgbClr val="FFFFFF"/>
+          <a:bodyPr wrap="square" lIns="0" tIns="0" rIns="0" bIns="0" rtlCol="0" anchor="ctr"/>
+          <a:lstStyle/>
+          <a:p>
+            <a:pPr indent="0" marL="0">
+              <a:buNone/>
+            </a:pPr>
+            <a:r>
+              <a:rPr lang="en-US" sz="1300" b="1" dirty="0">
+                <a:solidFill>
+                  <a:srgbClr val="B9C4BF"/>
                 </a:solidFill>
                 <a:latin typeface="Inter" pitchFamily="34" charset="0"/>
                 <a:ea typeface="Inter" pitchFamily="34" charset="-122"/>
                 <a:cs typeface="Inter" pitchFamily="34" charset="-120"/>
               </a:rPr>
-              <a:t>Isolation shortens the path, not always enough</a:t>
-            </a:r>
-            <a:endParaRPr lang="en-US" sz="2200" dirty="0"/>
-          </a:p>
-          <a:p>
-            <a:pPr marL="342900" indent="-342900">
-              <a:spcAft>
-                <a:spcPts val="1400"/>
-              </a:spcAft>
-              <a:buSzPct val="100000"/>
-              <a:buChar char="•"/>
-            </a:pPr>
-            <a:r>
-              <a:rPr lang="en-US" sz="2200" dirty="0">
-                <a:solidFill>
-                  <a:srgbClr val="FFFFFF"/>
+              <a:t>Today's limit</a:t>
+            </a:r>
+            <a:endParaRPr lang="en-US" sz="1300" dirty="0"/>
+          </a:p>
+        </p:txBody>
+      </p:sp>
+      <p:sp>
+        <p:nvSpPr>
+          <p:cNvPr id="4" name="Text 2"/>
+          <p:cNvSpPr txBox="1"/>
+          <p:nvPr/>
+        </p:nvSpPr>
+        <p:spPr>
+          <a:xfrm>
+            <a:off x="5989320" y="1325880"/>
+            <a:ext cx="5669280" cy="320040"/>
+          </a:xfrm>
+          <a:prstGeom prst="rect">
+            <a:avLst/>
+          </a:prstGeom>
+          <a:noFill/>
+          <a:ln/>
+        </p:spPr>
+        <p:txBody>
+          <a:bodyPr wrap="square" lIns="0" tIns="0" rIns="0" bIns="0" rtlCol="0" anchor="ctr"/>
+          <a:lstStyle/>
+          <a:p>
+            <a:pPr indent="0" marL="0">
+              <a:buNone/>
+            </a:pPr>
+            <a:r>
+              <a:rPr lang="en-US" sz="1300" b="1" dirty="0">
+                <a:solidFill>
+                  <a:srgbClr val="F2C14E"/>
                 </a:solidFill>
                 <a:latin typeface="Inter" pitchFamily="34" charset="0"/>
                 <a:ea typeface="Inter" pitchFamily="34" charset="-122"/>
                 <a:cs typeface="Inter" pitchFamily="34" charset="-120"/>
               </a:rPr>
-              <a:t>One leak: DeepSeek, email tool, raw file</a:t>
-            </a:r>
-            <a:endParaRPr lang="en-US" sz="2200" dirty="0"/>
-          </a:p>
-          <a:p>
-            <a:pPr marL="342900" indent="-342900">
-              <a:spcAft>
-                <a:spcPts val="1400"/>
-              </a:spcAft>
-              <a:buSzPct val="100000"/>
-              <a:buChar char="•"/>
-            </a:pPr>
-            <a:r>
-              <a:rPr lang="en-US" sz="2200" dirty="0">
-                <a:solidFill>
-                  <a:srgbClr val="FFFFFF"/>
+              <a:t>Future work that closes it</a:t>
+            </a:r>
+            <a:endParaRPr lang="en-US" sz="1300" dirty="0"/>
+          </a:p>
+        </p:txBody>
+      </p:sp>
+      <p:sp>
+        <p:nvSpPr>
+          <p:cNvPr id="5" name="Text 3"/>
+          <p:cNvSpPr txBox="1"/>
+          <p:nvPr/>
+        </p:nvSpPr>
+        <p:spPr>
+          <a:xfrm>
+            <a:off x="548640" y="1783080"/>
+            <a:ext cx="4754880" cy="457200"/>
+          </a:xfrm>
+          <a:prstGeom prst="rect">
+            <a:avLst/>
+          </a:prstGeom>
+          <a:noFill/>
+          <a:ln/>
+        </p:spPr>
+        <p:txBody>
+          <a:bodyPr wrap="square" lIns="0" tIns="0" rIns="0" bIns="0" rtlCol="0" anchor="ctr"/>
+          <a:lstStyle/>
+          <a:p>
+            <a:pPr indent="0" marL="0">
+              <a:buNone/>
+            </a:pPr>
+            <a:r>
+              <a:rPr lang="en-US" sz="1600" dirty="0">
+                <a:solidFill>
+                  <a:srgbClr val="B9C4BF"/>
                 </a:solidFill>
                 <a:latin typeface="Inter" pitchFamily="34" charset="0"/>
                 <a:ea typeface="Inter" pitchFamily="34" charset="-122"/>
                 <a:cs typeface="Inter" pitchFamily="34" charset="-120"/>
               </a:rPr>
-              <a:t>The help desk failed without attackers</a:t>
-            </a:r>
-            <a:endParaRPr lang="en-US" sz="2200" dirty="0"/>
-          </a:p>
-        </p:txBody>
-      </p:sp>
-      <p:sp>
-        <p:nvSpPr>
-          <p:cNvPr id="4" name="photo-Aryan Mittal"/>
+              <a:t>No human check of the scoring</a:t>
+            </a:r>
+            <a:endParaRPr lang="en-US" sz="1600" dirty="0"/>
+          </a:p>
+        </p:txBody>
+      </p:sp>
+      <p:sp>
+        <p:nvSpPr>
+          <p:cNvPr id="6" name="Shape 4"/>
           <p:cNvSpPr/>
           <p:nvPr/>
         </p:nvSpPr>
         <p:spPr>
           <a:xfrm>
-            <a:off x="1028700" y="3657600"/>
-            <a:ext cx="1325880" cy="1325880"/>
+            <a:off x="5349240" y="2011680"/>
+            <a:ext cx="457200" cy="914"/>
+          </a:xfrm>
+          <a:prstGeom prst="line">
+            <a:avLst/>
+          </a:prstGeom>
+          <a:noFill/>
+          <a:ln w="25400">
+            <a:solidFill>
+              <a:srgbClr val="F2C14E"/>
+            </a:solidFill>
+            <a:prstDash val="solid"/>
+            <a:tailEnd type="triangle"/>
+          </a:ln>
+        </p:spPr>
+      </p:sp>
+      <p:sp>
+        <p:nvSpPr>
+          <p:cNvPr id="7" name="Text 5"/>
+          <p:cNvSpPr txBox="1"/>
+          <p:nvPr/>
+        </p:nvSpPr>
+        <p:spPr>
+          <a:xfrm>
+            <a:off x="5989320" y="1783080"/>
+            <a:ext cx="5669280" cy="457200"/>
+          </a:xfrm>
+          <a:prstGeom prst="rect">
+            <a:avLst/>
+          </a:prstGeom>
+          <a:noFill/>
+          <a:ln/>
+        </p:spPr>
+        <p:txBody>
+          <a:bodyPr wrap="square" lIns="0" tIns="0" rIns="0" bIns="0" rtlCol="0" anchor="ctr"/>
+          <a:lstStyle/>
+          <a:p>
+            <a:pPr indent="0" marL="0">
+              <a:buNone/>
+            </a:pPr>
+            <a:r>
+              <a:rPr lang="en-US" sz="1800" b="1" dirty="0">
+                <a:solidFill>
+                  <a:srgbClr val="FFFFFF"/>
+                </a:solidFill>
+                <a:latin typeface="Inter" pitchFamily="34" charset="0"/>
+                <a:ea typeface="Inter" pitchFamily="34" charset="-122"/>
+                <a:cs typeface="Inter" pitchFamily="34" charset="-120"/>
+              </a:rPr>
+              <a:t>Two independent people check the scoring</a:t>
+            </a:r>
+            <a:endParaRPr lang="en-US" sz="1800" dirty="0"/>
+          </a:p>
+        </p:txBody>
+      </p:sp>
+      <p:sp>
+        <p:nvSpPr>
+          <p:cNvPr id="8" name="Text 6"/>
+          <p:cNvSpPr txBox="1"/>
+          <p:nvPr/>
+        </p:nvSpPr>
+        <p:spPr>
+          <a:xfrm>
+            <a:off x="548640" y="2404872"/>
+            <a:ext cx="4754880" cy="457200"/>
+          </a:xfrm>
+          <a:prstGeom prst="rect">
+            <a:avLst/>
+          </a:prstGeom>
+          <a:noFill/>
+          <a:ln/>
+        </p:spPr>
+        <p:txBody>
+          <a:bodyPr wrap="square" lIns="0" tIns="0" rIns="0" bIns="0" rtlCol="0" anchor="ctr"/>
+          <a:lstStyle/>
+          <a:p>
+            <a:pPr indent="0" marL="0">
+              <a:buNone/>
+            </a:pPr>
+            <a:r>
+              <a:rPr lang="en-US" sz="1600" dirty="0">
+                <a:solidFill>
+                  <a:srgbClr val="B9C4BF"/>
+                </a:solidFill>
+                <a:latin typeface="Inter" pitchFamily="34" charset="0"/>
+                <a:ea typeface="Inter" pitchFamily="34" charset="-122"/>
+                <a:cs typeface="Inter" pitchFamily="34" charset="-120"/>
+              </a:rPr>
+              <a:t>Exact repeats only, so rates are minimums</a:t>
+            </a:r>
+            <a:endParaRPr lang="en-US" sz="1600" dirty="0"/>
+          </a:p>
+        </p:txBody>
+      </p:sp>
+      <p:sp>
+        <p:nvSpPr>
+          <p:cNvPr id="9" name="Shape 7"/>
+          <p:cNvSpPr/>
+          <p:nvPr/>
+        </p:nvSpPr>
+        <p:spPr>
+          <a:xfrm>
+            <a:off x="5349240" y="2633472"/>
+            <a:ext cx="457200" cy="914"/>
+          </a:xfrm>
+          <a:prstGeom prst="line">
+            <a:avLst/>
+          </a:prstGeom>
+          <a:noFill/>
+          <a:ln w="25400">
+            <a:solidFill>
+              <a:srgbClr val="F2C14E"/>
+            </a:solidFill>
+            <a:prstDash val="solid"/>
+            <a:tailEnd type="triangle"/>
+          </a:ln>
+        </p:spPr>
+      </p:sp>
+      <p:sp>
+        <p:nvSpPr>
+          <p:cNvPr id="10" name="Text 8"/>
+          <p:cNvSpPr txBox="1"/>
+          <p:nvPr/>
+        </p:nvSpPr>
+        <p:spPr>
+          <a:xfrm>
+            <a:off x="5989320" y="2404872"/>
+            <a:ext cx="5669280" cy="457200"/>
+          </a:xfrm>
+          <a:prstGeom prst="rect">
+            <a:avLst/>
+          </a:prstGeom>
+          <a:noFill/>
+          <a:ln/>
+        </p:spPr>
+        <p:txBody>
+          <a:bodyPr wrap="square" lIns="0" tIns="0" rIns="0" bIns="0" rtlCol="0" anchor="ctr"/>
+          <a:lstStyle/>
+          <a:p>
+            <a:pPr indent="0" marL="0">
+              <a:buNone/>
+            </a:pPr>
+            <a:r>
+              <a:rPr lang="en-US" sz="1800" b="1" dirty="0">
+                <a:solidFill>
+                  <a:srgbClr val="FFFFFF"/>
+                </a:solidFill>
+                <a:latin typeface="Inter" pitchFamily="34" charset="0"/>
+                <a:ea typeface="Inter" pitchFamily="34" charset="-122"/>
+                <a:cs typeface="Inter" pitchFamily="34" charset="-120"/>
+              </a:rPr>
+              <a:t>Score paraphrased and indirect spread</a:t>
+            </a:r>
+            <a:endParaRPr lang="en-US" sz="1800" dirty="0"/>
+          </a:p>
+        </p:txBody>
+      </p:sp>
+      <p:sp>
+        <p:nvSpPr>
+          <p:cNvPr id="11" name="Text 9"/>
+          <p:cNvSpPr txBox="1"/>
+          <p:nvPr/>
+        </p:nvSpPr>
+        <p:spPr>
+          <a:xfrm>
+            <a:off x="548640" y="3026664"/>
+            <a:ext cx="4754880" cy="457200"/>
+          </a:xfrm>
+          <a:prstGeom prst="rect">
+            <a:avLst/>
+          </a:prstGeom>
+          <a:noFill/>
+          <a:ln/>
+        </p:spPr>
+        <p:txBody>
+          <a:bodyPr wrap="square" lIns="0" tIns="0" rIns="0" bIns="0" rtlCol="0" anchor="ctr"/>
+          <a:lstStyle/>
+          <a:p>
+            <a:pPr indent="0" marL="0">
+              <a:buNone/>
+            </a:pPr>
+            <a:r>
+              <a:rPr lang="en-US" sz="1600" dirty="0">
+                <a:solidFill>
+                  <a:srgbClr val="B9C4BF"/>
+                </a:solidFill>
+                <a:latin typeface="Inter" pitchFamily="34" charset="0"/>
+                <a:ea typeface="Inter" pitchFamily="34" charset="-122"/>
+                <a:cs typeface="Inter" pitchFamily="34" charset="-120"/>
+              </a:rPr>
+              <a:t>Two models; isolation hides who asked</a:t>
+            </a:r>
+            <a:endParaRPr lang="en-US" sz="1600" dirty="0"/>
+          </a:p>
+        </p:txBody>
+      </p:sp>
+      <p:sp>
+        <p:nvSpPr>
+          <p:cNvPr id="12" name="Shape 10"/>
+          <p:cNvSpPr/>
+          <p:nvPr/>
+        </p:nvSpPr>
+        <p:spPr>
+          <a:xfrm>
+            <a:off x="5349240" y="3255264"/>
+            <a:ext cx="457200" cy="914"/>
+          </a:xfrm>
+          <a:prstGeom prst="line">
+            <a:avLst/>
+          </a:prstGeom>
+          <a:noFill/>
+          <a:ln w="25400">
+            <a:solidFill>
+              <a:srgbClr val="F2C14E"/>
+            </a:solidFill>
+            <a:prstDash val="solid"/>
+            <a:tailEnd type="triangle"/>
+          </a:ln>
+        </p:spPr>
+      </p:sp>
+      <p:sp>
+        <p:nvSpPr>
+          <p:cNvPr id="13" name="Text 11"/>
+          <p:cNvSpPr txBox="1"/>
+          <p:nvPr/>
+        </p:nvSpPr>
+        <p:spPr>
+          <a:xfrm>
+            <a:off x="5989320" y="3026664"/>
+            <a:ext cx="5669280" cy="457200"/>
+          </a:xfrm>
+          <a:prstGeom prst="rect">
+            <a:avLst/>
+          </a:prstGeom>
+          <a:noFill/>
+          <a:ln/>
+        </p:spPr>
+        <p:txBody>
+          <a:bodyPr wrap="square" lIns="0" tIns="0" rIns="0" bIns="0" rtlCol="0" anchor="ctr"/>
+          <a:lstStyle/>
+          <a:p>
+            <a:pPr indent="0" marL="0">
+              <a:buNone/>
+            </a:pPr>
+            <a:r>
+              <a:rPr lang="en-US" sz="1800" b="1" dirty="0">
+                <a:solidFill>
+                  <a:srgbClr val="FFFFFF"/>
+                </a:solidFill>
+                <a:latin typeface="Inter" pitchFamily="34" charset="0"/>
+                <a:ea typeface="Inter" pitchFamily="34" charset="-122"/>
+                <a:cs typeface="Inter" pitchFamily="34" charset="-120"/>
+              </a:rPr>
+              <a:t>More models, isolation with verified identity</a:t>
+            </a:r>
+            <a:endParaRPr lang="en-US" sz="1800" dirty="0"/>
+          </a:p>
+        </p:txBody>
+      </p:sp>
+      <p:sp>
+        <p:nvSpPr>
+          <p:cNvPr id="14" name="photo-Aryan Mittal"/>
+          <p:cNvSpPr/>
+          <p:nvPr/>
+        </p:nvSpPr>
+        <p:spPr>
+          <a:xfrm>
+            <a:off x="1074420" y="3977640"/>
+            <a:ext cx="1234440" cy="1234440"/>
           </a:xfrm>
           <a:prstGeom prst="ellipse">
             <a:avLst/>
@@ -5331,7 +8623,7 @@
       </p:sp>
       <p:pic>
         <p:nvPicPr>
-          <p:cNvPr id="5" name="Image 0" descr="preencoded.png">    </p:cNvPr>
+          <p:cNvPr id="15" name="Image 0" descr="preencoded.png">    </p:cNvPr>
           <p:cNvPicPr>
             <a:picLocks noChangeAspect="1"/>
           </p:cNvPicPr>
@@ -5347,8 +8639,8 @@
         </p:blipFill>
         <p:spPr>
           <a:xfrm>
-            <a:off x="1417320" y="4005072"/>
-            <a:ext cx="548640" cy="548640"/>
+            <a:off x="1435608" y="4306824"/>
+            <a:ext cx="512064" cy="512064"/>
           </a:xfrm>
           <a:prstGeom prst="rect">
             <a:avLst/>
@@ -5357,13 +8649,13 @@
       </p:pic>
       <p:sp>
         <p:nvSpPr>
-          <p:cNvPr id="6" name="Text 3"/>
+          <p:cNvPr id="16" name="Text 13"/>
           <p:cNvSpPr txBox="1"/>
           <p:nvPr/>
         </p:nvSpPr>
         <p:spPr>
           <a:xfrm>
-            <a:off x="320040" y="5120640"/>
+            <a:off x="320040" y="5349240"/>
             <a:ext cx="2743200" cy="365760"/>
           </a:xfrm>
           <a:prstGeom prst="rect">
@@ -5396,13 +8688,13 @@
       </p:sp>
       <p:sp>
         <p:nvSpPr>
-          <p:cNvPr id="7" name="Text 4"/>
+          <p:cNvPr id="17" name="Text 14"/>
           <p:cNvSpPr txBox="1"/>
           <p:nvPr/>
         </p:nvSpPr>
         <p:spPr>
           <a:xfrm>
-            <a:off x="320040" y="5486400"/>
+            <a:off x="320040" y="5715000"/>
             <a:ext cx="2743200" cy="320040"/>
           </a:xfrm>
           <a:prstGeom prst="rect">
@@ -5435,14 +8727,14 @@
       </p:sp>
       <p:sp>
         <p:nvSpPr>
-          <p:cNvPr id="8" name="photo-Rohan Bhamidipati"/>
+          <p:cNvPr id="18" name="photo-Rohan Bhamidipati"/>
           <p:cNvSpPr/>
           <p:nvPr/>
         </p:nvSpPr>
         <p:spPr>
           <a:xfrm>
-            <a:off x="3954780" y="3657600"/>
-            <a:ext cx="1325880" cy="1325880"/>
+            <a:off x="4000500" y="3977640"/>
+            <a:ext cx="1234440" cy="1234440"/>
           </a:xfrm>
           <a:prstGeom prst="ellipse">
             <a:avLst/>
@@ -5460,7 +8752,7 @@
       </p:sp>
       <p:pic>
         <p:nvPicPr>
-          <p:cNvPr id="9" name="Image 1" descr="preencoded.png">    </p:cNvPr>
+          <p:cNvPr id="19" name="Image 1" descr="preencoded.png">    </p:cNvPr>
           <p:cNvPicPr>
             <a:picLocks noChangeAspect="1"/>
           </p:cNvPicPr>
@@ -5476,8 +8768,8 @@
         </p:blipFill>
         <p:spPr>
           <a:xfrm>
-            <a:off x="4343400" y="4005072"/>
-            <a:ext cx="548640" cy="548640"/>
+            <a:off x="4361688" y="4306824"/>
+            <a:ext cx="512064" cy="512064"/>
           </a:xfrm>
           <a:prstGeom prst="rect">
             <a:avLst/>
@@ -5486,13 +8778,13 @@
       </p:pic>
       <p:sp>
         <p:nvSpPr>
-          <p:cNvPr id="10" name="Text 6"/>
+          <p:cNvPr id="20" name="Text 16"/>
           <p:cNvSpPr txBox="1"/>
           <p:nvPr/>
         </p:nvSpPr>
         <p:spPr>
           <a:xfrm>
-            <a:off x="3246120" y="5120640"/>
+            <a:off x="3246120" y="5349240"/>
             <a:ext cx="2743200" cy="365760"/>
           </a:xfrm>
           <a:prstGeom prst="rect">
@@ -5525,13 +8817,13 @@
       </p:sp>
       <p:sp>
         <p:nvSpPr>
-          <p:cNvPr id="11" name="Text 7"/>
+          <p:cNvPr id="21" name="Text 17"/>
           <p:cNvSpPr txBox="1"/>
           <p:nvPr/>
         </p:nvSpPr>
         <p:spPr>
           <a:xfrm>
-            <a:off x="3246120" y="5486400"/>
+            <a:off x="3246120" y="5715000"/>
             <a:ext cx="2743200" cy="320040"/>
           </a:xfrm>
           <a:prstGeom prst="rect">
@@ -5564,14 +8856,14 @@
       </p:sp>
       <p:sp>
         <p:nvSpPr>
-          <p:cNvPr id="12" name="photo-Chaitanya Palasamudrum"/>
+          <p:cNvPr id="22" name="photo-Chaitanya Palasamudrum"/>
           <p:cNvSpPr/>
           <p:nvPr/>
         </p:nvSpPr>
         <p:spPr>
           <a:xfrm>
-            <a:off x="6880860" y="3657600"/>
-            <a:ext cx="1325880" cy="1325880"/>
+            <a:off x="6926580" y="3977640"/>
+            <a:ext cx="1234440" cy="1234440"/>
           </a:xfrm>
           <a:prstGeom prst="ellipse">
             <a:avLst/>
@@ -5589,7 +8881,7 @@
       </p:sp>
       <p:pic>
         <p:nvPicPr>
-          <p:cNvPr id="13" name="Image 2" descr="preencoded.png">    </p:cNvPr>
+          <p:cNvPr id="23" name="Image 2" descr="preencoded.png">    </p:cNvPr>
           <p:cNvPicPr>
             <a:picLocks noChangeAspect="1"/>
           </p:cNvPicPr>
@@ -5605,8 +8897,8 @@
         </p:blipFill>
         <p:spPr>
           <a:xfrm>
-            <a:off x="7269480" y="4005072"/>
-            <a:ext cx="548640" cy="548640"/>
+            <a:off x="7287768" y="4306824"/>
+            <a:ext cx="512064" cy="512064"/>
           </a:xfrm>
           <a:prstGeom prst="rect">
             <a:avLst/>
@@ -5615,13 +8907,13 @@
       </p:pic>
       <p:sp>
         <p:nvSpPr>
-          <p:cNvPr id="14" name="Text 9"/>
+          <p:cNvPr id="24" name="Text 19"/>
           <p:cNvSpPr txBox="1"/>
           <p:nvPr/>
         </p:nvSpPr>
         <p:spPr>
           <a:xfrm>
-            <a:off x="6172200" y="5120640"/>
+            <a:off x="6172200" y="5349240"/>
             <a:ext cx="2743200" cy="365760"/>
           </a:xfrm>
           <a:prstGeom prst="rect">
@@ -5654,13 +8946,13 @@
       </p:sp>
       <p:sp>
         <p:nvSpPr>
-          <p:cNvPr id="15" name="Text 10"/>
+          <p:cNvPr id="25" name="Text 20"/>
           <p:cNvSpPr txBox="1"/>
           <p:nvPr/>
         </p:nvSpPr>
         <p:spPr>
           <a:xfrm>
-            <a:off x="6172200" y="5486400"/>
+            <a:off x="6172200" y="5715000"/>
             <a:ext cx="2743200" cy="320040"/>
           </a:xfrm>
           <a:prstGeom prst="rect">
@@ -5693,14 +8985,14 @@
       </p:sp>
       <p:sp>
         <p:nvSpPr>
-          <p:cNvPr id="16" name="photo-Bibhuti Swain"/>
+          <p:cNvPr id="26" name="photo-Bibhuti Swain"/>
           <p:cNvSpPr/>
           <p:nvPr/>
         </p:nvSpPr>
         <p:spPr>
           <a:xfrm>
-            <a:off x="9806940" y="3657600"/>
-            <a:ext cx="1325880" cy="1325880"/>
+            <a:off x="9852660" y="3977640"/>
+            <a:ext cx="1234440" cy="1234440"/>
           </a:xfrm>
           <a:prstGeom prst="ellipse">
             <a:avLst/>
@@ -5718,7 +9010,7 @@
       </p:sp>
       <p:pic>
         <p:nvPicPr>
-          <p:cNvPr id="17" name="Image 3" descr="preencoded.png">    </p:cNvPr>
+          <p:cNvPr id="27" name="Image 3" descr="preencoded.png">    </p:cNvPr>
           <p:cNvPicPr>
             <a:picLocks noChangeAspect="1"/>
           </p:cNvPicPr>
@@ -5734,8 +9026,8 @@
         </p:blipFill>
         <p:spPr>
           <a:xfrm>
-            <a:off x="10195560" y="4005072"/>
-            <a:ext cx="548640" cy="548640"/>
+            <a:off x="10213848" y="4306824"/>
+            <a:ext cx="512064" cy="512064"/>
           </a:xfrm>
           <a:prstGeom prst="rect">
             <a:avLst/>
@@ -5744,13 +9036,13 @@
       </p:pic>
       <p:sp>
         <p:nvSpPr>
-          <p:cNvPr id="18" name="Text 12"/>
+          <p:cNvPr id="28" name="Text 22"/>
           <p:cNvSpPr txBox="1"/>
           <p:nvPr/>
         </p:nvSpPr>
         <p:spPr>
           <a:xfrm>
-            <a:off x="9098280" y="5120640"/>
+            <a:off x="9098280" y="5349240"/>
             <a:ext cx="2743200" cy="365760"/>
           </a:xfrm>
           <a:prstGeom prst="rect">
@@ -5783,13 +9075,13 @@
       </p:sp>
       <p:sp>
         <p:nvSpPr>
-          <p:cNvPr id="19" name="Text 13"/>
+          <p:cNvPr id="29" name="Text 23"/>
           <p:cNvSpPr txBox="1"/>
           <p:nvPr/>
         </p:nvSpPr>
         <p:spPr>
           <a:xfrm>
-            <a:off x="9098280" y="5486400"/>
+            <a:off x="9098280" y="5715000"/>
             <a:ext cx="2743200" cy="320040"/>
           </a:xfrm>
           <a:prstGeom prst="rect">
@@ -5822,7 +9114,7 @@
       </p:sp>
       <p:sp>
         <p:nvSpPr>
-          <p:cNvPr id="21" name="Text 0"/>
+          <p:cNvPr id="31" name="Text 0"/>
           <p:cNvSpPr/>
           <p:nvPr>
             <p:ph idx="100" type="title" hasCustomPrompt="1"/>
@@ -6628,7 +9920,7 @@
       </p:sp>
       <p:sp>
         <p:nvSpPr>
-          <p:cNvPr id="25" name="Slide Number Placeholder 0"/>
+          <p:cNvPr id="27" name="Slide Number Placeholder 0"/>
           <p:cNvSpPr>
             <a:spLocks noGrp="1"/>
           </p:cNvSpPr>
@@ -8321,7 +11613,7 @@
       </p:sp>
       <p:sp>
         <p:nvSpPr>
-          <p:cNvPr id="25" name="Slide Number Placeholder 0"/>
+          <p:cNvPr id="32" name="Slide Number Placeholder 0"/>
           <p:cNvSpPr>
             <a:spLocks noGrp="1"/>
           </p:cNvSpPr>

</xml_diff>

<commit_message>
Slides: color-code the pipeline slide by role and add a small key
Yellow = untrusted file, dark = AI agent, pale = record kept; solid arrow =
passes its output on, dashed orange = raw file with isolation off. The
isolation-off card shares the dashed border.
</commit_message>
<xml_diff>
--- a/presentation/eduinject-slides.pptx
+++ b/presentation/eduinject-slides.pptx
@@ -119,25 +119,25 @@
   <p:extLst>
     <p:ext uri="{521415D9-36F7-43E2-AB2F-B90AF26B5E84}">
       <p14:sectionLst xmlns:p14="http://schemas.microsoft.com/office/powerpoint/2010/main">
-        <p14:section name="Opening" id="{26c412dc-592d-25aa-2fce-fb746519e7ba}">
+        <p14:section name="Opening" id="{94044a12-80f1-641c-4fb0-c8750d7d614b}">
           <p14:sldIdLst>
             <p14:sldId id="256"/>
           </p14:sldIdLst>
         </p14:section>
-        <p14:section name="Problem" id="{04288314-713e-d87c-f46a-d0918e28a770}">
+        <p14:section name="Problem" id="{68c85242-25b1-3a35-0192-ccb7c774bcba}">
           <p14:sldIdLst>
             <p14:sldId id="257"/>
             <p14:sldId id="258"/>
           </p14:sldIdLst>
         </p14:section>
-        <p14:section name="Method" id="{bc921d8c-0b8a-a5e8-e711-7194bc26f211}">
+        <p14:section name="Method" id="{1b3f5898-5604-4015-fd78-13bbe11f22dd}">
           <p14:sldIdLst>
             <p14:sldId id="259"/>
             <p14:sldId id="260"/>
             <p14:sldId id="261"/>
           </p14:sldIdLst>
         </p14:section>
-        <p14:section name="Findings" id="{29a9a8a1-533a-ee99-9786-cc29ca2cdad2}">
+        <p14:section name="Findings" id="{886c1022-0fd9-a97f-15d2-dff0c62a158b}">
           <p14:sldIdLst>
             <p14:sldId id="262"/>
             <p14:sldId id="263"/>
@@ -145,7 +145,7 @@
             <p14:sldId id="265"/>
           </p14:sldIdLst>
         </p14:section>
-        <p14:section name="Takeaways" id="{f2c16401-5903-1fac-cd8a-ade79b585bc6}">
+        <p14:section name="Takeaways" id="{3a764bb2-4556-97e5-277b-aff14ede60e5}">
           <p14:sldIdLst>
             <p14:sldId id="266"/>
             <p14:sldId id="267"/>
@@ -10703,11 +10703,11 @@
             </a:avLst>
           </a:prstGeom>
           <a:solidFill>
-            <a:srgbClr val="F2F5F3"/>
+            <a:srgbClr val="F2C14E"/>
           </a:solidFill>
-          <a:ln w="19050">
+          <a:ln w="12700">
             <a:solidFill>
-              <a:srgbClr val="F2F5F3"/>
+              <a:srgbClr val="F2C14E"/>
             </a:solidFill>
             <a:prstDash val="solid"/>
           </a:ln>
@@ -10779,7 +10779,7 @@
             <a:r>
               <a:rPr lang="en-US" sz="1200" dirty="0">
                 <a:solidFill>
-                  <a:srgbClr val="5F6B66"/>
+                  <a:srgbClr val="5C4A12"/>
                 </a:solidFill>
                 <a:latin typeface="Inter" pitchFamily="34" charset="0"/>
                 <a:ea typeface="Inter" pitchFamily="34" charset="-122"/>
@@ -10808,9 +10808,9 @@
             </a:avLst>
           </a:prstGeom>
           <a:solidFill>
-            <a:srgbClr val="FFFFFF"/>
+            <a:srgbClr val="1E2A27"/>
           </a:solidFill>
-          <a:ln w="19050">
+          <a:ln w="12700">
             <a:solidFill>
               <a:srgbClr val="1E2A27"/>
             </a:solidFill>
@@ -10845,7 +10845,7 @@
             <a:r>
               <a:rPr lang="en-US" sz="1800" b="1" dirty="0">
                 <a:solidFill>
-                  <a:srgbClr val="1F1E1C"/>
+                  <a:srgbClr val="FFFFFF"/>
                 </a:solidFill>
                 <a:latin typeface="Inter" pitchFamily="34" charset="0"/>
                 <a:ea typeface="Inter" pitchFamily="34" charset="-122"/>
@@ -10884,7 +10884,7 @@
             <a:r>
               <a:rPr lang="en-US" sz="1200" dirty="0">
                 <a:solidFill>
-                  <a:srgbClr val="5F6B66"/>
+                  <a:srgbClr val="B9C4BF"/>
                 </a:solidFill>
                 <a:latin typeface="Inter" pitchFamily="34" charset="0"/>
                 <a:ea typeface="Inter" pitchFamily="34" charset="-122"/>
@@ -10913,9 +10913,9 @@
             </a:avLst>
           </a:prstGeom>
           <a:solidFill>
-            <a:srgbClr val="FFFFFF"/>
+            <a:srgbClr val="1E2A27"/>
           </a:solidFill>
-          <a:ln w="19050">
+          <a:ln w="12700">
             <a:solidFill>
               <a:srgbClr val="1E2A27"/>
             </a:solidFill>
@@ -10950,7 +10950,7 @@
             <a:r>
               <a:rPr lang="en-US" sz="1800" b="1" dirty="0">
                 <a:solidFill>
-                  <a:srgbClr val="1F1E1C"/>
+                  <a:srgbClr val="FFFFFF"/>
                 </a:solidFill>
                 <a:latin typeface="Inter" pitchFamily="34" charset="0"/>
                 <a:ea typeface="Inter" pitchFamily="34" charset="-122"/>
@@ -10989,7 +10989,7 @@
             <a:r>
               <a:rPr lang="en-US" sz="1200" dirty="0">
                 <a:solidFill>
-                  <a:srgbClr val="5F6B66"/>
+                  <a:srgbClr val="B9C4BF"/>
                 </a:solidFill>
                 <a:latin typeface="Inter" pitchFamily="34" charset="0"/>
                 <a:ea typeface="Inter" pitchFamily="34" charset="-122"/>
@@ -11018,9 +11018,9 @@
             </a:avLst>
           </a:prstGeom>
           <a:solidFill>
-            <a:srgbClr val="FFFFFF"/>
+            <a:srgbClr val="1E2A27"/>
           </a:solidFill>
-          <a:ln w="19050">
+          <a:ln w="12700">
             <a:solidFill>
               <a:srgbClr val="1E2A27"/>
             </a:solidFill>
@@ -11055,7 +11055,7 @@
             <a:r>
               <a:rPr lang="en-US" sz="1800" b="1" dirty="0">
                 <a:solidFill>
-                  <a:srgbClr val="1F1E1C"/>
+                  <a:srgbClr val="FFFFFF"/>
                 </a:solidFill>
                 <a:latin typeface="Inter" pitchFamily="34" charset="0"/>
                 <a:ea typeface="Inter" pitchFamily="34" charset="-122"/>
@@ -11094,7 +11094,7 @@
             <a:r>
               <a:rPr lang="en-US" sz="1200" dirty="0">
                 <a:solidFill>
-                  <a:srgbClr val="5F6B66"/>
+                  <a:srgbClr val="B9C4BF"/>
                 </a:solidFill>
                 <a:latin typeface="Inter" pitchFamily="34" charset="0"/>
                 <a:ea typeface="Inter" pitchFamily="34" charset="-122"/>
@@ -11123,11 +11123,11 @@
             </a:avLst>
           </a:prstGeom>
           <a:solidFill>
-            <a:srgbClr val="F2F5F3"/>
+            <a:srgbClr val="DCE5E1"/>
           </a:solidFill>
-          <a:ln w="19050">
+          <a:ln w="12700">
             <a:solidFill>
-              <a:srgbClr val="F2F5F3"/>
+              <a:srgbClr val="DCE5E1"/>
             </a:solidFill>
             <a:prstDash val="solid"/>
           </a:ln>
@@ -11403,7 +11403,331 @@
       </p:sp>
       <p:sp>
         <p:nvSpPr>
-          <p:cNvPr id="26" name="iso-off"/>
+          <p:cNvPr id="26" name="Shape 24"/>
+          <p:cNvSpPr/>
+          <p:nvPr/>
+        </p:nvSpPr>
+        <p:spPr>
+          <a:xfrm>
+            <a:off x="548640" y="1481328"/>
+            <a:ext cx="182880" cy="182880"/>
+          </a:xfrm>
+          <a:prstGeom prst="roundRect">
+            <a:avLst>
+              <a:gd name="adj" fmla="val 20000"/>
+            </a:avLst>
+          </a:prstGeom>
+          <a:solidFill>
+            <a:srgbClr val="F2C14E"/>
+          </a:solidFill>
+          <a:ln w="12700">
+            <a:solidFill>
+              <a:srgbClr val="F2C14E"/>
+            </a:solidFill>
+            <a:prstDash val="solid"/>
+          </a:ln>
+        </p:spPr>
+      </p:sp>
+      <p:sp>
+        <p:nvSpPr>
+          <p:cNvPr id="27" name="Text 25"/>
+          <p:cNvSpPr txBox="1"/>
+          <p:nvPr/>
+        </p:nvSpPr>
+        <p:spPr>
+          <a:xfrm>
+            <a:off x="822960" y="1444752"/>
+            <a:ext cx="1097280" cy="256032"/>
+          </a:xfrm>
+          <a:prstGeom prst="rect">
+            <a:avLst/>
+          </a:prstGeom>
+          <a:noFill/>
+          <a:ln/>
+        </p:spPr>
+        <p:txBody>
+          <a:bodyPr wrap="square" lIns="0" tIns="0" rIns="0" bIns="0" rtlCol="0" anchor="ctr"/>
+          <a:lstStyle/>
+          <a:p>
+            <a:pPr indent="0" marL="0">
+              <a:buNone/>
+            </a:pPr>
+            <a:r>
+              <a:rPr lang="en-US" sz="1100" dirty="0">
+                <a:solidFill>
+                  <a:srgbClr val="5F6B66"/>
+                </a:solidFill>
+                <a:latin typeface="Inter" pitchFamily="34" charset="0"/>
+                <a:ea typeface="Inter" pitchFamily="34" charset="-122"/>
+                <a:cs typeface="Inter" pitchFamily="34" charset="-120"/>
+              </a:rPr>
+              <a:t>Untrusted file</a:t>
+            </a:r>
+            <a:endParaRPr lang="en-US" sz="1100" dirty="0"/>
+          </a:p>
+        </p:txBody>
+      </p:sp>
+      <p:sp>
+        <p:nvSpPr>
+          <p:cNvPr id="28" name="Shape 26"/>
+          <p:cNvSpPr/>
+          <p:nvPr/>
+        </p:nvSpPr>
+        <p:spPr>
+          <a:xfrm>
+            <a:off x="2194560" y="1481328"/>
+            <a:ext cx="182880" cy="182880"/>
+          </a:xfrm>
+          <a:prstGeom prst="roundRect">
+            <a:avLst>
+              <a:gd name="adj" fmla="val 20000"/>
+            </a:avLst>
+          </a:prstGeom>
+          <a:solidFill>
+            <a:srgbClr val="1E2A27"/>
+          </a:solidFill>
+          <a:ln w="12700">
+            <a:solidFill>
+              <a:srgbClr val="1E2A27"/>
+            </a:solidFill>
+            <a:prstDash val="solid"/>
+          </a:ln>
+        </p:spPr>
+      </p:sp>
+      <p:sp>
+        <p:nvSpPr>
+          <p:cNvPr id="29" name="Text 27"/>
+          <p:cNvSpPr txBox="1"/>
+          <p:nvPr/>
+        </p:nvSpPr>
+        <p:spPr>
+          <a:xfrm>
+            <a:off x="2468880" y="1444752"/>
+            <a:ext cx="731520" cy="256032"/>
+          </a:xfrm>
+          <a:prstGeom prst="rect">
+            <a:avLst/>
+          </a:prstGeom>
+          <a:noFill/>
+          <a:ln/>
+        </p:spPr>
+        <p:txBody>
+          <a:bodyPr wrap="square" lIns="0" tIns="0" rIns="0" bIns="0" rtlCol="0" anchor="ctr"/>
+          <a:lstStyle/>
+          <a:p>
+            <a:pPr indent="0" marL="0">
+              <a:buNone/>
+            </a:pPr>
+            <a:r>
+              <a:rPr lang="en-US" sz="1100" dirty="0">
+                <a:solidFill>
+                  <a:srgbClr val="5F6B66"/>
+                </a:solidFill>
+                <a:latin typeface="Inter" pitchFamily="34" charset="0"/>
+                <a:ea typeface="Inter" pitchFamily="34" charset="-122"/>
+                <a:cs typeface="Inter" pitchFamily="34" charset="-120"/>
+              </a:rPr>
+              <a:t>AI agent</a:t>
+            </a:r>
+            <a:endParaRPr lang="en-US" sz="1100" dirty="0"/>
+          </a:p>
+        </p:txBody>
+      </p:sp>
+      <p:sp>
+        <p:nvSpPr>
+          <p:cNvPr id="30" name="Shape 28"/>
+          <p:cNvSpPr/>
+          <p:nvPr/>
+        </p:nvSpPr>
+        <p:spPr>
+          <a:xfrm>
+            <a:off x="3474720" y="1481328"/>
+            <a:ext cx="182880" cy="182880"/>
+          </a:xfrm>
+          <a:prstGeom prst="roundRect">
+            <a:avLst>
+              <a:gd name="adj" fmla="val 20000"/>
+            </a:avLst>
+          </a:prstGeom>
+          <a:solidFill>
+            <a:srgbClr val="DCE5E1"/>
+          </a:solidFill>
+          <a:ln w="12700">
+            <a:solidFill>
+              <a:srgbClr val="DCE5E1"/>
+            </a:solidFill>
+            <a:prstDash val="solid"/>
+          </a:ln>
+        </p:spPr>
+      </p:sp>
+      <p:sp>
+        <p:nvSpPr>
+          <p:cNvPr id="31" name="Text 29"/>
+          <p:cNvSpPr txBox="1"/>
+          <p:nvPr/>
+        </p:nvSpPr>
+        <p:spPr>
+          <a:xfrm>
+            <a:off x="3749040" y="1444752"/>
+            <a:ext cx="960120" cy="256032"/>
+          </a:xfrm>
+          <a:prstGeom prst="rect">
+            <a:avLst/>
+          </a:prstGeom>
+          <a:noFill/>
+          <a:ln/>
+        </p:spPr>
+        <p:txBody>
+          <a:bodyPr wrap="square" lIns="0" tIns="0" rIns="0" bIns="0" rtlCol="0" anchor="ctr"/>
+          <a:lstStyle/>
+          <a:p>
+            <a:pPr indent="0" marL="0">
+              <a:buNone/>
+            </a:pPr>
+            <a:r>
+              <a:rPr lang="en-US" sz="1100" dirty="0">
+                <a:solidFill>
+                  <a:srgbClr val="5F6B66"/>
+                </a:solidFill>
+                <a:latin typeface="Inter" pitchFamily="34" charset="0"/>
+                <a:ea typeface="Inter" pitchFamily="34" charset="-122"/>
+                <a:cs typeface="Inter" pitchFamily="34" charset="-120"/>
+              </a:rPr>
+              <a:t>Record kept</a:t>
+            </a:r>
+            <a:endParaRPr lang="en-US" sz="1100" dirty="0"/>
+          </a:p>
+        </p:txBody>
+      </p:sp>
+      <p:sp>
+        <p:nvSpPr>
+          <p:cNvPr id="32" name="Shape 30"/>
+          <p:cNvSpPr/>
+          <p:nvPr/>
+        </p:nvSpPr>
+        <p:spPr>
+          <a:xfrm>
+            <a:off x="4983480" y="1572768"/>
+            <a:ext cx="411480" cy="914"/>
+          </a:xfrm>
+          <a:prstGeom prst="line">
+            <a:avLst/>
+          </a:prstGeom>
+          <a:noFill/>
+          <a:ln w="25400">
+            <a:solidFill>
+              <a:srgbClr val="5F6B66"/>
+            </a:solidFill>
+            <a:prstDash val="solid"/>
+            <a:tailEnd type="triangle"/>
+          </a:ln>
+        </p:spPr>
+      </p:sp>
+      <p:sp>
+        <p:nvSpPr>
+          <p:cNvPr id="33" name="Text 31"/>
+          <p:cNvSpPr txBox="1"/>
+          <p:nvPr/>
+        </p:nvSpPr>
+        <p:spPr>
+          <a:xfrm>
+            <a:off x="5486400" y="1444752"/>
+            <a:ext cx="1508760" cy="256032"/>
+          </a:xfrm>
+          <a:prstGeom prst="rect">
+            <a:avLst/>
+          </a:prstGeom>
+          <a:noFill/>
+          <a:ln/>
+        </p:spPr>
+        <p:txBody>
+          <a:bodyPr wrap="square" lIns="0" tIns="0" rIns="0" bIns="0" rtlCol="0" anchor="ctr"/>
+          <a:lstStyle/>
+          <a:p>
+            <a:pPr indent="0" marL="0">
+              <a:buNone/>
+            </a:pPr>
+            <a:r>
+              <a:rPr lang="en-US" sz="1100" dirty="0">
+                <a:solidFill>
+                  <a:srgbClr val="5F6B66"/>
+                </a:solidFill>
+                <a:latin typeface="Inter" pitchFamily="34" charset="0"/>
+                <a:ea typeface="Inter" pitchFamily="34" charset="-122"/>
+                <a:cs typeface="Inter" pitchFamily="34" charset="-120"/>
+              </a:rPr>
+              <a:t>Passes its output on</a:t>
+            </a:r>
+            <a:endParaRPr lang="en-US" sz="1100" dirty="0"/>
+          </a:p>
+        </p:txBody>
+      </p:sp>
+      <p:sp>
+        <p:nvSpPr>
+          <p:cNvPr id="34" name="Shape 32"/>
+          <p:cNvSpPr/>
+          <p:nvPr/>
+        </p:nvSpPr>
+        <p:spPr>
+          <a:xfrm>
+            <a:off x="7269480" y="1572768"/>
+            <a:ext cx="411480" cy="914"/>
+          </a:xfrm>
+          <a:prstGeom prst="line">
+            <a:avLst/>
+          </a:prstGeom>
+          <a:noFill/>
+          <a:ln w="25400">
+            <a:solidFill>
+              <a:srgbClr val="EB6834"/>
+            </a:solidFill>
+            <a:prstDash val="dash"/>
+            <a:tailEnd type="triangle"/>
+          </a:ln>
+        </p:spPr>
+      </p:sp>
+      <p:sp>
+        <p:nvSpPr>
+          <p:cNvPr id="35" name="Text 33"/>
+          <p:cNvSpPr txBox="1"/>
+          <p:nvPr/>
+        </p:nvSpPr>
+        <p:spPr>
+          <a:xfrm>
+            <a:off x="7772400" y="1444752"/>
+            <a:ext cx="2377440" cy="256032"/>
+          </a:xfrm>
+          <a:prstGeom prst="rect">
+            <a:avLst/>
+          </a:prstGeom>
+          <a:noFill/>
+          <a:ln/>
+        </p:spPr>
+        <p:txBody>
+          <a:bodyPr wrap="square" lIns="0" tIns="0" rIns="0" bIns="0" rtlCol="0" anchor="ctr"/>
+          <a:lstStyle/>
+          <a:p>
+            <a:pPr indent="0" marL="0">
+              <a:buNone/>
+            </a:pPr>
+            <a:r>
+              <a:rPr lang="en-US" sz="1100" dirty="0">
+                <a:solidFill>
+                  <a:srgbClr val="5F6B66"/>
+                </a:solidFill>
+                <a:latin typeface="Inter" pitchFamily="34" charset="0"/>
+                <a:ea typeface="Inter" pitchFamily="34" charset="-122"/>
+                <a:cs typeface="Inter" pitchFamily="34" charset="-120"/>
+              </a:rPr>
+              <a:t>Raw file, only with isolation off</a:t>
+            </a:r>
+            <a:endParaRPr lang="en-US" sz="1100" dirty="0"/>
+          </a:p>
+        </p:txBody>
+      </p:sp>
+      <p:sp>
+        <p:nvSpPr>
+          <p:cNvPr id="36" name="iso-off"/>
           <p:cNvSpPr/>
           <p:nvPr/>
         </p:nvSpPr>
@@ -11420,17 +11744,17 @@
           <a:solidFill>
             <a:srgbClr val="FDE7DC"/>
           </a:solidFill>
-          <a:ln w="12700">
+          <a:ln w="19050">
             <a:solidFill>
-              <a:srgbClr val="FDE7DC"/>
+              <a:srgbClr val="EB6834"/>
             </a:solidFill>
-            <a:prstDash val="solid"/>
+            <a:prstDash val="dash"/>
           </a:ln>
         </p:spPr>
       </p:sp>
       <p:sp>
         <p:nvSpPr>
-          <p:cNvPr id="27" name="Text 25"/>
+          <p:cNvPr id="37" name="Text 35"/>
           <p:cNvSpPr txBox="1"/>
           <p:nvPr/>
         </p:nvSpPr>
@@ -11469,7 +11793,7 @@
       </p:sp>
       <p:sp>
         <p:nvSpPr>
-          <p:cNvPr id="28" name="Text 26"/>
+          <p:cNvPr id="38" name="Text 36"/>
           <p:cNvSpPr txBox="1"/>
           <p:nvPr/>
         </p:nvSpPr>
@@ -11508,7 +11832,7 @@
       </p:sp>
       <p:sp>
         <p:nvSpPr>
-          <p:cNvPr id="29" name="iso-on"/>
+          <p:cNvPr id="39" name="iso-on"/>
           <p:cNvSpPr/>
           <p:nvPr/>
         </p:nvSpPr>
@@ -11535,7 +11859,7 @@
       </p:sp>
       <p:sp>
         <p:nvSpPr>
-          <p:cNvPr id="30" name="Text 28"/>
+          <p:cNvPr id="40" name="Text 38"/>
           <p:cNvSpPr txBox="1"/>
           <p:nvPr/>
         </p:nvSpPr>
@@ -11574,7 +11898,7 @@
       </p:sp>
       <p:sp>
         <p:nvSpPr>
-          <p:cNvPr id="31" name="Text 29"/>
+          <p:cNvPr id="41" name="Text 39"/>
           <p:cNvSpPr txBox="1"/>
           <p:nvPr/>
         </p:nvSpPr>
@@ -11613,7 +11937,7 @@
       </p:sp>
       <p:sp>
         <p:nvSpPr>
-          <p:cNvPr id="32" name="Slide Number Placeholder 0"/>
+          <p:cNvPr id="42" name="Slide Number Placeholder 0"/>
           <p:cNvSpPr>
             <a:spLocks noGrp="1"/>
           </p:cNvSpPr>

</xml_diff>

<commit_message>
Slides: relabel the flowchart's dashed arrow ('Isolation off, so raw files passed along')
</commit_message>
<xml_diff>
--- a/presentation/eduinject-slides.pptx
+++ b/presentation/eduinject-slides.pptx
@@ -119,25 +119,25 @@
   <p:extLst>
     <p:ext uri="{521415D9-36F7-43E2-AB2F-B90AF26B5E84}">
       <p14:sectionLst xmlns:p14="http://schemas.microsoft.com/office/powerpoint/2010/main">
-        <p14:section name="Opening" id="{5fcada38-8bf3-cc44-98a9-e3fe2336e188}">
+        <p14:section name="Opening" id="{44dd8368-e903-8847-0d5a-606b393e580c}">
           <p14:sldIdLst>
             <p14:sldId id="256"/>
           </p14:sldIdLst>
         </p14:section>
-        <p14:section name="Problem" id="{4370baea-beb4-bb79-2f08-a2867e548390}">
+        <p14:section name="Problem" id="{96f83d48-dbfa-29a7-414c-7ff4411611ee}">
           <p14:sldIdLst>
             <p14:sldId id="257"/>
             <p14:sldId id="258"/>
           </p14:sldIdLst>
         </p14:section>
-        <p14:section name="Method" id="{599b3d3b-119b-575c-1d5a-0f134348c76f}">
+        <p14:section name="Method" id="{83794408-5ed8-7469-dc66-db95c0b33291}">
           <p14:sldIdLst>
             <p14:sldId id="259"/>
             <p14:sldId id="260"/>
             <p14:sldId id="261"/>
           </p14:sldIdLst>
         </p14:section>
-        <p14:section name="Findings" id="{1aeeb63e-106e-a618-c92c-a7ef1256e502}">
+        <p14:section name="Findings" id="{ae8d80ea-61ad-1e60-3baf-00258c171ed4}">
           <p14:sldIdLst>
             <p14:sldId id="262"/>
             <p14:sldId id="263"/>
@@ -145,7 +145,7 @@
             <p14:sldId id="265"/>
           </p14:sldIdLst>
         </p14:section>
-        <p14:section name="Takeaways" id="{1f8f6387-ac0a-2bdd-ddb6-abbf1ef89473}">
+        <p14:section name="Takeaways" id="{d9cf6a9b-e9bf-7e76-4fb4-3474f161adee}">
           <p14:sldIdLst>
             <p14:sldId id="266"/>
             <p14:sldId id="267"/>
@@ -6286,7 +6286,7 @@
         <p:spPr>
           <a:xfrm>
             <a:off x="822960" y="466344"/>
-            <a:ext cx="1051560" cy="256032"/>
+            <a:ext cx="960120" cy="256032"/>
           </a:xfrm>
           <a:prstGeom prst="rect">
             <a:avLst/>
@@ -6295,7 +6295,7 @@
           <a:ln/>
         </p:spPr>
         <p:txBody>
-          <a:bodyPr wrap="square" lIns="0" tIns="0" rIns="0" bIns="0" rtlCol="0" anchor="ctr"/>
+          <a:bodyPr wrap="none" lIns="0" tIns="0" rIns="0" bIns="0" rtlCol="0" anchor="ctr"/>
           <a:lstStyle/>
           <a:p>
             <a:pPr indent="0" marL="0">
@@ -6324,7 +6324,7 @@
         </p:nvSpPr>
         <p:spPr>
           <a:xfrm>
-            <a:off x="2103120" y="502920"/>
+            <a:off x="1929384" y="502920"/>
             <a:ext cx="182880" cy="182880"/>
           </a:xfrm>
           <a:prstGeom prst="roundRect">
@@ -6351,8 +6351,8 @@
         </p:nvSpPr>
         <p:spPr>
           <a:xfrm>
-            <a:off x="2377440" y="466344"/>
-            <a:ext cx="685800" cy="256032"/>
+            <a:off x="2203704" y="466344"/>
+            <a:ext cx="566928" cy="256032"/>
           </a:xfrm>
           <a:prstGeom prst="rect">
             <a:avLst/>
@@ -6361,7 +6361,7 @@
           <a:ln/>
         </p:spPr>
         <p:txBody>
-          <a:bodyPr wrap="square" lIns="0" tIns="0" rIns="0" bIns="0" rtlCol="0" anchor="ctr"/>
+          <a:bodyPr wrap="none" lIns="0" tIns="0" rIns="0" bIns="0" rtlCol="0" anchor="ctr"/>
           <a:lstStyle/>
           <a:p>
             <a:pPr indent="0" marL="0">
@@ -6390,7 +6390,7 @@
         </p:nvSpPr>
         <p:spPr>
           <a:xfrm>
-            <a:off x="3291840" y="502920"/>
+            <a:off x="2916936" y="502920"/>
             <a:ext cx="182880" cy="182880"/>
           </a:xfrm>
           <a:prstGeom prst="roundRect">
@@ -6417,8 +6417,8 @@
         </p:nvSpPr>
         <p:spPr>
           <a:xfrm>
-            <a:off x="3566160" y="466344"/>
-            <a:ext cx="1051560" cy="256032"/>
+            <a:off x="3191256" y="466344"/>
+            <a:ext cx="1005840" cy="256032"/>
           </a:xfrm>
           <a:prstGeom prst="rect">
             <a:avLst/>
@@ -6427,7 +6427,7 @@
           <a:ln/>
         </p:spPr>
         <p:txBody>
-          <a:bodyPr wrap="square" lIns="0" tIns="0" rIns="0" bIns="0" rtlCol="0" anchor="ctr"/>
+          <a:bodyPr wrap="none" lIns="0" tIns="0" rIns="0" bIns="0" rtlCol="0" anchor="ctr"/>
           <a:lstStyle/>
           <a:p>
             <a:pPr indent="0" marL="0">
@@ -6456,7 +6456,7 @@
         </p:nvSpPr>
         <p:spPr>
           <a:xfrm>
-            <a:off x="4846320" y="502920"/>
+            <a:off x="4343400" y="502920"/>
             <a:ext cx="182880" cy="182880"/>
           </a:xfrm>
           <a:prstGeom prst="roundRect">
@@ -6483,8 +6483,8 @@
         </p:nvSpPr>
         <p:spPr>
           <a:xfrm>
-            <a:off x="5120640" y="466344"/>
-            <a:ext cx="914400" cy="256032"/>
+            <a:off x="4617720" y="466344"/>
+            <a:ext cx="804672" cy="256032"/>
           </a:xfrm>
           <a:prstGeom prst="rect">
             <a:avLst/>
@@ -6493,7 +6493,7 @@
           <a:ln/>
         </p:spPr>
         <p:txBody>
-          <a:bodyPr wrap="square" lIns="0" tIns="0" rIns="0" bIns="0" rtlCol="0" anchor="ctr"/>
+          <a:bodyPr wrap="none" lIns="0" tIns="0" rIns="0" bIns="0" rtlCol="0" anchor="ctr"/>
           <a:lstStyle/>
           <a:p>
             <a:pPr indent="0" marL="0">
@@ -6522,7 +6522,7 @@
         </p:nvSpPr>
         <p:spPr>
           <a:xfrm>
-            <a:off x="6263640" y="502920"/>
+            <a:off x="5568696" y="502920"/>
             <a:ext cx="182880" cy="182880"/>
           </a:xfrm>
           <a:prstGeom prst="roundRect">
@@ -6549,8 +6549,8 @@
         </p:nvSpPr>
         <p:spPr>
           <a:xfrm>
-            <a:off x="6537960" y="466344"/>
-            <a:ext cx="548640" cy="256032"/>
+            <a:off x="5843016" y="466344"/>
+            <a:ext cx="457200" cy="256032"/>
           </a:xfrm>
           <a:prstGeom prst="rect">
             <a:avLst/>
@@ -6559,7 +6559,7 @@
           <a:ln/>
         </p:spPr>
         <p:txBody>
-          <a:bodyPr wrap="square" lIns="0" tIns="0" rIns="0" bIns="0" rtlCol="0" anchor="ctr"/>
+          <a:bodyPr wrap="none" lIns="0" tIns="0" rIns="0" bIns="0" rtlCol="0" anchor="ctr"/>
           <a:lstStyle/>
           <a:p>
             <a:pPr indent="0" marL="0">
@@ -6588,7 +6588,7 @@
         </p:nvSpPr>
         <p:spPr>
           <a:xfrm>
-            <a:off x="7315200" y="594360"/>
+            <a:off x="6446520" y="594360"/>
             <a:ext cx="365760" cy="914"/>
           </a:xfrm>
           <a:prstGeom prst="line">
@@ -6612,8 +6612,8 @@
         </p:nvSpPr>
         <p:spPr>
           <a:xfrm>
-            <a:off x="7772400" y="466344"/>
-            <a:ext cx="1188720" cy="256032"/>
+            <a:off x="6903720" y="466344"/>
+            <a:ext cx="1143000" cy="256032"/>
           </a:xfrm>
           <a:prstGeom prst="rect">
             <a:avLst/>
@@ -6622,7 +6622,7 @@
           <a:ln/>
         </p:spPr>
         <p:txBody>
-          <a:bodyPr wrap="square" lIns="0" tIns="0" rIns="0" bIns="0" rtlCol="0" anchor="ctr"/>
+          <a:bodyPr wrap="none" lIns="0" tIns="0" rIns="0" bIns="0" rtlCol="0" anchor="ctr"/>
           <a:lstStyle/>
           <a:p>
             <a:pPr indent="0" marL="0">
@@ -6651,7 +6651,7 @@
         </p:nvSpPr>
         <p:spPr>
           <a:xfrm>
-            <a:off x="9189720" y="594360"/>
+            <a:off x="8193024" y="594360"/>
             <a:ext cx="365760" cy="914"/>
           </a:xfrm>
           <a:prstGeom prst="line">
@@ -6675,8 +6675,8 @@
         </p:nvSpPr>
         <p:spPr>
           <a:xfrm>
-            <a:off x="9646920" y="466344"/>
-            <a:ext cx="2011680" cy="256032"/>
+            <a:off x="8650224" y="466344"/>
+            <a:ext cx="2651760" cy="256032"/>
           </a:xfrm>
           <a:prstGeom prst="rect">
             <a:avLst/>
@@ -6685,7 +6685,7 @@
           <a:ln/>
         </p:spPr>
         <p:txBody>
-          <a:bodyPr wrap="square" lIns="0" tIns="0" rIns="0" bIns="0" rtlCol="0" anchor="ctr"/>
+          <a:bodyPr wrap="none" lIns="0" tIns="0" rIns="0" bIns="0" rtlCol="0" anchor="ctr"/>
           <a:lstStyle/>
           <a:p>
             <a:pPr indent="0" marL="0">
@@ -6700,7 +6700,7 @@
                 <a:ea typeface="Inter" pitchFamily="34" charset="-122"/>
                 <a:cs typeface="Inter" pitchFamily="34" charset="-120"/>
               </a:rPr>
-              <a:t>Raw text, isolation off only</a:t>
+              <a:t>Isolation off, so raw files passed along</a:t>
             </a:r>
             <a:endParaRPr lang="en-US" sz="1100" dirty="0"/>
           </a:p>

</xml_diff>

<commit_message>
Slides: drop the isolation cards on the pipeline slide; relabel the dashed line
</commit_message>
<xml_diff>
--- a/presentation/eduinject-slides.pptx
+++ b/presentation/eduinject-slides.pptx
@@ -119,25 +119,25 @@
   <p:extLst>
     <p:ext uri="{521415D9-36F7-43E2-AB2F-B90AF26B5E84}">
       <p14:sectionLst xmlns:p14="http://schemas.microsoft.com/office/powerpoint/2010/main">
-        <p14:section name="Opening" id="{44dd8368-e903-8847-0d5a-606b393e580c}">
+        <p14:section name="Opening" id="{5dd2bbbb-02c3-96fc-b009-9ba8bb0ffbf9}">
           <p14:sldIdLst>
             <p14:sldId id="256"/>
           </p14:sldIdLst>
         </p14:section>
-        <p14:section name="Problem" id="{96f83d48-dbfa-29a7-414c-7ff4411611ee}">
+        <p14:section name="Problem" id="{c4153408-1c6b-4b02-1a17-9610c6ee88d7}">
           <p14:sldIdLst>
             <p14:sldId id="257"/>
             <p14:sldId id="258"/>
           </p14:sldIdLst>
         </p14:section>
-        <p14:section name="Method" id="{83794408-5ed8-7469-dc66-db95c0b33291}">
+        <p14:section name="Method" id="{bf0cf259-0873-672e-f9bf-6941f40b5c83}">
           <p14:sldIdLst>
             <p14:sldId id="259"/>
             <p14:sldId id="260"/>
             <p14:sldId id="261"/>
           </p14:sldIdLst>
         </p14:section>
-        <p14:section name="Findings" id="{ae8d80ea-61ad-1e60-3baf-00258c171ed4}">
+        <p14:section name="Findings" id="{ed86ed4c-2314-89d9-248a-305c07bc3177}">
           <p14:sldIdLst>
             <p14:sldId id="262"/>
             <p14:sldId id="263"/>
@@ -145,7 +145,7 @@
             <p14:sldId id="265"/>
           </p14:sldIdLst>
         </p14:section>
-        <p14:section name="Takeaways" id="{d9cf6a9b-e9bf-7e76-4fb4-3474f161adee}">
+        <p14:section name="Takeaways" id="{29275ee1-a3a6-133c-3208-cb2c8ec494a3}">
           <p14:sldIdLst>
             <p14:sldId id="266"/>
             <p14:sldId id="267"/>
@@ -6286,7 +6286,7 @@
         <p:spPr>
           <a:xfrm>
             <a:off x="822960" y="466344"/>
-            <a:ext cx="960120" cy="256032"/>
+            <a:ext cx="1051560" cy="256032"/>
           </a:xfrm>
           <a:prstGeom prst="rect">
             <a:avLst/>
@@ -6295,7 +6295,7 @@
           <a:ln/>
         </p:spPr>
         <p:txBody>
-          <a:bodyPr wrap="none" lIns="0" tIns="0" rIns="0" bIns="0" rtlCol="0" anchor="ctr"/>
+          <a:bodyPr wrap="square" lIns="0" tIns="0" rIns="0" bIns="0" rtlCol="0" anchor="ctr"/>
           <a:lstStyle/>
           <a:p>
             <a:pPr indent="0" marL="0">
@@ -6324,7 +6324,7 @@
         </p:nvSpPr>
         <p:spPr>
           <a:xfrm>
-            <a:off x="1929384" y="502920"/>
+            <a:off x="2103120" y="502920"/>
             <a:ext cx="182880" cy="182880"/>
           </a:xfrm>
           <a:prstGeom prst="roundRect">
@@ -6351,8 +6351,8 @@
         </p:nvSpPr>
         <p:spPr>
           <a:xfrm>
-            <a:off x="2203704" y="466344"/>
-            <a:ext cx="566928" cy="256032"/>
+            <a:off x="2377440" y="466344"/>
+            <a:ext cx="685800" cy="256032"/>
           </a:xfrm>
           <a:prstGeom prst="rect">
             <a:avLst/>
@@ -6361,7 +6361,7 @@
           <a:ln/>
         </p:spPr>
         <p:txBody>
-          <a:bodyPr wrap="none" lIns="0" tIns="0" rIns="0" bIns="0" rtlCol="0" anchor="ctr"/>
+          <a:bodyPr wrap="square" lIns="0" tIns="0" rIns="0" bIns="0" rtlCol="0" anchor="ctr"/>
           <a:lstStyle/>
           <a:p>
             <a:pPr indent="0" marL="0">
@@ -6390,7 +6390,7 @@
         </p:nvSpPr>
         <p:spPr>
           <a:xfrm>
-            <a:off x="2916936" y="502920"/>
+            <a:off x="3291840" y="502920"/>
             <a:ext cx="182880" cy="182880"/>
           </a:xfrm>
           <a:prstGeom prst="roundRect">
@@ -6417,8 +6417,8 @@
         </p:nvSpPr>
         <p:spPr>
           <a:xfrm>
-            <a:off x="3191256" y="466344"/>
-            <a:ext cx="1005840" cy="256032"/>
+            <a:off x="3566160" y="466344"/>
+            <a:ext cx="1051560" cy="256032"/>
           </a:xfrm>
           <a:prstGeom prst="rect">
             <a:avLst/>
@@ -6427,7 +6427,7 @@
           <a:ln/>
         </p:spPr>
         <p:txBody>
-          <a:bodyPr wrap="none" lIns="0" tIns="0" rIns="0" bIns="0" rtlCol="0" anchor="ctr"/>
+          <a:bodyPr wrap="square" lIns="0" tIns="0" rIns="0" bIns="0" rtlCol="0" anchor="ctr"/>
           <a:lstStyle/>
           <a:p>
             <a:pPr indent="0" marL="0">
@@ -6456,7 +6456,7 @@
         </p:nvSpPr>
         <p:spPr>
           <a:xfrm>
-            <a:off x="4343400" y="502920"/>
+            <a:off x="4846320" y="502920"/>
             <a:ext cx="182880" cy="182880"/>
           </a:xfrm>
           <a:prstGeom prst="roundRect">
@@ -6483,8 +6483,8 @@
         </p:nvSpPr>
         <p:spPr>
           <a:xfrm>
-            <a:off x="4617720" y="466344"/>
-            <a:ext cx="804672" cy="256032"/>
+            <a:off x="5120640" y="466344"/>
+            <a:ext cx="914400" cy="256032"/>
           </a:xfrm>
           <a:prstGeom prst="rect">
             <a:avLst/>
@@ -6493,7 +6493,7 @@
           <a:ln/>
         </p:spPr>
         <p:txBody>
-          <a:bodyPr wrap="none" lIns="0" tIns="0" rIns="0" bIns="0" rtlCol="0" anchor="ctr"/>
+          <a:bodyPr wrap="square" lIns="0" tIns="0" rIns="0" bIns="0" rtlCol="0" anchor="ctr"/>
           <a:lstStyle/>
           <a:p>
             <a:pPr indent="0" marL="0">
@@ -6522,7 +6522,7 @@
         </p:nvSpPr>
         <p:spPr>
           <a:xfrm>
-            <a:off x="5568696" y="502920"/>
+            <a:off x="6263640" y="502920"/>
             <a:ext cx="182880" cy="182880"/>
           </a:xfrm>
           <a:prstGeom prst="roundRect">
@@ -6549,8 +6549,8 @@
         </p:nvSpPr>
         <p:spPr>
           <a:xfrm>
-            <a:off x="5843016" y="466344"/>
-            <a:ext cx="457200" cy="256032"/>
+            <a:off x="6537960" y="466344"/>
+            <a:ext cx="548640" cy="256032"/>
           </a:xfrm>
           <a:prstGeom prst="rect">
             <a:avLst/>
@@ -6559,7 +6559,7 @@
           <a:ln/>
         </p:spPr>
         <p:txBody>
-          <a:bodyPr wrap="none" lIns="0" tIns="0" rIns="0" bIns="0" rtlCol="0" anchor="ctr"/>
+          <a:bodyPr wrap="square" lIns="0" tIns="0" rIns="0" bIns="0" rtlCol="0" anchor="ctr"/>
           <a:lstStyle/>
           <a:p>
             <a:pPr indent="0" marL="0">
@@ -6588,7 +6588,7 @@
         </p:nvSpPr>
         <p:spPr>
           <a:xfrm>
-            <a:off x="6446520" y="594360"/>
+            <a:off x="7315200" y="594360"/>
             <a:ext cx="365760" cy="914"/>
           </a:xfrm>
           <a:prstGeom prst="line">
@@ -6612,8 +6612,8 @@
         </p:nvSpPr>
         <p:spPr>
           <a:xfrm>
-            <a:off x="6903720" y="466344"/>
-            <a:ext cx="1143000" cy="256032"/>
+            <a:off x="7772400" y="466344"/>
+            <a:ext cx="1188720" cy="256032"/>
           </a:xfrm>
           <a:prstGeom prst="rect">
             <a:avLst/>
@@ -6622,7 +6622,7 @@
           <a:ln/>
         </p:spPr>
         <p:txBody>
-          <a:bodyPr wrap="none" lIns="0" tIns="0" rIns="0" bIns="0" rtlCol="0" anchor="ctr"/>
+          <a:bodyPr wrap="square" lIns="0" tIns="0" rIns="0" bIns="0" rtlCol="0" anchor="ctr"/>
           <a:lstStyle/>
           <a:p>
             <a:pPr indent="0" marL="0">
@@ -6651,7 +6651,7 @@
         </p:nvSpPr>
         <p:spPr>
           <a:xfrm>
-            <a:off x="8193024" y="594360"/>
+            <a:off x="9189720" y="594360"/>
             <a:ext cx="365760" cy="914"/>
           </a:xfrm>
           <a:prstGeom prst="line">
@@ -6675,8 +6675,8 @@
         </p:nvSpPr>
         <p:spPr>
           <a:xfrm>
-            <a:off x="8650224" y="466344"/>
-            <a:ext cx="2651760" cy="256032"/>
+            <a:off x="9646920" y="466344"/>
+            <a:ext cx="2011680" cy="256032"/>
           </a:xfrm>
           <a:prstGeom prst="rect">
             <a:avLst/>
@@ -6685,7 +6685,7 @@
           <a:ln/>
         </p:spPr>
         <p:txBody>
-          <a:bodyPr wrap="none" lIns="0" tIns="0" rIns="0" bIns="0" rtlCol="0" anchor="ctr"/>
+          <a:bodyPr wrap="square" lIns="0" tIns="0" rIns="0" bIns="0" rtlCol="0" anchor="ctr"/>
           <a:lstStyle/>
           <a:p>
             <a:pPr indent="0" marL="0">
@@ -6700,7 +6700,7 @@
                 <a:ea typeface="Inter" pitchFamily="34" charset="-122"/>
                 <a:cs typeface="Inter" pitchFamily="34" charset="-120"/>
               </a:rPr>
-              <a:t>Isolation off, so raw files passed along</a:t>
+              <a:t>Raw text, isolation off only</a:t>
             </a:r>
             <a:endParaRPr lang="en-US" sz="1100" dirty="0"/>
           </a:p>
@@ -11425,7 +11425,7 @@
         </p:nvSpPr>
         <p:spPr>
           <a:xfrm>
-            <a:off x="548640" y="2240280"/>
+            <a:off x="548640" y="2743200"/>
             <a:ext cx="1965960" cy="1234440"/>
           </a:xfrm>
           <a:prstGeom prst="roundRect">
@@ -11452,7 +11452,7 @@
         </p:nvSpPr>
         <p:spPr>
           <a:xfrm>
-            <a:off x="548640" y="2514600"/>
+            <a:off x="548640" y="3017520"/>
             <a:ext cx="1965960" cy="411480"/>
           </a:xfrm>
           <a:prstGeom prst="rect">
@@ -11491,7 +11491,7 @@
         </p:nvSpPr>
         <p:spPr>
           <a:xfrm>
-            <a:off x="548640" y="2953512"/>
+            <a:off x="548640" y="3456432"/>
             <a:ext cx="1965960" cy="320040"/>
           </a:xfrm>
           <a:prstGeom prst="rect">
@@ -11530,7 +11530,7 @@
         </p:nvSpPr>
         <p:spPr>
           <a:xfrm>
-            <a:off x="2743200" y="2240280"/>
+            <a:off x="2743200" y="2743200"/>
             <a:ext cx="1965960" cy="1234440"/>
           </a:xfrm>
           <a:prstGeom prst="roundRect">
@@ -11557,7 +11557,7 @@
         </p:nvSpPr>
         <p:spPr>
           <a:xfrm>
-            <a:off x="2743200" y="2514600"/>
+            <a:off x="2743200" y="3017520"/>
             <a:ext cx="1965960" cy="411480"/>
           </a:xfrm>
           <a:prstGeom prst="rect">
@@ -11596,7 +11596,7 @@
         </p:nvSpPr>
         <p:spPr>
           <a:xfrm>
-            <a:off x="2743200" y="2953512"/>
+            <a:off x="2743200" y="3456432"/>
             <a:ext cx="1965960" cy="320040"/>
           </a:xfrm>
           <a:prstGeom prst="rect">
@@ -11635,7 +11635,7 @@
         </p:nvSpPr>
         <p:spPr>
           <a:xfrm>
-            <a:off x="5257800" y="2240280"/>
+            <a:off x="5257800" y="2743200"/>
             <a:ext cx="1965960" cy="1234440"/>
           </a:xfrm>
           <a:prstGeom prst="roundRect">
@@ -11662,7 +11662,7 @@
         </p:nvSpPr>
         <p:spPr>
           <a:xfrm>
-            <a:off x="5257800" y="2514600"/>
+            <a:off x="5257800" y="3017520"/>
             <a:ext cx="1965960" cy="411480"/>
           </a:xfrm>
           <a:prstGeom prst="rect">
@@ -11701,7 +11701,7 @@
         </p:nvSpPr>
         <p:spPr>
           <a:xfrm>
-            <a:off x="5257800" y="2953512"/>
+            <a:off x="5257800" y="3456432"/>
             <a:ext cx="1965960" cy="320040"/>
           </a:xfrm>
           <a:prstGeom prst="rect">
@@ -11740,7 +11740,7 @@
         </p:nvSpPr>
         <p:spPr>
           <a:xfrm>
-            <a:off x="7772400" y="2240280"/>
+            <a:off x="7772400" y="2743200"/>
             <a:ext cx="1965960" cy="1234440"/>
           </a:xfrm>
           <a:prstGeom prst="roundRect">
@@ -11767,7 +11767,7 @@
         </p:nvSpPr>
         <p:spPr>
           <a:xfrm>
-            <a:off x="7772400" y="2514600"/>
+            <a:off x="7772400" y="3017520"/>
             <a:ext cx="1965960" cy="411480"/>
           </a:xfrm>
           <a:prstGeom prst="rect">
@@ -11806,7 +11806,7 @@
         </p:nvSpPr>
         <p:spPr>
           <a:xfrm>
-            <a:off x="7772400" y="2953512"/>
+            <a:off x="7772400" y="3456432"/>
             <a:ext cx="1965960" cy="320040"/>
           </a:xfrm>
           <a:prstGeom prst="rect">
@@ -11845,7 +11845,7 @@
         </p:nvSpPr>
         <p:spPr>
           <a:xfrm>
-            <a:off x="10058400" y="2240280"/>
+            <a:off x="10058400" y="2743200"/>
             <a:ext cx="1581912" cy="1234440"/>
           </a:xfrm>
           <a:prstGeom prst="roundRect">
@@ -11872,7 +11872,7 @@
         </p:nvSpPr>
         <p:spPr>
           <a:xfrm>
-            <a:off x="10058400" y="2514600"/>
+            <a:off x="10058400" y="3017520"/>
             <a:ext cx="1581912" cy="411480"/>
           </a:xfrm>
           <a:prstGeom prst="rect">
@@ -11911,7 +11911,7 @@
         </p:nvSpPr>
         <p:spPr>
           <a:xfrm>
-            <a:off x="10058400" y="2953512"/>
+            <a:off x="10058400" y="3456432"/>
             <a:ext cx="1581912" cy="320040"/>
           </a:xfrm>
           <a:prstGeom prst="rect">
@@ -11950,7 +11950,7 @@
         </p:nvSpPr>
         <p:spPr>
           <a:xfrm>
-            <a:off x="2514600" y="2857500"/>
+            <a:off x="2514600" y="3360420"/>
             <a:ext cx="210312" cy="914"/>
           </a:xfrm>
           <a:prstGeom prst="line">
@@ -11974,7 +11974,7 @@
         </p:nvSpPr>
         <p:spPr>
           <a:xfrm>
-            <a:off x="4709160" y="2857500"/>
+            <a:off x="4709160" y="3360420"/>
             <a:ext cx="530352" cy="914"/>
           </a:xfrm>
           <a:prstGeom prst="line">
@@ -11998,7 +11998,7 @@
         </p:nvSpPr>
         <p:spPr>
           <a:xfrm>
-            <a:off x="7223760" y="2857500"/>
+            <a:off x="7223760" y="3360420"/>
             <a:ext cx="530352" cy="914"/>
           </a:xfrm>
           <a:prstGeom prst="line">
@@ -12022,7 +12022,7 @@
         </p:nvSpPr>
         <p:spPr>
           <a:xfrm>
-            <a:off x="9738360" y="2857500"/>
+            <a:off x="9738360" y="3360420"/>
             <a:ext cx="301752" cy="914"/>
           </a:xfrm>
           <a:prstGeom prst="line">
@@ -12046,7 +12046,7 @@
         </p:nvSpPr>
         <p:spPr>
           <a:xfrm>
-            <a:off x="1531620" y="3474720"/>
+            <a:off x="1531620" y="3977640"/>
             <a:ext cx="914" cy="685800"/>
           </a:xfrm>
           <a:prstGeom prst="line">
@@ -12069,7 +12069,7 @@
         </p:nvSpPr>
         <p:spPr>
           <a:xfrm>
-            <a:off x="1531620" y="4160520"/>
+            <a:off x="1531620" y="4663440"/>
             <a:ext cx="7223760" cy="914"/>
           </a:xfrm>
           <a:prstGeom prst="line">
@@ -12092,7 +12092,7 @@
         </p:nvSpPr>
         <p:spPr>
           <a:xfrm flipV="1">
-            <a:off x="6240780" y="3493008"/>
+            <a:off x="6240780" y="3995928"/>
             <a:ext cx="914" cy="667512"/>
           </a:xfrm>
           <a:prstGeom prst="line">
@@ -12116,7 +12116,7 @@
         </p:nvSpPr>
         <p:spPr>
           <a:xfrm flipV="1">
-            <a:off x="8755380" y="3493008"/>
+            <a:off x="8755380" y="3995928"/>
             <a:ext cx="914" cy="667512"/>
           </a:xfrm>
           <a:prstGeom prst="line">
@@ -12426,7 +12426,7 @@
         <p:spPr>
           <a:xfrm>
             <a:off x="7772400" y="1444752"/>
-            <a:ext cx="2377440" cy="256032"/>
+            <a:ext cx="2834640" cy="256032"/>
           </a:xfrm>
           <a:prstGeom prst="rect">
             <a:avLst/>
@@ -12450,7 +12450,7 @@
                 <a:ea typeface="Inter" pitchFamily="34" charset="-122"/>
                 <a:cs typeface="Inter" pitchFamily="34" charset="-120"/>
               </a:rPr>
-              <a:t>Raw file, only with isolation off</a:t>
+              <a:t>Isolation off, so raw files passed along</a:t>
             </a:r>
             <a:endParaRPr lang="en-US" sz="1100" dirty="0"/>
           </a:p>
@@ -12458,217 +12458,7 @@
       </p:sp>
       <p:sp>
         <p:nvSpPr>
-          <p:cNvPr id="36" name="iso-off"/>
-          <p:cNvSpPr/>
-          <p:nvPr/>
-        </p:nvSpPr>
-        <p:spPr>
-          <a:xfrm>
-            <a:off x="548640" y="4754880"/>
-            <a:ext cx="5394960" cy="1188720"/>
-          </a:xfrm>
-          <a:prstGeom prst="roundRect">
-            <a:avLst>
-              <a:gd name="adj" fmla="val 9231"/>
-            </a:avLst>
-          </a:prstGeom>
-          <a:solidFill>
-            <a:srgbClr val="FDE7DC"/>
-          </a:solidFill>
-          <a:ln w="19050">
-            <a:solidFill>
-              <a:srgbClr val="EB6834"/>
-            </a:solidFill>
-            <a:prstDash val="dash"/>
-          </a:ln>
-        </p:spPr>
-      </p:sp>
-      <p:sp>
-        <p:nvSpPr>
-          <p:cNvPr id="37" name="Text 35"/>
-          <p:cNvSpPr txBox="1"/>
-          <p:nvPr/>
-        </p:nvSpPr>
-        <p:spPr>
-          <a:xfrm>
-            <a:off x="822960" y="4892040"/>
-            <a:ext cx="4846320" cy="365760"/>
-          </a:xfrm>
-          <a:prstGeom prst="rect">
-            <a:avLst/>
-          </a:prstGeom>
-          <a:noFill/>
-          <a:ln/>
-        </p:spPr>
-        <p:txBody>
-          <a:bodyPr wrap="square" lIns="0" tIns="0" rIns="0" bIns="0" rtlCol="0" anchor="ctr"/>
-          <a:lstStyle/>
-          <a:p>
-            <a:pPr indent="0" marL="0">
-              <a:buNone/>
-            </a:pPr>
-            <a:r>
-              <a:rPr lang="en-US" sz="1800" b="1" dirty="0">
-                <a:solidFill>
-                  <a:srgbClr val="B0471E"/>
-                </a:solidFill>
-                <a:latin typeface="Inter" pitchFamily="34" charset="0"/>
-                <a:ea typeface="Inter" pitchFamily="34" charset="-122"/>
-                <a:cs typeface="Inter" pitchFamily="34" charset="-120"/>
-              </a:rPr>
-              <a:t>Isolation off</a:t>
-            </a:r>
-            <a:endParaRPr lang="en-US" sz="1800" dirty="0"/>
-          </a:p>
-        </p:txBody>
-      </p:sp>
-      <p:sp>
-        <p:nvSpPr>
-          <p:cNvPr id="38" name="Text 36"/>
-          <p:cNvSpPr txBox="1"/>
-          <p:nvPr/>
-        </p:nvSpPr>
-        <p:spPr>
-          <a:xfrm>
-            <a:off x="822960" y="5303520"/>
-            <a:ext cx="4846320" cy="365760"/>
-          </a:xfrm>
-          <a:prstGeom prst="rect">
-            <a:avLst/>
-          </a:prstGeom>
-          <a:noFill/>
-          <a:ln/>
-        </p:spPr>
-        <p:txBody>
-          <a:bodyPr wrap="square" lIns="0" tIns="0" rIns="0" bIns="0" rtlCol="0" anchor="ctr"/>
-          <a:lstStyle/>
-          <a:p>
-            <a:pPr indent="0" marL="0">
-              <a:buNone/>
-            </a:pPr>
-            <a:r>
-              <a:rPr lang="en-US" sz="1600" dirty="0">
-                <a:solidFill>
-                  <a:srgbClr val="1F1E1C"/>
-                </a:solidFill>
-                <a:latin typeface="Inter" pitchFamily="34" charset="0"/>
-                <a:ea typeface="Inter" pitchFamily="34" charset="-122"/>
-                <a:cs typeface="Inter" pitchFamily="34" charset="-120"/>
-              </a:rPr>
-              <a:t>Every agent reads the original file</a:t>
-            </a:r>
-            <a:endParaRPr lang="en-US" sz="1600" dirty="0"/>
-          </a:p>
-        </p:txBody>
-      </p:sp>
-      <p:sp>
-        <p:nvSpPr>
-          <p:cNvPr id="39" name="iso-on"/>
-          <p:cNvSpPr/>
-          <p:nvPr/>
-        </p:nvSpPr>
-        <p:spPr>
-          <a:xfrm>
-            <a:off x="6245352" y="4754880"/>
-            <a:ext cx="5394960" cy="1188720"/>
-          </a:xfrm>
-          <a:prstGeom prst="roundRect">
-            <a:avLst>
-              <a:gd name="adj" fmla="val 9231"/>
-            </a:avLst>
-          </a:prstGeom>
-          <a:solidFill>
-            <a:srgbClr val="F2F5F3"/>
-          </a:solidFill>
-          <a:ln w="12700">
-            <a:solidFill>
-              <a:srgbClr val="F2F5F3"/>
-            </a:solidFill>
-            <a:prstDash val="solid"/>
-          </a:ln>
-        </p:spPr>
-      </p:sp>
-      <p:sp>
-        <p:nvSpPr>
-          <p:cNvPr id="40" name="Text 38"/>
-          <p:cNvSpPr txBox="1"/>
-          <p:nvPr/>
-        </p:nvSpPr>
-        <p:spPr>
-          <a:xfrm>
-            <a:off x="6519672" y="4892040"/>
-            <a:ext cx="4846320" cy="365760"/>
-          </a:xfrm>
-          <a:prstGeom prst="rect">
-            <a:avLst/>
-          </a:prstGeom>
-          <a:noFill/>
-          <a:ln/>
-        </p:spPr>
-        <p:txBody>
-          <a:bodyPr wrap="square" lIns="0" tIns="0" rIns="0" bIns="0" rtlCol="0" anchor="ctr"/>
-          <a:lstStyle/>
-          <a:p>
-            <a:pPr indent="0" marL="0">
-              <a:buNone/>
-            </a:pPr>
-            <a:r>
-              <a:rPr lang="en-US" sz="1800" b="1" dirty="0">
-                <a:solidFill>
-                  <a:srgbClr val="1E2A27"/>
-                </a:solidFill>
-                <a:latin typeface="Inter" pitchFamily="34" charset="0"/>
-                <a:ea typeface="Inter" pitchFamily="34" charset="-122"/>
-                <a:cs typeface="Inter" pitchFamily="34" charset="-120"/>
-              </a:rPr>
-              <a:t>Isolation on</a:t>
-            </a:r>
-            <a:endParaRPr lang="en-US" sz="1800" dirty="0"/>
-          </a:p>
-        </p:txBody>
-      </p:sp>
-      <p:sp>
-        <p:nvSpPr>
-          <p:cNvPr id="41" name="Text 39"/>
-          <p:cNvSpPr txBox="1"/>
-          <p:nvPr/>
-        </p:nvSpPr>
-        <p:spPr>
-          <a:xfrm>
-            <a:off x="6519672" y="5303520"/>
-            <a:ext cx="4846320" cy="365760"/>
-          </a:xfrm>
-          <a:prstGeom prst="rect">
-            <a:avLst/>
-          </a:prstGeom>
-          <a:noFill/>
-          <a:ln/>
-        </p:spPr>
-        <p:txBody>
-          <a:bodyPr wrap="square" lIns="0" tIns="0" rIns="0" bIns="0" rtlCol="0" anchor="ctr"/>
-          <a:lstStyle/>
-          <a:p>
-            <a:pPr indent="0" marL="0">
-              <a:buNone/>
-            </a:pPr>
-            <a:r>
-              <a:rPr lang="en-US" sz="1600" dirty="0">
-                <a:solidFill>
-                  <a:srgbClr val="1F1E1C"/>
-                </a:solidFill>
-                <a:latin typeface="Inter" pitchFamily="34" charset="0"/>
-                <a:ea typeface="Inter" pitchFamily="34" charset="-122"/>
-                <a:cs typeface="Inter" pitchFamily="34" charset="-120"/>
-              </a:rPr>
-              <a:t>Agents 2 and 3 only see a summary</a:t>
-            </a:r>
-            <a:endParaRPr lang="en-US" sz="1600" dirty="0"/>
-          </a:p>
-        </p:txBody>
-      </p:sp>
-      <p:sp>
-        <p:nvSpPr>
-          <p:cNvPr id="42" name="Slide Number Placeholder 0"/>
+          <p:cNvPr id="36" name="Slide Number Placeholder 0"/>
           <p:cNvSpPr>
             <a:spLocks noGrp="1"/>
           </p:cNvSpPr>

</xml_diff>

<commit_message>
Slides: chart icon for Findings; EduInject between the flowchart rows
</commit_message>
<xml_diff>
--- a/presentation/eduinject-slides.pptx
+++ b/presentation/eduinject-slides.pptx
@@ -119,25 +119,25 @@
   <p:extLst>
     <p:ext uri="{521415D9-36F7-43E2-AB2F-B90AF26B5E84}">
       <p14:sectionLst xmlns:p14="http://schemas.microsoft.com/office/powerpoint/2010/main">
-        <p14:section name="Opening" id="{82a59542-0f0e-2cf9-1dae-01b680ec731a}">
+        <p14:section name="Opening" id="{8be88736-7b8b-3d25-08e7-5e28c274fd56}">
           <p14:sldIdLst>
             <p14:sldId id="256"/>
           </p14:sldIdLst>
         </p14:section>
-        <p14:section name="Problem" id="{b5b4c6f8-abcd-417b-4c30-6722b3990016}">
+        <p14:section name="Problem" id="{9ecc8217-009b-c461-b2a3-08dae0d23963}">
           <p14:sldIdLst>
             <p14:sldId id="257"/>
             <p14:sldId id="258"/>
           </p14:sldIdLst>
         </p14:section>
-        <p14:section name="Method" id="{0788ef39-d9fc-c530-26bd-13bfa0935357}">
+        <p14:section name="Method" id="{39adbcb0-19e4-965d-368d-05adc9b9373c}">
           <p14:sldIdLst>
             <p14:sldId id="259"/>
             <p14:sldId id="260"/>
             <p14:sldId id="261"/>
           </p14:sldIdLst>
         </p14:section>
-        <p14:section name="Findings" id="{18085cdb-5d57-bb72-73b6-e1ac1316d8d5}">
+        <p14:section name="Findings" id="{c32e4738-3319-4576-37ac-3b0e31b466d2}">
           <p14:sldIdLst>
             <p14:sldId id="262"/>
             <p14:sldId id="263"/>
@@ -145,7 +145,7 @@
             <p14:sldId id="265"/>
           </p14:sldIdLst>
         </p14:section>
-        <p14:section name="Takeaways" id="{0d8c2dcd-5a1c-e03c-9db6-e66061f7a6f4}">
+        <p14:section name="Takeaways" id="{9fd47a30-7223-9efc-a577-3b198366c1c1}">
           <p14:sldIdLst>
             <p14:sldId id="266"/>
             <p14:sldId id="267"/>
@@ -4769,7 +4769,7 @@
         </p:nvSpPr>
         <p:spPr>
           <a:xfrm>
-            <a:off x="548640" y="1554480"/>
+            <a:off x="548640" y="1463040"/>
             <a:ext cx="1926275" cy="1188720"/>
           </a:xfrm>
           <a:prstGeom prst="roundRect">
@@ -4799,7 +4799,7 @@
         </p:blipFill>
         <p:spPr>
           <a:xfrm>
-            <a:off x="713232" y="1965960"/>
+            <a:off x="713232" y="1874520"/>
             <a:ext cx="365760" cy="365760"/>
           </a:xfrm>
           <a:prstGeom prst="rect">
@@ -4815,7 +4815,7 @@
         </p:nvSpPr>
         <p:spPr>
           <a:xfrm>
-            <a:off x="1188720" y="1554480"/>
+            <a:off x="1188720" y="1463040"/>
             <a:ext cx="1194755" cy="1188720"/>
           </a:xfrm>
           <a:prstGeom prst="rect">
@@ -4854,7 +4854,7 @@
         </p:nvSpPr>
         <p:spPr>
           <a:xfrm>
-            <a:off x="2840675" y="1554480"/>
+            <a:off x="2840675" y="1463040"/>
             <a:ext cx="1926275" cy="1188720"/>
           </a:xfrm>
           <a:prstGeom prst="roundRect">
@@ -4884,7 +4884,7 @@
         </p:blipFill>
         <p:spPr>
           <a:xfrm>
-            <a:off x="3005267" y="1965960"/>
+            <a:off x="3005267" y="1874520"/>
             <a:ext cx="365760" cy="365760"/>
           </a:xfrm>
           <a:prstGeom prst="rect">
@@ -4900,7 +4900,7 @@
         </p:nvSpPr>
         <p:spPr>
           <a:xfrm>
-            <a:off x="3480755" y="1554480"/>
+            <a:off x="3480755" y="1463040"/>
             <a:ext cx="1194755" cy="1188720"/>
           </a:xfrm>
           <a:prstGeom prst="rect">
@@ -4939,7 +4939,7 @@
         </p:nvSpPr>
         <p:spPr>
           <a:xfrm>
-            <a:off x="5132710" y="1554480"/>
+            <a:off x="5132710" y="1463040"/>
             <a:ext cx="1926275" cy="1188720"/>
           </a:xfrm>
           <a:prstGeom prst="roundRect">
@@ -4969,7 +4969,7 @@
         </p:blipFill>
         <p:spPr>
           <a:xfrm>
-            <a:off x="5297302" y="1965960"/>
+            <a:off x="5297302" y="1874520"/>
             <a:ext cx="365760" cy="365760"/>
           </a:xfrm>
           <a:prstGeom prst="rect">
@@ -4985,7 +4985,7 @@
         </p:nvSpPr>
         <p:spPr>
           <a:xfrm>
-            <a:off x="5772790" y="1554480"/>
+            <a:off x="5772790" y="1463040"/>
             <a:ext cx="1194755" cy="1188720"/>
           </a:xfrm>
           <a:prstGeom prst="rect">
@@ -5024,7 +5024,7 @@
         </p:nvSpPr>
         <p:spPr>
           <a:xfrm>
-            <a:off x="7424745" y="1554480"/>
+            <a:off x="7424745" y="1463040"/>
             <a:ext cx="1926275" cy="1188720"/>
           </a:xfrm>
           <a:prstGeom prst="roundRect">
@@ -5054,7 +5054,7 @@
         </p:blipFill>
         <p:spPr>
           <a:xfrm>
-            <a:off x="7589337" y="1965960"/>
+            <a:off x="7589337" y="1874520"/>
             <a:ext cx="365760" cy="365760"/>
           </a:xfrm>
           <a:prstGeom prst="rect">
@@ -5070,7 +5070,7 @@
         </p:nvSpPr>
         <p:spPr>
           <a:xfrm>
-            <a:off x="8064825" y="1554480"/>
+            <a:off x="8064825" y="1463040"/>
             <a:ext cx="1194755" cy="1188720"/>
           </a:xfrm>
           <a:prstGeom prst="rect">
@@ -5109,7 +5109,7 @@
         </p:nvSpPr>
         <p:spPr>
           <a:xfrm>
-            <a:off x="9716780" y="1554480"/>
+            <a:off x="9716780" y="1463040"/>
             <a:ext cx="1926275" cy="1188720"/>
           </a:xfrm>
           <a:prstGeom prst="roundRect">
@@ -5139,7 +5139,7 @@
         </p:blipFill>
         <p:spPr>
           <a:xfrm>
-            <a:off x="9881372" y="1965960"/>
+            <a:off x="9881372" y="1874520"/>
             <a:ext cx="365760" cy="365760"/>
           </a:xfrm>
           <a:prstGeom prst="rect">
@@ -5155,7 +5155,7 @@
         </p:nvSpPr>
         <p:spPr>
           <a:xfrm>
-            <a:off x="10356860" y="1801368"/>
+            <a:off x="10356860" y="1709928"/>
             <a:ext cx="1194755" cy="365760"/>
           </a:xfrm>
           <a:prstGeom prst="rect">
@@ -5194,7 +5194,7 @@
         </p:nvSpPr>
         <p:spPr>
           <a:xfrm>
-            <a:off x="10356860" y="2157984"/>
+            <a:off x="10356860" y="2066544"/>
             <a:ext cx="1194755" cy="411480"/>
           </a:xfrm>
           <a:prstGeom prst="rect">
@@ -5219,7 +5219,7 @@
                 <a:ea typeface="Lato" pitchFamily="34" charset="-122"/>
                 <a:cs typeface="Lato" pitchFamily="34" charset="-120"/>
               </a:rPr>
-              <a:t>uses its allowed tools</a:t>
+              <a:t>uses allowed tools</a:t>
             </a:r>
             <a:endParaRPr lang="en-US" sz="1100" dirty="0"/>
           </a:p>
@@ -5233,7 +5233,7 @@
         </p:nvSpPr>
         <p:spPr>
           <a:xfrm>
-            <a:off x="9716780" y="3840480"/>
+            <a:off x="9716780" y="4069080"/>
             <a:ext cx="1926275" cy="1188720"/>
           </a:xfrm>
           <a:prstGeom prst="roundRect">
@@ -5263,7 +5263,7 @@
         </p:blipFill>
         <p:spPr>
           <a:xfrm>
-            <a:off x="9881372" y="4251960"/>
+            <a:off x="9881372" y="4480560"/>
             <a:ext cx="365760" cy="365760"/>
           </a:xfrm>
           <a:prstGeom prst="rect">
@@ -5279,7 +5279,7 @@
         </p:nvSpPr>
         <p:spPr>
           <a:xfrm>
-            <a:off x="10356860" y="3840480"/>
+            <a:off x="10356860" y="4069080"/>
             <a:ext cx="1194755" cy="1188720"/>
           </a:xfrm>
           <a:prstGeom prst="rect">
@@ -5318,7 +5318,7 @@
         </p:nvSpPr>
         <p:spPr>
           <a:xfrm>
-            <a:off x="7424745" y="3840480"/>
+            <a:off x="7424745" y="4069080"/>
             <a:ext cx="1926275" cy="1188720"/>
           </a:xfrm>
           <a:prstGeom prst="roundRect">
@@ -5348,7 +5348,7 @@
         </p:blipFill>
         <p:spPr>
           <a:xfrm>
-            <a:off x="7589337" y="4251960"/>
+            <a:off x="7589337" y="4480560"/>
             <a:ext cx="365760" cy="365760"/>
           </a:xfrm>
           <a:prstGeom prst="rect">
@@ -5364,7 +5364,7 @@
         </p:nvSpPr>
         <p:spPr>
           <a:xfrm>
-            <a:off x="8064825" y="3840480"/>
+            <a:off x="8064825" y="4069080"/>
             <a:ext cx="1194755" cy="1188720"/>
           </a:xfrm>
           <a:prstGeom prst="rect">
@@ -5403,7 +5403,7 @@
         </p:nvSpPr>
         <p:spPr>
           <a:xfrm>
-            <a:off x="5132710" y="3840480"/>
+            <a:off x="5132710" y="4069080"/>
             <a:ext cx="1926275" cy="1188720"/>
           </a:xfrm>
           <a:prstGeom prst="roundRect">
@@ -5433,7 +5433,7 @@
         </p:blipFill>
         <p:spPr>
           <a:xfrm>
-            <a:off x="5297302" y="4251960"/>
+            <a:off x="5297302" y="4480560"/>
             <a:ext cx="365760" cy="365760"/>
           </a:xfrm>
           <a:prstGeom prst="rect">
@@ -5449,7 +5449,7 @@
         </p:nvSpPr>
         <p:spPr>
           <a:xfrm>
-            <a:off x="5772790" y="3840480"/>
+            <a:off x="5772790" y="4069080"/>
             <a:ext cx="1194755" cy="1188720"/>
           </a:xfrm>
           <a:prstGeom prst="rect">
@@ -5488,7 +5488,7 @@
         </p:nvSpPr>
         <p:spPr>
           <a:xfrm>
-            <a:off x="2840675" y="3840480"/>
+            <a:off x="2840675" y="4069080"/>
             <a:ext cx="1926275" cy="1188720"/>
           </a:xfrm>
           <a:prstGeom prst="roundRect">
@@ -5518,7 +5518,7 @@
         </p:blipFill>
         <p:spPr>
           <a:xfrm>
-            <a:off x="3005267" y="4251960"/>
+            <a:off x="3005267" y="4480560"/>
             <a:ext cx="365760" cy="365760"/>
           </a:xfrm>
           <a:prstGeom prst="rect">
@@ -5534,7 +5534,7 @@
         </p:nvSpPr>
         <p:spPr>
           <a:xfrm>
-            <a:off x="3480755" y="3840480"/>
+            <a:off x="3480755" y="4069080"/>
             <a:ext cx="1194755" cy="1188720"/>
           </a:xfrm>
           <a:prstGeom prst="rect">
@@ -5573,7 +5573,7 @@
         </p:nvSpPr>
         <p:spPr>
           <a:xfrm>
-            <a:off x="548640" y="3840480"/>
+            <a:off x="548640" y="4069080"/>
             <a:ext cx="1926275" cy="1188720"/>
           </a:xfrm>
           <a:prstGeom prst="roundRect">
@@ -5603,7 +5603,7 @@
         </p:blipFill>
         <p:spPr>
           <a:xfrm>
-            <a:off x="713232" y="4251960"/>
+            <a:off x="713232" y="4480560"/>
             <a:ext cx="365760" cy="365760"/>
           </a:xfrm>
           <a:prstGeom prst="rect">
@@ -5619,7 +5619,7 @@
         </p:nvSpPr>
         <p:spPr>
           <a:xfrm>
-            <a:off x="1188720" y="3840480"/>
+            <a:off x="1188720" y="4069080"/>
             <a:ext cx="1194755" cy="1188720"/>
           </a:xfrm>
           <a:prstGeom prst="rect">
@@ -5658,7 +5658,7 @@
         </p:nvSpPr>
         <p:spPr>
           <a:xfrm>
-            <a:off x="2520635" y="2148840"/>
+            <a:off x="2520635" y="2057400"/>
             <a:ext cx="274320" cy="914"/>
           </a:xfrm>
           <a:prstGeom prst="line">
@@ -5682,7 +5682,7 @@
         </p:nvSpPr>
         <p:spPr>
           <a:xfrm>
-            <a:off x="4812670" y="2148840"/>
+            <a:off x="4812670" y="2057400"/>
             <a:ext cx="274320" cy="914"/>
           </a:xfrm>
           <a:prstGeom prst="line">
@@ -5706,7 +5706,7 @@
         </p:nvSpPr>
         <p:spPr>
           <a:xfrm>
-            <a:off x="7104705" y="2148840"/>
+            <a:off x="7104705" y="2057400"/>
             <a:ext cx="274320" cy="914"/>
           </a:xfrm>
           <a:prstGeom prst="line">
@@ -5730,7 +5730,7 @@
         </p:nvSpPr>
         <p:spPr>
           <a:xfrm>
-            <a:off x="9396740" y="2148840"/>
+            <a:off x="9396740" y="2057400"/>
             <a:ext cx="274320" cy="914"/>
           </a:xfrm>
           <a:prstGeom prst="line">
@@ -5754,8 +5754,8 @@
         </p:nvSpPr>
         <p:spPr>
           <a:xfrm>
-            <a:off x="11026647" y="2798064"/>
-            <a:ext cx="914" cy="987552"/>
+            <a:off x="11026647" y="2706624"/>
+            <a:ext cx="914" cy="1307592"/>
           </a:xfrm>
           <a:prstGeom prst="line">
             <a:avLst/>
@@ -5778,7 +5778,7 @@
         </p:nvSpPr>
         <p:spPr>
           <a:xfrm flipH="1">
-            <a:off x="9396740" y="4434840"/>
+            <a:off x="9396740" y="4663440"/>
             <a:ext cx="274320" cy="914"/>
           </a:xfrm>
           <a:prstGeom prst="line">
@@ -5802,7 +5802,7 @@
         </p:nvSpPr>
         <p:spPr>
           <a:xfrm flipH="1">
-            <a:off x="7104705" y="4434840"/>
+            <a:off x="7104705" y="4663440"/>
             <a:ext cx="274320" cy="914"/>
           </a:xfrm>
           <a:prstGeom prst="line">
@@ -5826,7 +5826,7 @@
         </p:nvSpPr>
         <p:spPr>
           <a:xfrm flipH="1">
-            <a:off x="4812670" y="4434840"/>
+            <a:off x="4812670" y="4663440"/>
             <a:ext cx="274320" cy="914"/>
           </a:xfrm>
           <a:prstGeom prst="line">
@@ -5850,7 +5850,7 @@
         </p:nvSpPr>
         <p:spPr>
           <a:xfrm flipH="1">
-            <a:off x="2520635" y="4434840"/>
+            <a:off x="2520635" y="4663440"/>
             <a:ext cx="274320" cy="914"/>
           </a:xfrm>
           <a:prstGeom prst="line">
@@ -5874,8 +5874,8 @@
         </p:nvSpPr>
         <p:spPr>
           <a:xfrm>
-            <a:off x="3803813" y="2743200"/>
-            <a:ext cx="914" cy="502920"/>
+            <a:off x="3803813" y="2651760"/>
+            <a:ext cx="914" cy="292608"/>
           </a:xfrm>
           <a:prstGeom prst="line">
             <a:avLst/>
@@ -5897,7 +5897,7 @@
         </p:nvSpPr>
         <p:spPr>
           <a:xfrm>
-            <a:off x="3803813" y="3246120"/>
+            <a:off x="3803813" y="2944368"/>
             <a:ext cx="6490850" cy="914"/>
           </a:xfrm>
           <a:prstGeom prst="line">
@@ -5920,8 +5920,8 @@
         </p:nvSpPr>
         <p:spPr>
           <a:xfrm flipV="1">
-            <a:off x="8387883" y="2798064"/>
-            <a:ext cx="914" cy="448056"/>
+            <a:off x="8387883" y="2706624"/>
+            <a:ext cx="914" cy="237744"/>
           </a:xfrm>
           <a:prstGeom prst="line">
             <a:avLst/>
@@ -5944,8 +5944,8 @@
         </p:nvSpPr>
         <p:spPr>
           <a:xfrm flipV="1">
-            <a:off x="10294663" y="2798064"/>
-            <a:ext cx="914" cy="448056"/>
+            <a:off x="10294663" y="2706624"/>
+            <a:ext cx="914" cy="237744"/>
           </a:xfrm>
           <a:prstGeom prst="line">
             <a:avLst/>
@@ -5962,7 +5962,46 @@
       </p:sp>
       <p:sp>
         <p:nvSpPr>
-          <p:cNvPr id="46" name="Shape 34"/>
+          <p:cNvPr id="46" name="Text 34"/>
+          <p:cNvSpPr txBox="1"/>
+          <p:nvPr/>
+        </p:nvSpPr>
+        <p:spPr>
+          <a:xfrm>
+            <a:off x="4267048" y="3108960"/>
+            <a:ext cx="3657600" cy="822960"/>
+          </a:xfrm>
+          <a:prstGeom prst="rect">
+            <a:avLst/>
+          </a:prstGeom>
+          <a:noFill/>
+          <a:ln/>
+        </p:spPr>
+        <p:txBody>
+          <a:bodyPr wrap="square" lIns="0" tIns="0" rIns="0" bIns="0" rtlCol="0" anchor="ctr"/>
+          <a:lstStyle/>
+          <a:p>
+            <a:pPr algn="ctr" indent="0" marL="0">
+              <a:buNone/>
+            </a:pPr>
+            <a:r>
+              <a:rPr lang="en-US" sz="3000" b="1" dirty="0">
+                <a:solidFill>
+                  <a:srgbClr val="1E2A27"/>
+                </a:solidFill>
+                <a:latin typeface="Lato" pitchFamily="34" charset="0"/>
+                <a:ea typeface="Lato" pitchFamily="34" charset="-122"/>
+                <a:cs typeface="Lato" pitchFamily="34" charset="-120"/>
+              </a:rPr>
+              <a:t>EduInject</a:t>
+            </a:r>
+            <a:endParaRPr lang="en-US" sz="3000" dirty="0"/>
+          </a:p>
+        </p:txBody>
+      </p:sp>
+      <p:sp>
+        <p:nvSpPr>
+          <p:cNvPr id="47" name="Shape 35"/>
           <p:cNvSpPr/>
           <p:nvPr/>
         </p:nvSpPr>
@@ -5984,7 +6023,7 @@
       </p:sp>
       <p:sp>
         <p:nvSpPr>
-          <p:cNvPr id="47" name="Text 35"/>
+          <p:cNvPr id="48" name="Text 36"/>
           <p:cNvSpPr txBox="1"/>
           <p:nvPr/>
         </p:nvSpPr>
@@ -6023,7 +6062,7 @@
       </p:sp>
       <p:sp>
         <p:nvSpPr>
-          <p:cNvPr id="48" name="Shape 36"/>
+          <p:cNvPr id="49" name="Shape 37"/>
           <p:cNvSpPr/>
           <p:nvPr/>
         </p:nvSpPr>
@@ -6045,7 +6084,7 @@
       </p:sp>
       <p:sp>
         <p:nvSpPr>
-          <p:cNvPr id="49" name="Text 37"/>
+          <p:cNvPr id="50" name="Text 38"/>
           <p:cNvSpPr txBox="1"/>
           <p:nvPr/>
         </p:nvSpPr>
@@ -6084,7 +6123,7 @@
       </p:sp>
       <p:sp>
         <p:nvSpPr>
-          <p:cNvPr id="50" name="Shape 38"/>
+          <p:cNvPr id="51" name="Shape 39"/>
           <p:cNvSpPr/>
           <p:nvPr/>
         </p:nvSpPr>
@@ -6106,7 +6145,7 @@
       </p:sp>
       <p:sp>
         <p:nvSpPr>
-          <p:cNvPr id="51" name="Text 39"/>
+          <p:cNvPr id="52" name="Text 40"/>
           <p:cNvSpPr txBox="1"/>
           <p:nvPr/>
         </p:nvSpPr>
@@ -6145,7 +6184,7 @@
       </p:sp>
       <p:sp>
         <p:nvSpPr>
-          <p:cNvPr id="52" name="Shape 40"/>
+          <p:cNvPr id="53" name="Shape 41"/>
           <p:cNvSpPr/>
           <p:nvPr/>
         </p:nvSpPr>
@@ -6167,7 +6206,7 @@
       </p:sp>
       <p:sp>
         <p:nvSpPr>
-          <p:cNvPr id="53" name="Text 41"/>
+          <p:cNvPr id="54" name="Text 42"/>
           <p:cNvSpPr txBox="1"/>
           <p:nvPr/>
         </p:nvSpPr>
@@ -6206,7 +6245,7 @@
       </p:sp>
       <p:sp>
         <p:nvSpPr>
-          <p:cNvPr id="54" name="Shape 42"/>
+          <p:cNvPr id="55" name="Shape 43"/>
           <p:cNvSpPr/>
           <p:nvPr/>
         </p:nvSpPr>
@@ -6228,7 +6267,7 @@
       </p:sp>
       <p:sp>
         <p:nvSpPr>
-          <p:cNvPr id="55" name="Text 43"/>
+          <p:cNvPr id="56" name="Text 44"/>
           <p:cNvSpPr txBox="1"/>
           <p:nvPr/>
         </p:nvSpPr>
@@ -6267,7 +6306,7 @@
       </p:sp>
       <p:sp>
         <p:nvSpPr>
-          <p:cNvPr id="56" name="Shape 44"/>
+          <p:cNvPr id="57" name="Shape 45"/>
           <p:cNvSpPr/>
           <p:nvPr/>
         </p:nvSpPr>
@@ -6291,7 +6330,7 @@
       </p:sp>
       <p:sp>
         <p:nvSpPr>
-          <p:cNvPr id="57" name="Text 45"/>
+          <p:cNvPr id="58" name="Text 46"/>
           <p:cNvSpPr txBox="1"/>
           <p:nvPr/>
         </p:nvSpPr>
@@ -6330,7 +6369,7 @@
       </p:sp>
       <p:sp>
         <p:nvSpPr>
-          <p:cNvPr id="58" name="Shape 46"/>
+          <p:cNvPr id="59" name="Shape 47"/>
           <p:cNvSpPr/>
           <p:nvPr/>
         </p:nvSpPr>
@@ -6354,7 +6393,7 @@
       </p:sp>
       <p:sp>
         <p:nvSpPr>
-          <p:cNvPr id="59" name="Text 47"/>
+          <p:cNvPr id="60" name="Text 48"/>
           <p:cNvSpPr txBox="1"/>
           <p:nvPr/>
         </p:nvSpPr>
@@ -6393,7 +6432,7 @@
       </p:sp>
       <p:sp>
         <p:nvSpPr>
-          <p:cNvPr id="60" name="Slide Number Placeholder 0"/>
+          <p:cNvPr id="61" name="Slide Number Placeholder 0"/>
           <p:cNvSpPr>
             <a:spLocks noGrp="1"/>
           </p:cNvSpPr>

</xml_diff>

<commit_message>
Slides: label the flowchart's drop arrow 'tool calls'
</commit_message>
<xml_diff>
--- a/presentation/eduinject-slides.pptx
+++ b/presentation/eduinject-slides.pptx
@@ -119,25 +119,25 @@
   <p:extLst>
     <p:ext uri="{521415D9-36F7-43E2-AB2F-B90AF26B5E84}">
       <p14:sectionLst xmlns:p14="http://schemas.microsoft.com/office/powerpoint/2010/main">
-        <p14:section name="Opening" id="{8be88736-7b8b-3d25-08e7-5e28c274fd56}">
+        <p14:section name="Opening" id="{5ba91ca0-555a-63a8-4ada-54ceb5d22e10}">
           <p14:sldIdLst>
             <p14:sldId id="256"/>
           </p14:sldIdLst>
         </p14:section>
-        <p14:section name="Problem" id="{9ecc8217-009b-c461-b2a3-08dae0d23963}">
+        <p14:section name="Problem" id="{9f4039b9-3957-11da-be28-9691cb314857}">
           <p14:sldIdLst>
             <p14:sldId id="257"/>
             <p14:sldId id="258"/>
           </p14:sldIdLst>
         </p14:section>
-        <p14:section name="Method" id="{39adbcb0-19e4-965d-368d-05adc9b9373c}">
+        <p14:section name="Method" id="{e51c8160-4c09-6fb1-21c7-241a1b287c1f}">
           <p14:sldIdLst>
             <p14:sldId id="259"/>
             <p14:sldId id="260"/>
             <p14:sldId id="261"/>
           </p14:sldIdLst>
         </p14:section>
-        <p14:section name="Findings" id="{c32e4738-3319-4576-37ac-3b0e31b466d2}">
+        <p14:section name="Findings" id="{ff65aa06-8c3b-4c9c-00ae-8133eb81cbf2}">
           <p14:sldIdLst>
             <p14:sldId id="262"/>
             <p14:sldId id="263"/>
@@ -145,7 +145,7 @@
             <p14:sldId id="265"/>
           </p14:sldIdLst>
         </p14:section>
-        <p14:section name="Takeaways" id="{9fd47a30-7223-9efc-a577-3b198366c1c1}">
+        <p14:section name="Takeaways" id="{36006ebf-e206-98ad-eaf9-c6be4f10e740}">
           <p14:sldIdLst>
             <p14:sldId id="266"/>
             <p14:sldId id="267"/>
@@ -5772,7 +5772,46 @@
       </p:sp>
       <p:sp>
         <p:nvSpPr>
-          <p:cNvPr id="38" name="fc-a6"/>
+          <p:cNvPr id="38" name="fc-a5-label"/>
+          <p:cNvSpPr txBox="1"/>
+          <p:nvPr/>
+        </p:nvSpPr>
+        <p:spPr>
+          <a:xfrm>
+            <a:off x="9563607" y="3406140"/>
+            <a:ext cx="1371600" cy="320040"/>
+          </a:xfrm>
+          <a:prstGeom prst="rect">
+            <a:avLst/>
+          </a:prstGeom>
+          <a:noFill/>
+          <a:ln/>
+        </p:spPr>
+        <p:txBody>
+          <a:bodyPr wrap="square" lIns="0" tIns="0" rIns="0" bIns="0" rtlCol="0" anchor="ctr"/>
+          <a:lstStyle/>
+          <a:p>
+            <a:pPr algn="r" indent="0" marL="0">
+              <a:buNone/>
+            </a:pPr>
+            <a:r>
+              <a:rPr lang="en-US" sz="1200" dirty="0">
+                <a:solidFill>
+                  <a:srgbClr val="5F6B66"/>
+                </a:solidFill>
+                <a:latin typeface="Lato" pitchFamily="34" charset="0"/>
+                <a:ea typeface="Lato" pitchFamily="34" charset="-122"/>
+                <a:cs typeface="Lato" pitchFamily="34" charset="-120"/>
+              </a:rPr>
+              <a:t>tool calls</a:t>
+            </a:r>
+            <a:endParaRPr lang="en-US" sz="1200" dirty="0"/>
+          </a:p>
+        </p:txBody>
+      </p:sp>
+      <p:sp>
+        <p:nvSpPr>
+          <p:cNvPr id="39" name="fc-a6"/>
           <p:cNvSpPr/>
           <p:nvPr/>
         </p:nvSpPr>
@@ -5796,7 +5835,7 @@
       </p:sp>
       <p:sp>
         <p:nvSpPr>
-          <p:cNvPr id="39" name="fc-a7"/>
+          <p:cNvPr id="40" name="fc-a7"/>
           <p:cNvSpPr/>
           <p:nvPr/>
         </p:nvSpPr>
@@ -5820,7 +5859,7 @@
       </p:sp>
       <p:sp>
         <p:nvSpPr>
-          <p:cNvPr id="40" name="fc-a8"/>
+          <p:cNvPr id="41" name="fc-a8"/>
           <p:cNvSpPr/>
           <p:nvPr/>
         </p:nvSpPr>
@@ -5844,7 +5883,7 @@
       </p:sp>
       <p:sp>
         <p:nvSpPr>
-          <p:cNvPr id="41" name="fc-a9"/>
+          <p:cNvPr id="42" name="fc-a9"/>
           <p:cNvSpPr/>
           <p:nvPr/>
         </p:nvSpPr>
@@ -5868,7 +5907,7 @@
       </p:sp>
       <p:sp>
         <p:nvSpPr>
-          <p:cNvPr id="42" name="fc-iso-1"/>
+          <p:cNvPr id="43" name="fc-iso-1"/>
           <p:cNvSpPr/>
           <p:nvPr/>
         </p:nvSpPr>
@@ -5891,7 +5930,7 @@
       </p:sp>
       <p:sp>
         <p:nvSpPr>
-          <p:cNvPr id="43" name="fc-iso-2"/>
+          <p:cNvPr id="44" name="fc-iso-2"/>
           <p:cNvSpPr/>
           <p:nvPr/>
         </p:nvSpPr>
@@ -5914,7 +5953,7 @@
       </p:sp>
       <p:sp>
         <p:nvSpPr>
-          <p:cNvPr id="44" name="fc-iso-3"/>
+          <p:cNvPr id="45" name="fc-iso-3"/>
           <p:cNvSpPr/>
           <p:nvPr/>
         </p:nvSpPr>
@@ -5938,7 +5977,7 @@
       </p:sp>
       <p:sp>
         <p:nvSpPr>
-          <p:cNvPr id="45" name="fc-iso-4"/>
+          <p:cNvPr id="46" name="fc-iso-4"/>
           <p:cNvSpPr/>
           <p:nvPr/>
         </p:nvSpPr>
@@ -5962,7 +6001,7 @@
       </p:sp>
       <p:sp>
         <p:nvSpPr>
-          <p:cNvPr id="46" name="Text 34"/>
+          <p:cNvPr id="47" name="Text 35"/>
           <p:cNvSpPr txBox="1"/>
           <p:nvPr/>
         </p:nvSpPr>
@@ -6001,7 +6040,7 @@
       </p:sp>
       <p:sp>
         <p:nvSpPr>
-          <p:cNvPr id="47" name="Shape 35"/>
+          <p:cNvPr id="48" name="Shape 36"/>
           <p:cNvSpPr/>
           <p:nvPr/>
         </p:nvSpPr>
@@ -6023,7 +6062,7 @@
       </p:sp>
       <p:sp>
         <p:nvSpPr>
-          <p:cNvPr id="48" name="Text 36"/>
+          <p:cNvPr id="49" name="Text 37"/>
           <p:cNvSpPr txBox="1"/>
           <p:nvPr/>
         </p:nvSpPr>
@@ -6062,7 +6101,7 @@
       </p:sp>
       <p:sp>
         <p:nvSpPr>
-          <p:cNvPr id="49" name="Shape 37"/>
+          <p:cNvPr id="50" name="Shape 38"/>
           <p:cNvSpPr/>
           <p:nvPr/>
         </p:nvSpPr>
@@ -6084,7 +6123,7 @@
       </p:sp>
       <p:sp>
         <p:nvSpPr>
-          <p:cNvPr id="50" name="Text 38"/>
+          <p:cNvPr id="51" name="Text 39"/>
           <p:cNvSpPr txBox="1"/>
           <p:nvPr/>
         </p:nvSpPr>
@@ -6123,7 +6162,7 @@
       </p:sp>
       <p:sp>
         <p:nvSpPr>
-          <p:cNvPr id="51" name="Shape 39"/>
+          <p:cNvPr id="52" name="Shape 40"/>
           <p:cNvSpPr/>
           <p:nvPr/>
         </p:nvSpPr>
@@ -6145,7 +6184,7 @@
       </p:sp>
       <p:sp>
         <p:nvSpPr>
-          <p:cNvPr id="52" name="Text 40"/>
+          <p:cNvPr id="53" name="Text 41"/>
           <p:cNvSpPr txBox="1"/>
           <p:nvPr/>
         </p:nvSpPr>
@@ -6184,7 +6223,7 @@
       </p:sp>
       <p:sp>
         <p:nvSpPr>
-          <p:cNvPr id="53" name="Shape 41"/>
+          <p:cNvPr id="54" name="Shape 42"/>
           <p:cNvSpPr/>
           <p:nvPr/>
         </p:nvSpPr>
@@ -6206,7 +6245,7 @@
       </p:sp>
       <p:sp>
         <p:nvSpPr>
-          <p:cNvPr id="54" name="Text 42"/>
+          <p:cNvPr id="55" name="Text 43"/>
           <p:cNvSpPr txBox="1"/>
           <p:nvPr/>
         </p:nvSpPr>
@@ -6245,7 +6284,7 @@
       </p:sp>
       <p:sp>
         <p:nvSpPr>
-          <p:cNvPr id="55" name="Shape 43"/>
+          <p:cNvPr id="56" name="Shape 44"/>
           <p:cNvSpPr/>
           <p:nvPr/>
         </p:nvSpPr>
@@ -6267,7 +6306,7 @@
       </p:sp>
       <p:sp>
         <p:nvSpPr>
-          <p:cNvPr id="56" name="Text 44"/>
+          <p:cNvPr id="57" name="Text 45"/>
           <p:cNvSpPr txBox="1"/>
           <p:nvPr/>
         </p:nvSpPr>
@@ -6306,7 +6345,7 @@
       </p:sp>
       <p:sp>
         <p:nvSpPr>
-          <p:cNvPr id="57" name="Shape 45"/>
+          <p:cNvPr id="58" name="Shape 46"/>
           <p:cNvSpPr/>
           <p:nvPr/>
         </p:nvSpPr>
@@ -6330,7 +6369,7 @@
       </p:sp>
       <p:sp>
         <p:nvSpPr>
-          <p:cNvPr id="58" name="Text 46"/>
+          <p:cNvPr id="59" name="Text 47"/>
           <p:cNvSpPr txBox="1"/>
           <p:nvPr/>
         </p:nvSpPr>
@@ -6369,7 +6408,7 @@
       </p:sp>
       <p:sp>
         <p:nvSpPr>
-          <p:cNvPr id="59" name="Shape 47"/>
+          <p:cNvPr id="60" name="Shape 48"/>
           <p:cNvSpPr/>
           <p:nvPr/>
         </p:nvSpPr>
@@ -6393,7 +6432,7 @@
       </p:sp>
       <p:sp>
         <p:nvSpPr>
-          <p:cNvPr id="60" name="Text 48"/>
+          <p:cNvPr id="61" name="Text 49"/>
           <p:cNvSpPr txBox="1"/>
           <p:nvPr/>
         </p:nvSpPr>
@@ -6432,7 +6471,7 @@
       </p:sp>
       <p:sp>
         <p:nvSpPr>
-          <p:cNvPr id="61" name="Slide Number Placeholder 0"/>
+          <p:cNvPr id="62" name="Slide Number Placeholder 0"/>
           <p:cNvSpPr>
             <a:spLocks noGrp="1"/>
           </p:cNvSpPr>
@@ -7307,7 +7346,7 @@
                                           </p:stCondLst>
                                         </p:cTn>
                                         <p:tgtEl>
-                                          <p:spTgt spid="42"/>
+                                          <p:spTgt spid="43"/>
                                         </p:tgtEl>
                                         <p:attrNameLst>
                                           <p:attrName>style.visibility</p:attrName>
@@ -7321,7 +7360,7 @@
                                       <p:cBhvr>
                                         <p:cTn id="77" dur="400"/>
                                         <p:tgtEl>
-                                          <p:spTgt spid="42"/>
+                                          <p:spTgt spid="43"/>
                                         </p:tgtEl>
                                       </p:cBhvr>
                                     </p:animEffect>
@@ -7342,7 +7381,7 @@
                                           </p:stCondLst>
                                         </p:cTn>
                                         <p:tgtEl>
-                                          <p:spTgt spid="43"/>
+                                          <p:spTgt spid="44"/>
                                         </p:tgtEl>
                                         <p:attrNameLst>
                                           <p:attrName>style.visibility</p:attrName>
@@ -7356,7 +7395,7 @@
                                       <p:cBhvr>
                                         <p:cTn id="80" dur="400"/>
                                         <p:tgtEl>
-                                          <p:spTgt spid="43"/>
+                                          <p:spTgt spid="44"/>
                                         </p:tgtEl>
                                       </p:cBhvr>
                                     </p:animEffect>
@@ -7377,7 +7416,7 @@
                                           </p:stCondLst>
                                         </p:cTn>
                                         <p:tgtEl>
-                                          <p:spTgt spid="44"/>
+                                          <p:spTgt spid="45"/>
                                         </p:tgtEl>
                                         <p:attrNameLst>
                                           <p:attrName>style.visibility</p:attrName>
@@ -7391,7 +7430,7 @@
                                       <p:cBhvr>
                                         <p:cTn id="83" dur="400"/>
                                         <p:tgtEl>
-                                          <p:spTgt spid="44"/>
+                                          <p:spTgt spid="45"/>
                                         </p:tgtEl>
                                       </p:cBhvr>
                                     </p:animEffect>
@@ -7412,7 +7451,7 @@
                                           </p:stCondLst>
                                         </p:cTn>
                                         <p:tgtEl>
-                                          <p:spTgt spid="45"/>
+                                          <p:spTgt spid="46"/>
                                         </p:tgtEl>
                                         <p:attrNameLst>
                                           <p:attrName>style.visibility</p:attrName>
@@ -7426,7 +7465,7 @@
                                       <p:cBhvr>
                                         <p:cTn id="86" dur="400"/>
                                         <p:tgtEl>
-                                          <p:spTgt spid="45"/>
+                                          <p:spTgt spid="46"/>
                                         </p:tgtEl>
                                       </p:cBhvr>
                                     </p:animEffect>
@@ -7489,7 +7528,7 @@
                               <p:par>
                                 <p:cTn id="92" presetID="10" presetClass="entr" presetSubtype="0" fill="hold" nodeType="withEffect">
                                   <p:stCondLst>
-                                    <p:cond delay="250"/>
+                                    <p:cond delay="0"/>
                                   </p:stCondLst>
                                   <p:childTnLst>
                                     <p:set>
@@ -7500,7 +7539,7 @@
                                           </p:stCondLst>
                                         </p:cTn>
                                         <p:tgtEl>
-                                          <p:spTgt spid="18"/>
+                                          <p:spTgt spid="38"/>
                                         </p:tgtEl>
                                         <p:attrNameLst>
                                           <p:attrName>style.visibility</p:attrName>
@@ -7514,7 +7553,7 @@
                                       <p:cBhvr>
                                         <p:cTn id="94" dur="400"/>
                                         <p:tgtEl>
-                                          <p:spTgt spid="18"/>
+                                          <p:spTgt spid="38"/>
                                         </p:tgtEl>
                                       </p:cBhvr>
                                     </p:animEffect>
@@ -7535,7 +7574,7 @@
                                           </p:stCondLst>
                                         </p:cTn>
                                         <p:tgtEl>
-                                          <p:spTgt spid="19"/>
+                                          <p:spTgt spid="18"/>
                                         </p:tgtEl>
                                         <p:attrNameLst>
                                           <p:attrName>style.visibility</p:attrName>
@@ -7549,7 +7588,7 @@
                                       <p:cBhvr>
                                         <p:cTn id="97" dur="400"/>
                                         <p:tgtEl>
-                                          <p:spTgt spid="19"/>
+                                          <p:spTgt spid="18"/>
                                         </p:tgtEl>
                                       </p:cBhvr>
                                     </p:animEffect>
@@ -7570,6 +7609,41 @@
                                           </p:stCondLst>
                                         </p:cTn>
                                         <p:tgtEl>
+                                          <p:spTgt spid="19"/>
+                                        </p:tgtEl>
+                                        <p:attrNameLst>
+                                          <p:attrName>style.visibility</p:attrName>
+                                        </p:attrNameLst>
+                                      </p:cBhvr>
+                                      <p:to>
+                                        <p:strVal val="visible"/>
+                                      </p:to>
+                                    </p:set>
+                                    <p:animEffect transition="in" filter="fade">
+                                      <p:cBhvr>
+                                        <p:cTn id="100" dur="400"/>
+                                        <p:tgtEl>
+                                          <p:spTgt spid="19"/>
+                                        </p:tgtEl>
+                                      </p:cBhvr>
+                                    </p:animEffect>
+                                  </p:childTnLst>
+                                </p:cTn>
+                              </p:par>
+                              <p:par>
+                                <p:cTn id="101" presetID="10" presetClass="entr" presetSubtype="0" fill="hold" nodeType="withEffect">
+                                  <p:stCondLst>
+                                    <p:cond delay="250"/>
+                                  </p:stCondLst>
+                                  <p:childTnLst>
+                                    <p:set>
+                                      <p:cBhvr>
+                                        <p:cTn id="102" dur="1" fill="hold">
+                                          <p:stCondLst>
+                                            <p:cond delay="0"/>
+                                          </p:stCondLst>
+                                        </p:cTn>
+                                        <p:tgtEl>
                                           <p:spTgt spid="20"/>
                                         </p:tgtEl>
                                         <p:attrNameLst>
@@ -7582,7 +7656,7 @@
                                     </p:set>
                                     <p:animEffect transition="in" filter="fade">
                                       <p:cBhvr>
-                                        <p:cTn id="100" dur="400"/>
+                                        <p:cTn id="103" dur="400"/>
                                         <p:tgtEl>
                                           <p:spTgt spid="20"/>
                                         </p:tgtEl>
@@ -7598,56 +7672,21 @@
                     </p:cTn>
                   </p:par>
                   <p:par>
-                    <p:cTn id="101" fill="hold">
+                    <p:cTn id="104" fill="hold">
                       <p:stCondLst>
                         <p:cond delay="indefinite"/>
                       </p:stCondLst>
                       <p:childTnLst>
                         <p:par>
-                          <p:cTn id="102" fill="hold">
+                          <p:cTn id="105" fill="hold">
                             <p:stCondLst>
                               <p:cond delay="0"/>
                             </p:stCondLst>
                             <p:childTnLst>
                               <p:par>
-                                <p:cTn id="103" presetID="10" presetClass="entr" presetSubtype="0" fill="hold" nodeType="clickEffect">
+                                <p:cTn id="106" presetID="10" presetClass="entr" presetSubtype="0" fill="hold" nodeType="clickEffect">
                                   <p:stCondLst>
                                     <p:cond delay="0"/>
-                                  </p:stCondLst>
-                                  <p:childTnLst>
-                                    <p:set>
-                                      <p:cBhvr>
-                                        <p:cTn id="104" dur="1" fill="hold">
-                                          <p:stCondLst>
-                                            <p:cond delay="0"/>
-                                          </p:stCondLst>
-                                        </p:cTn>
-                                        <p:tgtEl>
-                                          <p:spTgt spid="38"/>
-                                        </p:tgtEl>
-                                        <p:attrNameLst>
-                                          <p:attrName>style.visibility</p:attrName>
-                                        </p:attrNameLst>
-                                      </p:cBhvr>
-                                      <p:to>
-                                        <p:strVal val="visible"/>
-                                      </p:to>
-                                    </p:set>
-                                    <p:animEffect transition="in" filter="fade">
-                                      <p:cBhvr>
-                                        <p:cTn id="105" dur="400"/>
-                                        <p:tgtEl>
-                                          <p:spTgt spid="38"/>
-                                        </p:tgtEl>
-                                      </p:cBhvr>
-                                    </p:animEffect>
-                                  </p:childTnLst>
-                                </p:cTn>
-                              </p:par>
-                              <p:par>
-                                <p:cTn id="106" presetID="10" presetClass="entr" presetSubtype="0" fill="hold" nodeType="withEffect">
-                                  <p:stCondLst>
-                                    <p:cond delay="250"/>
                                   </p:stCondLst>
                                   <p:childTnLst>
                                     <p:set>
@@ -7658,7 +7697,7 @@
                                           </p:stCondLst>
                                         </p:cTn>
                                         <p:tgtEl>
-                                          <p:spTgt spid="21"/>
+                                          <p:spTgt spid="39"/>
                                         </p:tgtEl>
                                         <p:attrNameLst>
                                           <p:attrName>style.visibility</p:attrName>
@@ -7672,7 +7711,7 @@
                                       <p:cBhvr>
                                         <p:cTn id="108" dur="400"/>
                                         <p:tgtEl>
-                                          <p:spTgt spid="21"/>
+                                          <p:spTgt spid="39"/>
                                         </p:tgtEl>
                                       </p:cBhvr>
                                     </p:animEffect>
@@ -7693,7 +7732,7 @@
                                           </p:stCondLst>
                                         </p:cTn>
                                         <p:tgtEl>
-                                          <p:spTgt spid="22"/>
+                                          <p:spTgt spid="21"/>
                                         </p:tgtEl>
                                         <p:attrNameLst>
                                           <p:attrName>style.visibility</p:attrName>
@@ -7707,7 +7746,7 @@
                                       <p:cBhvr>
                                         <p:cTn id="111" dur="400"/>
                                         <p:tgtEl>
-                                          <p:spTgt spid="22"/>
+                                          <p:spTgt spid="21"/>
                                         </p:tgtEl>
                                       </p:cBhvr>
                                     </p:animEffect>
@@ -7728,6 +7767,41 @@
                                           </p:stCondLst>
                                         </p:cTn>
                                         <p:tgtEl>
+                                          <p:spTgt spid="22"/>
+                                        </p:tgtEl>
+                                        <p:attrNameLst>
+                                          <p:attrName>style.visibility</p:attrName>
+                                        </p:attrNameLst>
+                                      </p:cBhvr>
+                                      <p:to>
+                                        <p:strVal val="visible"/>
+                                      </p:to>
+                                    </p:set>
+                                    <p:animEffect transition="in" filter="fade">
+                                      <p:cBhvr>
+                                        <p:cTn id="114" dur="400"/>
+                                        <p:tgtEl>
+                                          <p:spTgt spid="22"/>
+                                        </p:tgtEl>
+                                      </p:cBhvr>
+                                    </p:animEffect>
+                                  </p:childTnLst>
+                                </p:cTn>
+                              </p:par>
+                              <p:par>
+                                <p:cTn id="115" presetID="10" presetClass="entr" presetSubtype="0" fill="hold" nodeType="withEffect">
+                                  <p:stCondLst>
+                                    <p:cond delay="250"/>
+                                  </p:stCondLst>
+                                  <p:childTnLst>
+                                    <p:set>
+                                      <p:cBhvr>
+                                        <p:cTn id="116" dur="1" fill="hold">
+                                          <p:stCondLst>
+                                            <p:cond delay="0"/>
+                                          </p:stCondLst>
+                                        </p:cTn>
+                                        <p:tgtEl>
                                           <p:spTgt spid="23"/>
                                         </p:tgtEl>
                                         <p:attrNameLst>
@@ -7740,7 +7814,7 @@
                                     </p:set>
                                     <p:animEffect transition="in" filter="fade">
                                       <p:cBhvr>
-                                        <p:cTn id="114" dur="400"/>
+                                        <p:cTn id="117" dur="400"/>
                                         <p:tgtEl>
                                           <p:spTgt spid="23"/>
                                         </p:tgtEl>
@@ -7756,56 +7830,21 @@
                     </p:cTn>
                   </p:par>
                   <p:par>
-                    <p:cTn id="115" fill="hold">
+                    <p:cTn id="118" fill="hold">
                       <p:stCondLst>
                         <p:cond delay="indefinite"/>
                       </p:stCondLst>
                       <p:childTnLst>
                         <p:par>
-                          <p:cTn id="116" fill="hold">
+                          <p:cTn id="119" fill="hold">
                             <p:stCondLst>
                               <p:cond delay="0"/>
                             </p:stCondLst>
                             <p:childTnLst>
                               <p:par>
-                                <p:cTn id="117" presetID="10" presetClass="entr" presetSubtype="0" fill="hold" nodeType="clickEffect">
+                                <p:cTn id="120" presetID="10" presetClass="entr" presetSubtype="0" fill="hold" nodeType="clickEffect">
                                   <p:stCondLst>
                                     <p:cond delay="0"/>
-                                  </p:stCondLst>
-                                  <p:childTnLst>
-                                    <p:set>
-                                      <p:cBhvr>
-                                        <p:cTn id="118" dur="1" fill="hold">
-                                          <p:stCondLst>
-                                            <p:cond delay="0"/>
-                                          </p:stCondLst>
-                                        </p:cTn>
-                                        <p:tgtEl>
-                                          <p:spTgt spid="39"/>
-                                        </p:tgtEl>
-                                        <p:attrNameLst>
-                                          <p:attrName>style.visibility</p:attrName>
-                                        </p:attrNameLst>
-                                      </p:cBhvr>
-                                      <p:to>
-                                        <p:strVal val="visible"/>
-                                      </p:to>
-                                    </p:set>
-                                    <p:animEffect transition="in" filter="fade">
-                                      <p:cBhvr>
-                                        <p:cTn id="119" dur="400"/>
-                                        <p:tgtEl>
-                                          <p:spTgt spid="39"/>
-                                        </p:tgtEl>
-                                      </p:cBhvr>
-                                    </p:animEffect>
-                                  </p:childTnLst>
-                                </p:cTn>
-                              </p:par>
-                              <p:par>
-                                <p:cTn id="120" presetID="10" presetClass="entr" presetSubtype="0" fill="hold" nodeType="withEffect">
-                                  <p:stCondLst>
-                                    <p:cond delay="250"/>
                                   </p:stCondLst>
                                   <p:childTnLst>
                                     <p:set>
@@ -7816,7 +7855,7 @@
                                           </p:stCondLst>
                                         </p:cTn>
                                         <p:tgtEl>
-                                          <p:spTgt spid="24"/>
+                                          <p:spTgt spid="40"/>
                                         </p:tgtEl>
                                         <p:attrNameLst>
                                           <p:attrName>style.visibility</p:attrName>
@@ -7830,7 +7869,7 @@
                                       <p:cBhvr>
                                         <p:cTn id="122" dur="400"/>
                                         <p:tgtEl>
-                                          <p:spTgt spid="24"/>
+                                          <p:spTgt spid="40"/>
                                         </p:tgtEl>
                                       </p:cBhvr>
                                     </p:animEffect>
@@ -7851,7 +7890,7 @@
                                           </p:stCondLst>
                                         </p:cTn>
                                         <p:tgtEl>
-                                          <p:spTgt spid="25"/>
+                                          <p:spTgt spid="24"/>
                                         </p:tgtEl>
                                         <p:attrNameLst>
                                           <p:attrName>style.visibility</p:attrName>
@@ -7865,7 +7904,7 @@
                                       <p:cBhvr>
                                         <p:cTn id="125" dur="400"/>
                                         <p:tgtEl>
-                                          <p:spTgt spid="25"/>
+                                          <p:spTgt spid="24"/>
                                         </p:tgtEl>
                                       </p:cBhvr>
                                     </p:animEffect>
@@ -7886,6 +7925,41 @@
                                           </p:stCondLst>
                                         </p:cTn>
                                         <p:tgtEl>
+                                          <p:spTgt spid="25"/>
+                                        </p:tgtEl>
+                                        <p:attrNameLst>
+                                          <p:attrName>style.visibility</p:attrName>
+                                        </p:attrNameLst>
+                                      </p:cBhvr>
+                                      <p:to>
+                                        <p:strVal val="visible"/>
+                                      </p:to>
+                                    </p:set>
+                                    <p:animEffect transition="in" filter="fade">
+                                      <p:cBhvr>
+                                        <p:cTn id="128" dur="400"/>
+                                        <p:tgtEl>
+                                          <p:spTgt spid="25"/>
+                                        </p:tgtEl>
+                                      </p:cBhvr>
+                                    </p:animEffect>
+                                  </p:childTnLst>
+                                </p:cTn>
+                              </p:par>
+                              <p:par>
+                                <p:cTn id="129" presetID="10" presetClass="entr" presetSubtype="0" fill="hold" nodeType="withEffect">
+                                  <p:stCondLst>
+                                    <p:cond delay="250"/>
+                                  </p:stCondLst>
+                                  <p:childTnLst>
+                                    <p:set>
+                                      <p:cBhvr>
+                                        <p:cTn id="130" dur="1" fill="hold">
+                                          <p:stCondLst>
+                                            <p:cond delay="0"/>
+                                          </p:stCondLst>
+                                        </p:cTn>
+                                        <p:tgtEl>
                                           <p:spTgt spid="26"/>
                                         </p:tgtEl>
                                         <p:attrNameLst>
@@ -7898,7 +7972,7 @@
                                     </p:set>
                                     <p:animEffect transition="in" filter="fade">
                                       <p:cBhvr>
-                                        <p:cTn id="128" dur="400"/>
+                                        <p:cTn id="131" dur="400"/>
                                         <p:tgtEl>
                                           <p:spTgt spid="26"/>
                                         </p:tgtEl>
@@ -7914,56 +7988,21 @@
                     </p:cTn>
                   </p:par>
                   <p:par>
-                    <p:cTn id="129" fill="hold">
+                    <p:cTn id="132" fill="hold">
                       <p:stCondLst>
                         <p:cond delay="indefinite"/>
                       </p:stCondLst>
                       <p:childTnLst>
                         <p:par>
-                          <p:cTn id="130" fill="hold">
+                          <p:cTn id="133" fill="hold">
                             <p:stCondLst>
                               <p:cond delay="0"/>
                             </p:stCondLst>
                             <p:childTnLst>
                               <p:par>
-                                <p:cTn id="131" presetID="10" presetClass="entr" presetSubtype="0" fill="hold" nodeType="clickEffect">
+                                <p:cTn id="134" presetID="10" presetClass="entr" presetSubtype="0" fill="hold" nodeType="clickEffect">
                                   <p:stCondLst>
                                     <p:cond delay="0"/>
-                                  </p:stCondLst>
-                                  <p:childTnLst>
-                                    <p:set>
-                                      <p:cBhvr>
-                                        <p:cTn id="132" dur="1" fill="hold">
-                                          <p:stCondLst>
-                                            <p:cond delay="0"/>
-                                          </p:stCondLst>
-                                        </p:cTn>
-                                        <p:tgtEl>
-                                          <p:spTgt spid="40"/>
-                                        </p:tgtEl>
-                                        <p:attrNameLst>
-                                          <p:attrName>style.visibility</p:attrName>
-                                        </p:attrNameLst>
-                                      </p:cBhvr>
-                                      <p:to>
-                                        <p:strVal val="visible"/>
-                                      </p:to>
-                                    </p:set>
-                                    <p:animEffect transition="in" filter="fade">
-                                      <p:cBhvr>
-                                        <p:cTn id="133" dur="400"/>
-                                        <p:tgtEl>
-                                          <p:spTgt spid="40"/>
-                                        </p:tgtEl>
-                                      </p:cBhvr>
-                                    </p:animEffect>
-                                  </p:childTnLst>
-                                </p:cTn>
-                              </p:par>
-                              <p:par>
-                                <p:cTn id="134" presetID="10" presetClass="entr" presetSubtype="0" fill="hold" nodeType="withEffect">
-                                  <p:stCondLst>
-                                    <p:cond delay="250"/>
                                   </p:stCondLst>
                                   <p:childTnLst>
                                     <p:set>
@@ -7974,7 +8013,7 @@
                                           </p:stCondLst>
                                         </p:cTn>
                                         <p:tgtEl>
-                                          <p:spTgt spid="27"/>
+                                          <p:spTgt spid="41"/>
                                         </p:tgtEl>
                                         <p:attrNameLst>
                                           <p:attrName>style.visibility</p:attrName>
@@ -7988,7 +8027,7 @@
                                       <p:cBhvr>
                                         <p:cTn id="136" dur="400"/>
                                         <p:tgtEl>
-                                          <p:spTgt spid="27"/>
+                                          <p:spTgt spid="41"/>
                                         </p:tgtEl>
                                       </p:cBhvr>
                                     </p:animEffect>
@@ -8009,7 +8048,7 @@
                                           </p:stCondLst>
                                         </p:cTn>
                                         <p:tgtEl>
-                                          <p:spTgt spid="28"/>
+                                          <p:spTgt spid="27"/>
                                         </p:tgtEl>
                                         <p:attrNameLst>
                                           <p:attrName>style.visibility</p:attrName>
@@ -8023,7 +8062,7 @@
                                       <p:cBhvr>
                                         <p:cTn id="139" dur="400"/>
                                         <p:tgtEl>
-                                          <p:spTgt spid="28"/>
+                                          <p:spTgt spid="27"/>
                                         </p:tgtEl>
                                       </p:cBhvr>
                                     </p:animEffect>
@@ -8044,6 +8083,41 @@
                                           </p:stCondLst>
                                         </p:cTn>
                                         <p:tgtEl>
+                                          <p:spTgt spid="28"/>
+                                        </p:tgtEl>
+                                        <p:attrNameLst>
+                                          <p:attrName>style.visibility</p:attrName>
+                                        </p:attrNameLst>
+                                      </p:cBhvr>
+                                      <p:to>
+                                        <p:strVal val="visible"/>
+                                      </p:to>
+                                    </p:set>
+                                    <p:animEffect transition="in" filter="fade">
+                                      <p:cBhvr>
+                                        <p:cTn id="142" dur="400"/>
+                                        <p:tgtEl>
+                                          <p:spTgt spid="28"/>
+                                        </p:tgtEl>
+                                      </p:cBhvr>
+                                    </p:animEffect>
+                                  </p:childTnLst>
+                                </p:cTn>
+                              </p:par>
+                              <p:par>
+                                <p:cTn id="143" presetID="10" presetClass="entr" presetSubtype="0" fill="hold" nodeType="withEffect">
+                                  <p:stCondLst>
+                                    <p:cond delay="250"/>
+                                  </p:stCondLst>
+                                  <p:childTnLst>
+                                    <p:set>
+                                      <p:cBhvr>
+                                        <p:cTn id="144" dur="1" fill="hold">
+                                          <p:stCondLst>
+                                            <p:cond delay="0"/>
+                                          </p:stCondLst>
+                                        </p:cTn>
+                                        <p:tgtEl>
                                           <p:spTgt spid="29"/>
                                         </p:tgtEl>
                                         <p:attrNameLst>
@@ -8056,7 +8130,7 @@
                                     </p:set>
                                     <p:animEffect transition="in" filter="fade">
                                       <p:cBhvr>
-                                        <p:cTn id="142" dur="400"/>
+                                        <p:cTn id="145" dur="400"/>
                                         <p:tgtEl>
                                           <p:spTgt spid="29"/>
                                         </p:tgtEl>
@@ -8072,56 +8146,21 @@
                     </p:cTn>
                   </p:par>
                   <p:par>
-                    <p:cTn id="143" fill="hold">
+                    <p:cTn id="146" fill="hold">
                       <p:stCondLst>
                         <p:cond delay="indefinite"/>
                       </p:stCondLst>
                       <p:childTnLst>
                         <p:par>
-                          <p:cTn id="144" fill="hold">
+                          <p:cTn id="147" fill="hold">
                             <p:stCondLst>
                               <p:cond delay="0"/>
                             </p:stCondLst>
                             <p:childTnLst>
                               <p:par>
-                                <p:cTn id="145" presetID="10" presetClass="entr" presetSubtype="0" fill="hold" nodeType="clickEffect">
+                                <p:cTn id="148" presetID="10" presetClass="entr" presetSubtype="0" fill="hold" nodeType="clickEffect">
                                   <p:stCondLst>
                                     <p:cond delay="0"/>
-                                  </p:stCondLst>
-                                  <p:childTnLst>
-                                    <p:set>
-                                      <p:cBhvr>
-                                        <p:cTn id="146" dur="1" fill="hold">
-                                          <p:stCondLst>
-                                            <p:cond delay="0"/>
-                                          </p:stCondLst>
-                                        </p:cTn>
-                                        <p:tgtEl>
-                                          <p:spTgt spid="41"/>
-                                        </p:tgtEl>
-                                        <p:attrNameLst>
-                                          <p:attrName>style.visibility</p:attrName>
-                                        </p:attrNameLst>
-                                      </p:cBhvr>
-                                      <p:to>
-                                        <p:strVal val="visible"/>
-                                      </p:to>
-                                    </p:set>
-                                    <p:animEffect transition="in" filter="fade">
-                                      <p:cBhvr>
-                                        <p:cTn id="147" dur="400"/>
-                                        <p:tgtEl>
-                                          <p:spTgt spid="41"/>
-                                        </p:tgtEl>
-                                      </p:cBhvr>
-                                    </p:animEffect>
-                                  </p:childTnLst>
-                                </p:cTn>
-                              </p:par>
-                              <p:par>
-                                <p:cTn id="148" presetID="10" presetClass="entr" presetSubtype="0" fill="hold" nodeType="withEffect">
-                                  <p:stCondLst>
-                                    <p:cond delay="250"/>
                                   </p:stCondLst>
                                   <p:childTnLst>
                                     <p:set>
@@ -8132,7 +8171,7 @@
                                           </p:stCondLst>
                                         </p:cTn>
                                         <p:tgtEl>
-                                          <p:spTgt spid="30"/>
+                                          <p:spTgt spid="42"/>
                                         </p:tgtEl>
                                         <p:attrNameLst>
                                           <p:attrName>style.visibility</p:attrName>
@@ -8146,7 +8185,7 @@
                                       <p:cBhvr>
                                         <p:cTn id="150" dur="400"/>
                                         <p:tgtEl>
-                                          <p:spTgt spid="30"/>
+                                          <p:spTgt spid="42"/>
                                         </p:tgtEl>
                                       </p:cBhvr>
                                     </p:animEffect>
@@ -8167,7 +8206,7 @@
                                           </p:stCondLst>
                                         </p:cTn>
                                         <p:tgtEl>
-                                          <p:spTgt spid="31"/>
+                                          <p:spTgt spid="30"/>
                                         </p:tgtEl>
                                         <p:attrNameLst>
                                           <p:attrName>style.visibility</p:attrName>
@@ -8181,7 +8220,7 @@
                                       <p:cBhvr>
                                         <p:cTn id="153" dur="400"/>
                                         <p:tgtEl>
-                                          <p:spTgt spid="31"/>
+                                          <p:spTgt spid="30"/>
                                         </p:tgtEl>
                                       </p:cBhvr>
                                     </p:animEffect>
@@ -8202,6 +8241,41 @@
                                           </p:stCondLst>
                                         </p:cTn>
                                         <p:tgtEl>
+                                          <p:spTgt spid="31"/>
+                                        </p:tgtEl>
+                                        <p:attrNameLst>
+                                          <p:attrName>style.visibility</p:attrName>
+                                        </p:attrNameLst>
+                                      </p:cBhvr>
+                                      <p:to>
+                                        <p:strVal val="visible"/>
+                                      </p:to>
+                                    </p:set>
+                                    <p:animEffect transition="in" filter="fade">
+                                      <p:cBhvr>
+                                        <p:cTn id="156" dur="400"/>
+                                        <p:tgtEl>
+                                          <p:spTgt spid="31"/>
+                                        </p:tgtEl>
+                                      </p:cBhvr>
+                                    </p:animEffect>
+                                  </p:childTnLst>
+                                </p:cTn>
+                              </p:par>
+                              <p:par>
+                                <p:cTn id="157" presetID="10" presetClass="entr" presetSubtype="0" fill="hold" nodeType="withEffect">
+                                  <p:stCondLst>
+                                    <p:cond delay="250"/>
+                                  </p:stCondLst>
+                                  <p:childTnLst>
+                                    <p:set>
+                                      <p:cBhvr>
+                                        <p:cTn id="158" dur="1" fill="hold">
+                                          <p:stCondLst>
+                                            <p:cond delay="0"/>
+                                          </p:stCondLst>
+                                        </p:cTn>
+                                        <p:tgtEl>
                                           <p:spTgt spid="32"/>
                                         </p:tgtEl>
                                         <p:attrNameLst>
@@ -8214,7 +8288,7 @@
                                     </p:set>
                                     <p:animEffect transition="in" filter="fade">
                                       <p:cBhvr>
-                                        <p:cTn id="156" dur="400"/>
+                                        <p:cTn id="159" dur="400"/>
                                         <p:tgtEl>
                                           <p:spTgt spid="32"/>
                                         </p:tgtEl>

</xml_diff>

<commit_message>
Revert "Slides: label the flowchart's drop arrow 'tool calls'"
This reverts commit fd97d9c64b51c27938bcda56df739145d15b0b7c.
</commit_message>
<xml_diff>
--- a/presentation/eduinject-slides.pptx
+++ b/presentation/eduinject-slides.pptx
@@ -119,25 +119,25 @@
   <p:extLst>
     <p:ext uri="{521415D9-36F7-43E2-AB2F-B90AF26B5E84}">
       <p14:sectionLst xmlns:p14="http://schemas.microsoft.com/office/powerpoint/2010/main">
-        <p14:section name="Opening" id="{5ba91ca0-555a-63a8-4ada-54ceb5d22e10}">
+        <p14:section name="Opening" id="{8be88736-7b8b-3d25-08e7-5e28c274fd56}">
           <p14:sldIdLst>
             <p14:sldId id="256"/>
           </p14:sldIdLst>
         </p14:section>
-        <p14:section name="Problem" id="{9f4039b9-3957-11da-be28-9691cb314857}">
+        <p14:section name="Problem" id="{9ecc8217-009b-c461-b2a3-08dae0d23963}">
           <p14:sldIdLst>
             <p14:sldId id="257"/>
             <p14:sldId id="258"/>
           </p14:sldIdLst>
         </p14:section>
-        <p14:section name="Method" id="{e51c8160-4c09-6fb1-21c7-241a1b287c1f}">
+        <p14:section name="Method" id="{39adbcb0-19e4-965d-368d-05adc9b9373c}">
           <p14:sldIdLst>
             <p14:sldId id="259"/>
             <p14:sldId id="260"/>
             <p14:sldId id="261"/>
           </p14:sldIdLst>
         </p14:section>
-        <p14:section name="Findings" id="{ff65aa06-8c3b-4c9c-00ae-8133eb81cbf2}">
+        <p14:section name="Findings" id="{c32e4738-3319-4576-37ac-3b0e31b466d2}">
           <p14:sldIdLst>
             <p14:sldId id="262"/>
             <p14:sldId id="263"/>
@@ -145,7 +145,7 @@
             <p14:sldId id="265"/>
           </p14:sldIdLst>
         </p14:section>
-        <p14:section name="Takeaways" id="{36006ebf-e206-98ad-eaf9-c6be4f10e740}">
+        <p14:section name="Takeaways" id="{9fd47a30-7223-9efc-a577-3b198366c1c1}">
           <p14:sldIdLst>
             <p14:sldId id="266"/>
             <p14:sldId id="267"/>
@@ -5772,46 +5772,7 @@
       </p:sp>
       <p:sp>
         <p:nvSpPr>
-          <p:cNvPr id="38" name="fc-a5-label"/>
-          <p:cNvSpPr txBox="1"/>
-          <p:nvPr/>
-        </p:nvSpPr>
-        <p:spPr>
-          <a:xfrm>
-            <a:off x="9563607" y="3406140"/>
-            <a:ext cx="1371600" cy="320040"/>
-          </a:xfrm>
-          <a:prstGeom prst="rect">
-            <a:avLst/>
-          </a:prstGeom>
-          <a:noFill/>
-          <a:ln/>
-        </p:spPr>
-        <p:txBody>
-          <a:bodyPr wrap="square" lIns="0" tIns="0" rIns="0" bIns="0" rtlCol="0" anchor="ctr"/>
-          <a:lstStyle/>
-          <a:p>
-            <a:pPr algn="r" indent="0" marL="0">
-              <a:buNone/>
-            </a:pPr>
-            <a:r>
-              <a:rPr lang="en-US" sz="1200" dirty="0">
-                <a:solidFill>
-                  <a:srgbClr val="5F6B66"/>
-                </a:solidFill>
-                <a:latin typeface="Lato" pitchFamily="34" charset="0"/>
-                <a:ea typeface="Lato" pitchFamily="34" charset="-122"/>
-                <a:cs typeface="Lato" pitchFamily="34" charset="-120"/>
-              </a:rPr>
-              <a:t>tool calls</a:t>
-            </a:r>
-            <a:endParaRPr lang="en-US" sz="1200" dirty="0"/>
-          </a:p>
-        </p:txBody>
-      </p:sp>
-      <p:sp>
-        <p:nvSpPr>
-          <p:cNvPr id="39" name="fc-a6"/>
+          <p:cNvPr id="38" name="fc-a6"/>
           <p:cNvSpPr/>
           <p:nvPr/>
         </p:nvSpPr>
@@ -5835,7 +5796,7 @@
       </p:sp>
       <p:sp>
         <p:nvSpPr>
-          <p:cNvPr id="40" name="fc-a7"/>
+          <p:cNvPr id="39" name="fc-a7"/>
           <p:cNvSpPr/>
           <p:nvPr/>
         </p:nvSpPr>
@@ -5859,7 +5820,7 @@
       </p:sp>
       <p:sp>
         <p:nvSpPr>
-          <p:cNvPr id="41" name="fc-a8"/>
+          <p:cNvPr id="40" name="fc-a8"/>
           <p:cNvSpPr/>
           <p:nvPr/>
         </p:nvSpPr>
@@ -5883,7 +5844,7 @@
       </p:sp>
       <p:sp>
         <p:nvSpPr>
-          <p:cNvPr id="42" name="fc-a9"/>
+          <p:cNvPr id="41" name="fc-a9"/>
           <p:cNvSpPr/>
           <p:nvPr/>
         </p:nvSpPr>
@@ -5907,7 +5868,7 @@
       </p:sp>
       <p:sp>
         <p:nvSpPr>
-          <p:cNvPr id="43" name="fc-iso-1"/>
+          <p:cNvPr id="42" name="fc-iso-1"/>
           <p:cNvSpPr/>
           <p:nvPr/>
         </p:nvSpPr>
@@ -5930,7 +5891,7 @@
       </p:sp>
       <p:sp>
         <p:nvSpPr>
-          <p:cNvPr id="44" name="fc-iso-2"/>
+          <p:cNvPr id="43" name="fc-iso-2"/>
           <p:cNvSpPr/>
           <p:nvPr/>
         </p:nvSpPr>
@@ -5953,7 +5914,7 @@
       </p:sp>
       <p:sp>
         <p:nvSpPr>
-          <p:cNvPr id="45" name="fc-iso-3"/>
+          <p:cNvPr id="44" name="fc-iso-3"/>
           <p:cNvSpPr/>
           <p:nvPr/>
         </p:nvSpPr>
@@ -5977,7 +5938,7 @@
       </p:sp>
       <p:sp>
         <p:nvSpPr>
-          <p:cNvPr id="46" name="fc-iso-4"/>
+          <p:cNvPr id="45" name="fc-iso-4"/>
           <p:cNvSpPr/>
           <p:nvPr/>
         </p:nvSpPr>
@@ -6001,7 +5962,7 @@
       </p:sp>
       <p:sp>
         <p:nvSpPr>
-          <p:cNvPr id="47" name="Text 35"/>
+          <p:cNvPr id="46" name="Text 34"/>
           <p:cNvSpPr txBox="1"/>
           <p:nvPr/>
         </p:nvSpPr>
@@ -6040,7 +6001,7 @@
       </p:sp>
       <p:sp>
         <p:nvSpPr>
-          <p:cNvPr id="48" name="Shape 36"/>
+          <p:cNvPr id="47" name="Shape 35"/>
           <p:cNvSpPr/>
           <p:nvPr/>
         </p:nvSpPr>
@@ -6062,7 +6023,7 @@
       </p:sp>
       <p:sp>
         <p:nvSpPr>
-          <p:cNvPr id="49" name="Text 37"/>
+          <p:cNvPr id="48" name="Text 36"/>
           <p:cNvSpPr txBox="1"/>
           <p:nvPr/>
         </p:nvSpPr>
@@ -6101,7 +6062,7 @@
       </p:sp>
       <p:sp>
         <p:nvSpPr>
-          <p:cNvPr id="50" name="Shape 38"/>
+          <p:cNvPr id="49" name="Shape 37"/>
           <p:cNvSpPr/>
           <p:nvPr/>
         </p:nvSpPr>
@@ -6123,7 +6084,7 @@
       </p:sp>
       <p:sp>
         <p:nvSpPr>
-          <p:cNvPr id="51" name="Text 39"/>
+          <p:cNvPr id="50" name="Text 38"/>
           <p:cNvSpPr txBox="1"/>
           <p:nvPr/>
         </p:nvSpPr>
@@ -6162,7 +6123,7 @@
       </p:sp>
       <p:sp>
         <p:nvSpPr>
-          <p:cNvPr id="52" name="Shape 40"/>
+          <p:cNvPr id="51" name="Shape 39"/>
           <p:cNvSpPr/>
           <p:nvPr/>
         </p:nvSpPr>
@@ -6184,7 +6145,7 @@
       </p:sp>
       <p:sp>
         <p:nvSpPr>
-          <p:cNvPr id="53" name="Text 41"/>
+          <p:cNvPr id="52" name="Text 40"/>
           <p:cNvSpPr txBox="1"/>
           <p:nvPr/>
         </p:nvSpPr>
@@ -6223,7 +6184,7 @@
       </p:sp>
       <p:sp>
         <p:nvSpPr>
-          <p:cNvPr id="54" name="Shape 42"/>
+          <p:cNvPr id="53" name="Shape 41"/>
           <p:cNvSpPr/>
           <p:nvPr/>
         </p:nvSpPr>
@@ -6245,7 +6206,7 @@
       </p:sp>
       <p:sp>
         <p:nvSpPr>
-          <p:cNvPr id="55" name="Text 43"/>
+          <p:cNvPr id="54" name="Text 42"/>
           <p:cNvSpPr txBox="1"/>
           <p:nvPr/>
         </p:nvSpPr>
@@ -6284,7 +6245,7 @@
       </p:sp>
       <p:sp>
         <p:nvSpPr>
-          <p:cNvPr id="56" name="Shape 44"/>
+          <p:cNvPr id="55" name="Shape 43"/>
           <p:cNvSpPr/>
           <p:nvPr/>
         </p:nvSpPr>
@@ -6306,7 +6267,7 @@
       </p:sp>
       <p:sp>
         <p:nvSpPr>
-          <p:cNvPr id="57" name="Text 45"/>
+          <p:cNvPr id="56" name="Text 44"/>
           <p:cNvSpPr txBox="1"/>
           <p:nvPr/>
         </p:nvSpPr>
@@ -6345,7 +6306,7 @@
       </p:sp>
       <p:sp>
         <p:nvSpPr>
-          <p:cNvPr id="58" name="Shape 46"/>
+          <p:cNvPr id="57" name="Shape 45"/>
           <p:cNvSpPr/>
           <p:nvPr/>
         </p:nvSpPr>
@@ -6369,7 +6330,7 @@
       </p:sp>
       <p:sp>
         <p:nvSpPr>
-          <p:cNvPr id="59" name="Text 47"/>
+          <p:cNvPr id="58" name="Text 46"/>
           <p:cNvSpPr txBox="1"/>
           <p:nvPr/>
         </p:nvSpPr>
@@ -6408,7 +6369,7 @@
       </p:sp>
       <p:sp>
         <p:nvSpPr>
-          <p:cNvPr id="60" name="Shape 48"/>
+          <p:cNvPr id="59" name="Shape 47"/>
           <p:cNvSpPr/>
           <p:nvPr/>
         </p:nvSpPr>
@@ -6432,7 +6393,7 @@
       </p:sp>
       <p:sp>
         <p:nvSpPr>
-          <p:cNvPr id="61" name="Text 49"/>
+          <p:cNvPr id="60" name="Text 48"/>
           <p:cNvSpPr txBox="1"/>
           <p:nvPr/>
         </p:nvSpPr>
@@ -6471,7 +6432,7 @@
       </p:sp>
       <p:sp>
         <p:nvSpPr>
-          <p:cNvPr id="62" name="Slide Number Placeholder 0"/>
+          <p:cNvPr id="61" name="Slide Number Placeholder 0"/>
           <p:cNvSpPr>
             <a:spLocks noGrp="1"/>
           </p:cNvSpPr>
@@ -7346,7 +7307,7 @@
                                           </p:stCondLst>
                                         </p:cTn>
                                         <p:tgtEl>
-                                          <p:spTgt spid="43"/>
+                                          <p:spTgt spid="42"/>
                                         </p:tgtEl>
                                         <p:attrNameLst>
                                           <p:attrName>style.visibility</p:attrName>
@@ -7360,7 +7321,7 @@
                                       <p:cBhvr>
                                         <p:cTn id="77" dur="400"/>
                                         <p:tgtEl>
-                                          <p:spTgt spid="43"/>
+                                          <p:spTgt spid="42"/>
                                         </p:tgtEl>
                                       </p:cBhvr>
                                     </p:animEffect>
@@ -7381,7 +7342,7 @@
                                           </p:stCondLst>
                                         </p:cTn>
                                         <p:tgtEl>
-                                          <p:spTgt spid="44"/>
+                                          <p:spTgt spid="43"/>
                                         </p:tgtEl>
                                         <p:attrNameLst>
                                           <p:attrName>style.visibility</p:attrName>
@@ -7395,7 +7356,7 @@
                                       <p:cBhvr>
                                         <p:cTn id="80" dur="400"/>
                                         <p:tgtEl>
-                                          <p:spTgt spid="44"/>
+                                          <p:spTgt spid="43"/>
                                         </p:tgtEl>
                                       </p:cBhvr>
                                     </p:animEffect>
@@ -7416,7 +7377,7 @@
                                           </p:stCondLst>
                                         </p:cTn>
                                         <p:tgtEl>
-                                          <p:spTgt spid="45"/>
+                                          <p:spTgt spid="44"/>
                                         </p:tgtEl>
                                         <p:attrNameLst>
                                           <p:attrName>style.visibility</p:attrName>
@@ -7430,7 +7391,7 @@
                                       <p:cBhvr>
                                         <p:cTn id="83" dur="400"/>
                                         <p:tgtEl>
-                                          <p:spTgt spid="45"/>
+                                          <p:spTgt spid="44"/>
                                         </p:tgtEl>
                                       </p:cBhvr>
                                     </p:animEffect>
@@ -7451,7 +7412,7 @@
                                           </p:stCondLst>
                                         </p:cTn>
                                         <p:tgtEl>
-                                          <p:spTgt spid="46"/>
+                                          <p:spTgt spid="45"/>
                                         </p:tgtEl>
                                         <p:attrNameLst>
                                           <p:attrName>style.visibility</p:attrName>
@@ -7465,7 +7426,7 @@
                                       <p:cBhvr>
                                         <p:cTn id="86" dur="400"/>
                                         <p:tgtEl>
-                                          <p:spTgt spid="46"/>
+                                          <p:spTgt spid="45"/>
                                         </p:tgtEl>
                                       </p:cBhvr>
                                     </p:animEffect>
@@ -7528,7 +7489,7 @@
                               <p:par>
                                 <p:cTn id="92" presetID="10" presetClass="entr" presetSubtype="0" fill="hold" nodeType="withEffect">
                                   <p:stCondLst>
-                                    <p:cond delay="0"/>
+                                    <p:cond delay="250"/>
                                   </p:stCondLst>
                                   <p:childTnLst>
                                     <p:set>
@@ -7539,7 +7500,7 @@
                                           </p:stCondLst>
                                         </p:cTn>
                                         <p:tgtEl>
-                                          <p:spTgt spid="38"/>
+                                          <p:spTgt spid="18"/>
                                         </p:tgtEl>
                                         <p:attrNameLst>
                                           <p:attrName>style.visibility</p:attrName>
@@ -7553,7 +7514,7 @@
                                       <p:cBhvr>
                                         <p:cTn id="94" dur="400"/>
                                         <p:tgtEl>
-                                          <p:spTgt spid="38"/>
+                                          <p:spTgt spid="18"/>
                                         </p:tgtEl>
                                       </p:cBhvr>
                                     </p:animEffect>
@@ -7574,7 +7535,7 @@
                                           </p:stCondLst>
                                         </p:cTn>
                                         <p:tgtEl>
-                                          <p:spTgt spid="18"/>
+                                          <p:spTgt spid="19"/>
                                         </p:tgtEl>
                                         <p:attrNameLst>
                                           <p:attrName>style.visibility</p:attrName>
@@ -7588,7 +7549,7 @@
                                       <p:cBhvr>
                                         <p:cTn id="97" dur="400"/>
                                         <p:tgtEl>
-                                          <p:spTgt spid="18"/>
+                                          <p:spTgt spid="19"/>
                                         </p:tgtEl>
                                       </p:cBhvr>
                                     </p:animEffect>
@@ -7609,7 +7570,7 @@
                                           </p:stCondLst>
                                         </p:cTn>
                                         <p:tgtEl>
-                                          <p:spTgt spid="19"/>
+                                          <p:spTgt spid="20"/>
                                         </p:tgtEl>
                                         <p:attrNameLst>
                                           <p:attrName>style.visibility</p:attrName>
@@ -7622,41 +7583,6 @@
                                     <p:animEffect transition="in" filter="fade">
                                       <p:cBhvr>
                                         <p:cTn id="100" dur="400"/>
-                                        <p:tgtEl>
-                                          <p:spTgt spid="19"/>
-                                        </p:tgtEl>
-                                      </p:cBhvr>
-                                    </p:animEffect>
-                                  </p:childTnLst>
-                                </p:cTn>
-                              </p:par>
-                              <p:par>
-                                <p:cTn id="101" presetID="10" presetClass="entr" presetSubtype="0" fill="hold" nodeType="withEffect">
-                                  <p:stCondLst>
-                                    <p:cond delay="250"/>
-                                  </p:stCondLst>
-                                  <p:childTnLst>
-                                    <p:set>
-                                      <p:cBhvr>
-                                        <p:cTn id="102" dur="1" fill="hold">
-                                          <p:stCondLst>
-                                            <p:cond delay="0"/>
-                                          </p:stCondLst>
-                                        </p:cTn>
-                                        <p:tgtEl>
-                                          <p:spTgt spid="20"/>
-                                        </p:tgtEl>
-                                        <p:attrNameLst>
-                                          <p:attrName>style.visibility</p:attrName>
-                                        </p:attrNameLst>
-                                      </p:cBhvr>
-                                      <p:to>
-                                        <p:strVal val="visible"/>
-                                      </p:to>
-                                    </p:set>
-                                    <p:animEffect transition="in" filter="fade">
-                                      <p:cBhvr>
-                                        <p:cTn id="103" dur="400"/>
                                         <p:tgtEl>
                                           <p:spTgt spid="20"/>
                                         </p:tgtEl>
@@ -7672,21 +7598,56 @@
                     </p:cTn>
                   </p:par>
                   <p:par>
-                    <p:cTn id="104" fill="hold">
+                    <p:cTn id="101" fill="hold">
                       <p:stCondLst>
                         <p:cond delay="indefinite"/>
                       </p:stCondLst>
                       <p:childTnLst>
                         <p:par>
-                          <p:cTn id="105" fill="hold">
+                          <p:cTn id="102" fill="hold">
                             <p:stCondLst>
                               <p:cond delay="0"/>
                             </p:stCondLst>
                             <p:childTnLst>
                               <p:par>
-                                <p:cTn id="106" presetID="10" presetClass="entr" presetSubtype="0" fill="hold" nodeType="clickEffect">
+                                <p:cTn id="103" presetID="10" presetClass="entr" presetSubtype="0" fill="hold" nodeType="clickEffect">
                                   <p:stCondLst>
                                     <p:cond delay="0"/>
+                                  </p:stCondLst>
+                                  <p:childTnLst>
+                                    <p:set>
+                                      <p:cBhvr>
+                                        <p:cTn id="104" dur="1" fill="hold">
+                                          <p:stCondLst>
+                                            <p:cond delay="0"/>
+                                          </p:stCondLst>
+                                        </p:cTn>
+                                        <p:tgtEl>
+                                          <p:spTgt spid="38"/>
+                                        </p:tgtEl>
+                                        <p:attrNameLst>
+                                          <p:attrName>style.visibility</p:attrName>
+                                        </p:attrNameLst>
+                                      </p:cBhvr>
+                                      <p:to>
+                                        <p:strVal val="visible"/>
+                                      </p:to>
+                                    </p:set>
+                                    <p:animEffect transition="in" filter="fade">
+                                      <p:cBhvr>
+                                        <p:cTn id="105" dur="400"/>
+                                        <p:tgtEl>
+                                          <p:spTgt spid="38"/>
+                                        </p:tgtEl>
+                                      </p:cBhvr>
+                                    </p:animEffect>
+                                  </p:childTnLst>
+                                </p:cTn>
+                              </p:par>
+                              <p:par>
+                                <p:cTn id="106" presetID="10" presetClass="entr" presetSubtype="0" fill="hold" nodeType="withEffect">
+                                  <p:stCondLst>
+                                    <p:cond delay="250"/>
                                   </p:stCondLst>
                                   <p:childTnLst>
                                     <p:set>
@@ -7697,7 +7658,7 @@
                                           </p:stCondLst>
                                         </p:cTn>
                                         <p:tgtEl>
-                                          <p:spTgt spid="39"/>
+                                          <p:spTgt spid="21"/>
                                         </p:tgtEl>
                                         <p:attrNameLst>
                                           <p:attrName>style.visibility</p:attrName>
@@ -7711,7 +7672,7 @@
                                       <p:cBhvr>
                                         <p:cTn id="108" dur="400"/>
                                         <p:tgtEl>
-                                          <p:spTgt spid="39"/>
+                                          <p:spTgt spid="21"/>
                                         </p:tgtEl>
                                       </p:cBhvr>
                                     </p:animEffect>
@@ -7732,7 +7693,7 @@
                                           </p:stCondLst>
                                         </p:cTn>
                                         <p:tgtEl>
-                                          <p:spTgt spid="21"/>
+                                          <p:spTgt spid="22"/>
                                         </p:tgtEl>
                                         <p:attrNameLst>
                                           <p:attrName>style.visibility</p:attrName>
@@ -7746,7 +7707,7 @@
                                       <p:cBhvr>
                                         <p:cTn id="111" dur="400"/>
                                         <p:tgtEl>
-                                          <p:spTgt spid="21"/>
+                                          <p:spTgt spid="22"/>
                                         </p:tgtEl>
                                       </p:cBhvr>
                                     </p:animEffect>
@@ -7767,7 +7728,7 @@
                                           </p:stCondLst>
                                         </p:cTn>
                                         <p:tgtEl>
-                                          <p:spTgt spid="22"/>
+                                          <p:spTgt spid="23"/>
                                         </p:tgtEl>
                                         <p:attrNameLst>
                                           <p:attrName>style.visibility</p:attrName>
@@ -7780,41 +7741,6 @@
                                     <p:animEffect transition="in" filter="fade">
                                       <p:cBhvr>
                                         <p:cTn id="114" dur="400"/>
-                                        <p:tgtEl>
-                                          <p:spTgt spid="22"/>
-                                        </p:tgtEl>
-                                      </p:cBhvr>
-                                    </p:animEffect>
-                                  </p:childTnLst>
-                                </p:cTn>
-                              </p:par>
-                              <p:par>
-                                <p:cTn id="115" presetID="10" presetClass="entr" presetSubtype="0" fill="hold" nodeType="withEffect">
-                                  <p:stCondLst>
-                                    <p:cond delay="250"/>
-                                  </p:stCondLst>
-                                  <p:childTnLst>
-                                    <p:set>
-                                      <p:cBhvr>
-                                        <p:cTn id="116" dur="1" fill="hold">
-                                          <p:stCondLst>
-                                            <p:cond delay="0"/>
-                                          </p:stCondLst>
-                                        </p:cTn>
-                                        <p:tgtEl>
-                                          <p:spTgt spid="23"/>
-                                        </p:tgtEl>
-                                        <p:attrNameLst>
-                                          <p:attrName>style.visibility</p:attrName>
-                                        </p:attrNameLst>
-                                      </p:cBhvr>
-                                      <p:to>
-                                        <p:strVal val="visible"/>
-                                      </p:to>
-                                    </p:set>
-                                    <p:animEffect transition="in" filter="fade">
-                                      <p:cBhvr>
-                                        <p:cTn id="117" dur="400"/>
                                         <p:tgtEl>
                                           <p:spTgt spid="23"/>
                                         </p:tgtEl>
@@ -7830,21 +7756,56 @@
                     </p:cTn>
                   </p:par>
                   <p:par>
-                    <p:cTn id="118" fill="hold">
+                    <p:cTn id="115" fill="hold">
                       <p:stCondLst>
                         <p:cond delay="indefinite"/>
                       </p:stCondLst>
                       <p:childTnLst>
                         <p:par>
-                          <p:cTn id="119" fill="hold">
+                          <p:cTn id="116" fill="hold">
                             <p:stCondLst>
                               <p:cond delay="0"/>
                             </p:stCondLst>
                             <p:childTnLst>
                               <p:par>
-                                <p:cTn id="120" presetID="10" presetClass="entr" presetSubtype="0" fill="hold" nodeType="clickEffect">
+                                <p:cTn id="117" presetID="10" presetClass="entr" presetSubtype="0" fill="hold" nodeType="clickEffect">
                                   <p:stCondLst>
                                     <p:cond delay="0"/>
+                                  </p:stCondLst>
+                                  <p:childTnLst>
+                                    <p:set>
+                                      <p:cBhvr>
+                                        <p:cTn id="118" dur="1" fill="hold">
+                                          <p:stCondLst>
+                                            <p:cond delay="0"/>
+                                          </p:stCondLst>
+                                        </p:cTn>
+                                        <p:tgtEl>
+                                          <p:spTgt spid="39"/>
+                                        </p:tgtEl>
+                                        <p:attrNameLst>
+                                          <p:attrName>style.visibility</p:attrName>
+                                        </p:attrNameLst>
+                                      </p:cBhvr>
+                                      <p:to>
+                                        <p:strVal val="visible"/>
+                                      </p:to>
+                                    </p:set>
+                                    <p:animEffect transition="in" filter="fade">
+                                      <p:cBhvr>
+                                        <p:cTn id="119" dur="400"/>
+                                        <p:tgtEl>
+                                          <p:spTgt spid="39"/>
+                                        </p:tgtEl>
+                                      </p:cBhvr>
+                                    </p:animEffect>
+                                  </p:childTnLst>
+                                </p:cTn>
+                              </p:par>
+                              <p:par>
+                                <p:cTn id="120" presetID="10" presetClass="entr" presetSubtype="0" fill="hold" nodeType="withEffect">
+                                  <p:stCondLst>
+                                    <p:cond delay="250"/>
                                   </p:stCondLst>
                                   <p:childTnLst>
                                     <p:set>
@@ -7855,7 +7816,7 @@
                                           </p:stCondLst>
                                         </p:cTn>
                                         <p:tgtEl>
-                                          <p:spTgt spid="40"/>
+                                          <p:spTgt spid="24"/>
                                         </p:tgtEl>
                                         <p:attrNameLst>
                                           <p:attrName>style.visibility</p:attrName>
@@ -7869,7 +7830,7 @@
                                       <p:cBhvr>
                                         <p:cTn id="122" dur="400"/>
                                         <p:tgtEl>
-                                          <p:spTgt spid="40"/>
+                                          <p:spTgt spid="24"/>
                                         </p:tgtEl>
                                       </p:cBhvr>
                                     </p:animEffect>
@@ -7890,7 +7851,7 @@
                                           </p:stCondLst>
                                         </p:cTn>
                                         <p:tgtEl>
-                                          <p:spTgt spid="24"/>
+                                          <p:spTgt spid="25"/>
                                         </p:tgtEl>
                                         <p:attrNameLst>
                                           <p:attrName>style.visibility</p:attrName>
@@ -7904,7 +7865,7 @@
                                       <p:cBhvr>
                                         <p:cTn id="125" dur="400"/>
                                         <p:tgtEl>
-                                          <p:spTgt spid="24"/>
+                                          <p:spTgt spid="25"/>
                                         </p:tgtEl>
                                       </p:cBhvr>
                                     </p:animEffect>
@@ -7925,7 +7886,7 @@
                                           </p:stCondLst>
                                         </p:cTn>
                                         <p:tgtEl>
-                                          <p:spTgt spid="25"/>
+                                          <p:spTgt spid="26"/>
                                         </p:tgtEl>
                                         <p:attrNameLst>
                                           <p:attrName>style.visibility</p:attrName>
@@ -7938,41 +7899,6 @@
                                     <p:animEffect transition="in" filter="fade">
                                       <p:cBhvr>
                                         <p:cTn id="128" dur="400"/>
-                                        <p:tgtEl>
-                                          <p:spTgt spid="25"/>
-                                        </p:tgtEl>
-                                      </p:cBhvr>
-                                    </p:animEffect>
-                                  </p:childTnLst>
-                                </p:cTn>
-                              </p:par>
-                              <p:par>
-                                <p:cTn id="129" presetID="10" presetClass="entr" presetSubtype="0" fill="hold" nodeType="withEffect">
-                                  <p:stCondLst>
-                                    <p:cond delay="250"/>
-                                  </p:stCondLst>
-                                  <p:childTnLst>
-                                    <p:set>
-                                      <p:cBhvr>
-                                        <p:cTn id="130" dur="1" fill="hold">
-                                          <p:stCondLst>
-                                            <p:cond delay="0"/>
-                                          </p:stCondLst>
-                                        </p:cTn>
-                                        <p:tgtEl>
-                                          <p:spTgt spid="26"/>
-                                        </p:tgtEl>
-                                        <p:attrNameLst>
-                                          <p:attrName>style.visibility</p:attrName>
-                                        </p:attrNameLst>
-                                      </p:cBhvr>
-                                      <p:to>
-                                        <p:strVal val="visible"/>
-                                      </p:to>
-                                    </p:set>
-                                    <p:animEffect transition="in" filter="fade">
-                                      <p:cBhvr>
-                                        <p:cTn id="131" dur="400"/>
                                         <p:tgtEl>
                                           <p:spTgt spid="26"/>
                                         </p:tgtEl>
@@ -7988,21 +7914,56 @@
                     </p:cTn>
                   </p:par>
                   <p:par>
-                    <p:cTn id="132" fill="hold">
+                    <p:cTn id="129" fill="hold">
                       <p:stCondLst>
                         <p:cond delay="indefinite"/>
                       </p:stCondLst>
                       <p:childTnLst>
                         <p:par>
-                          <p:cTn id="133" fill="hold">
+                          <p:cTn id="130" fill="hold">
                             <p:stCondLst>
                               <p:cond delay="0"/>
                             </p:stCondLst>
                             <p:childTnLst>
                               <p:par>
-                                <p:cTn id="134" presetID="10" presetClass="entr" presetSubtype="0" fill="hold" nodeType="clickEffect">
+                                <p:cTn id="131" presetID="10" presetClass="entr" presetSubtype="0" fill="hold" nodeType="clickEffect">
                                   <p:stCondLst>
                                     <p:cond delay="0"/>
+                                  </p:stCondLst>
+                                  <p:childTnLst>
+                                    <p:set>
+                                      <p:cBhvr>
+                                        <p:cTn id="132" dur="1" fill="hold">
+                                          <p:stCondLst>
+                                            <p:cond delay="0"/>
+                                          </p:stCondLst>
+                                        </p:cTn>
+                                        <p:tgtEl>
+                                          <p:spTgt spid="40"/>
+                                        </p:tgtEl>
+                                        <p:attrNameLst>
+                                          <p:attrName>style.visibility</p:attrName>
+                                        </p:attrNameLst>
+                                      </p:cBhvr>
+                                      <p:to>
+                                        <p:strVal val="visible"/>
+                                      </p:to>
+                                    </p:set>
+                                    <p:animEffect transition="in" filter="fade">
+                                      <p:cBhvr>
+                                        <p:cTn id="133" dur="400"/>
+                                        <p:tgtEl>
+                                          <p:spTgt spid="40"/>
+                                        </p:tgtEl>
+                                      </p:cBhvr>
+                                    </p:animEffect>
+                                  </p:childTnLst>
+                                </p:cTn>
+                              </p:par>
+                              <p:par>
+                                <p:cTn id="134" presetID="10" presetClass="entr" presetSubtype="0" fill="hold" nodeType="withEffect">
+                                  <p:stCondLst>
+                                    <p:cond delay="250"/>
                                   </p:stCondLst>
                                   <p:childTnLst>
                                     <p:set>
@@ -8013,7 +7974,7 @@
                                           </p:stCondLst>
                                         </p:cTn>
                                         <p:tgtEl>
-                                          <p:spTgt spid="41"/>
+                                          <p:spTgt spid="27"/>
                                         </p:tgtEl>
                                         <p:attrNameLst>
                                           <p:attrName>style.visibility</p:attrName>
@@ -8027,7 +7988,7 @@
                                       <p:cBhvr>
                                         <p:cTn id="136" dur="400"/>
                                         <p:tgtEl>
-                                          <p:spTgt spid="41"/>
+                                          <p:spTgt spid="27"/>
                                         </p:tgtEl>
                                       </p:cBhvr>
                                     </p:animEffect>
@@ -8048,7 +8009,7 @@
                                           </p:stCondLst>
                                         </p:cTn>
                                         <p:tgtEl>
-                                          <p:spTgt spid="27"/>
+                                          <p:spTgt spid="28"/>
                                         </p:tgtEl>
                                         <p:attrNameLst>
                                           <p:attrName>style.visibility</p:attrName>
@@ -8062,7 +8023,7 @@
                                       <p:cBhvr>
                                         <p:cTn id="139" dur="400"/>
                                         <p:tgtEl>
-                                          <p:spTgt spid="27"/>
+                                          <p:spTgt spid="28"/>
                                         </p:tgtEl>
                                       </p:cBhvr>
                                     </p:animEffect>
@@ -8083,7 +8044,7 @@
                                           </p:stCondLst>
                                         </p:cTn>
                                         <p:tgtEl>
-                                          <p:spTgt spid="28"/>
+                                          <p:spTgt spid="29"/>
                                         </p:tgtEl>
                                         <p:attrNameLst>
                                           <p:attrName>style.visibility</p:attrName>
@@ -8096,41 +8057,6 @@
                                     <p:animEffect transition="in" filter="fade">
                                       <p:cBhvr>
                                         <p:cTn id="142" dur="400"/>
-                                        <p:tgtEl>
-                                          <p:spTgt spid="28"/>
-                                        </p:tgtEl>
-                                      </p:cBhvr>
-                                    </p:animEffect>
-                                  </p:childTnLst>
-                                </p:cTn>
-                              </p:par>
-                              <p:par>
-                                <p:cTn id="143" presetID="10" presetClass="entr" presetSubtype="0" fill="hold" nodeType="withEffect">
-                                  <p:stCondLst>
-                                    <p:cond delay="250"/>
-                                  </p:stCondLst>
-                                  <p:childTnLst>
-                                    <p:set>
-                                      <p:cBhvr>
-                                        <p:cTn id="144" dur="1" fill="hold">
-                                          <p:stCondLst>
-                                            <p:cond delay="0"/>
-                                          </p:stCondLst>
-                                        </p:cTn>
-                                        <p:tgtEl>
-                                          <p:spTgt spid="29"/>
-                                        </p:tgtEl>
-                                        <p:attrNameLst>
-                                          <p:attrName>style.visibility</p:attrName>
-                                        </p:attrNameLst>
-                                      </p:cBhvr>
-                                      <p:to>
-                                        <p:strVal val="visible"/>
-                                      </p:to>
-                                    </p:set>
-                                    <p:animEffect transition="in" filter="fade">
-                                      <p:cBhvr>
-                                        <p:cTn id="145" dur="400"/>
                                         <p:tgtEl>
                                           <p:spTgt spid="29"/>
                                         </p:tgtEl>
@@ -8146,21 +8072,56 @@
                     </p:cTn>
                   </p:par>
                   <p:par>
-                    <p:cTn id="146" fill="hold">
+                    <p:cTn id="143" fill="hold">
                       <p:stCondLst>
                         <p:cond delay="indefinite"/>
                       </p:stCondLst>
                       <p:childTnLst>
                         <p:par>
-                          <p:cTn id="147" fill="hold">
+                          <p:cTn id="144" fill="hold">
                             <p:stCondLst>
                               <p:cond delay="0"/>
                             </p:stCondLst>
                             <p:childTnLst>
                               <p:par>
-                                <p:cTn id="148" presetID="10" presetClass="entr" presetSubtype="0" fill="hold" nodeType="clickEffect">
+                                <p:cTn id="145" presetID="10" presetClass="entr" presetSubtype="0" fill="hold" nodeType="clickEffect">
                                   <p:stCondLst>
                                     <p:cond delay="0"/>
+                                  </p:stCondLst>
+                                  <p:childTnLst>
+                                    <p:set>
+                                      <p:cBhvr>
+                                        <p:cTn id="146" dur="1" fill="hold">
+                                          <p:stCondLst>
+                                            <p:cond delay="0"/>
+                                          </p:stCondLst>
+                                        </p:cTn>
+                                        <p:tgtEl>
+                                          <p:spTgt spid="41"/>
+                                        </p:tgtEl>
+                                        <p:attrNameLst>
+                                          <p:attrName>style.visibility</p:attrName>
+                                        </p:attrNameLst>
+                                      </p:cBhvr>
+                                      <p:to>
+                                        <p:strVal val="visible"/>
+                                      </p:to>
+                                    </p:set>
+                                    <p:animEffect transition="in" filter="fade">
+                                      <p:cBhvr>
+                                        <p:cTn id="147" dur="400"/>
+                                        <p:tgtEl>
+                                          <p:spTgt spid="41"/>
+                                        </p:tgtEl>
+                                      </p:cBhvr>
+                                    </p:animEffect>
+                                  </p:childTnLst>
+                                </p:cTn>
+                              </p:par>
+                              <p:par>
+                                <p:cTn id="148" presetID="10" presetClass="entr" presetSubtype="0" fill="hold" nodeType="withEffect">
+                                  <p:stCondLst>
+                                    <p:cond delay="250"/>
                                   </p:stCondLst>
                                   <p:childTnLst>
                                     <p:set>
@@ -8171,7 +8132,7 @@
                                           </p:stCondLst>
                                         </p:cTn>
                                         <p:tgtEl>
-                                          <p:spTgt spid="42"/>
+                                          <p:spTgt spid="30"/>
                                         </p:tgtEl>
                                         <p:attrNameLst>
                                           <p:attrName>style.visibility</p:attrName>
@@ -8185,7 +8146,7 @@
                                       <p:cBhvr>
                                         <p:cTn id="150" dur="400"/>
                                         <p:tgtEl>
-                                          <p:spTgt spid="42"/>
+                                          <p:spTgt spid="30"/>
                                         </p:tgtEl>
                                       </p:cBhvr>
                                     </p:animEffect>
@@ -8206,7 +8167,7 @@
                                           </p:stCondLst>
                                         </p:cTn>
                                         <p:tgtEl>
-                                          <p:spTgt spid="30"/>
+                                          <p:spTgt spid="31"/>
                                         </p:tgtEl>
                                         <p:attrNameLst>
                                           <p:attrName>style.visibility</p:attrName>
@@ -8220,7 +8181,7 @@
                                       <p:cBhvr>
                                         <p:cTn id="153" dur="400"/>
                                         <p:tgtEl>
-                                          <p:spTgt spid="30"/>
+                                          <p:spTgt spid="31"/>
                                         </p:tgtEl>
                                       </p:cBhvr>
                                     </p:animEffect>
@@ -8241,7 +8202,7 @@
                                           </p:stCondLst>
                                         </p:cTn>
                                         <p:tgtEl>
-                                          <p:spTgt spid="31"/>
+                                          <p:spTgt spid="32"/>
                                         </p:tgtEl>
                                         <p:attrNameLst>
                                           <p:attrName>style.visibility</p:attrName>
@@ -8254,41 +8215,6 @@
                                     <p:animEffect transition="in" filter="fade">
                                       <p:cBhvr>
                                         <p:cTn id="156" dur="400"/>
-                                        <p:tgtEl>
-                                          <p:spTgt spid="31"/>
-                                        </p:tgtEl>
-                                      </p:cBhvr>
-                                    </p:animEffect>
-                                  </p:childTnLst>
-                                </p:cTn>
-                              </p:par>
-                              <p:par>
-                                <p:cTn id="157" presetID="10" presetClass="entr" presetSubtype="0" fill="hold" nodeType="withEffect">
-                                  <p:stCondLst>
-                                    <p:cond delay="250"/>
-                                  </p:stCondLst>
-                                  <p:childTnLst>
-                                    <p:set>
-                                      <p:cBhvr>
-                                        <p:cTn id="158" dur="1" fill="hold">
-                                          <p:stCondLst>
-                                            <p:cond delay="0"/>
-                                          </p:stCondLst>
-                                        </p:cTn>
-                                        <p:tgtEl>
-                                          <p:spTgt spid="32"/>
-                                        </p:tgtEl>
-                                        <p:attrNameLst>
-                                          <p:attrName>style.visibility</p:attrName>
-                                        </p:attrNameLst>
-                                      </p:cBhvr>
-                                      <p:to>
-                                        <p:strVal val="visible"/>
-                                      </p:to>
-                                    </p:set>
-                                    <p:animEffect transition="in" filter="fade">
-                                      <p:cBhvr>
-                                        <p:cTn id="159" dur="400"/>
                                         <p:tgtEl>
                                           <p:spTgt spid="32"/>
                                         </p:tgtEl>

</xml_diff>

<commit_message>
Slides: vector title illustration; title names match the poster
- title-art.svg (document with hidden note -> intake/analysis/action ->
  email out) embedded as a real SVG with a PNG fallback, the way
  PowerPoint stores inserted SVGs.
- Names block: four names in bold, then 'Advisor: Patricia Tamburelli',
  matching the poster header.
</commit_message>
<xml_diff>
--- a/presentation/eduinject-slides.pptx
+++ b/presentation/eduinject-slides.pptx
@@ -119,25 +119,25 @@
   <p:extLst>
     <p:ext uri="{521415D9-36F7-43E2-AB2F-B90AF26B5E84}">
       <p14:sectionLst xmlns:p14="http://schemas.microsoft.com/office/powerpoint/2010/main">
-        <p14:section name="Opening" id="{8be88736-7b8b-3d25-08e7-5e28c274fd56}">
+        <p14:section name="Opening" id="{37223656-a70c-000c-17a1-dfa00d77e7d7}">
           <p14:sldIdLst>
             <p14:sldId id="256"/>
           </p14:sldIdLst>
         </p14:section>
-        <p14:section name="Problem" id="{9ecc8217-009b-c461-b2a3-08dae0d23963}">
+        <p14:section name="Problem" id="{4a32b9d6-a272-6d8a-6ae6-ca28249bad77}">
           <p14:sldIdLst>
             <p14:sldId id="257"/>
             <p14:sldId id="258"/>
           </p14:sldIdLst>
         </p14:section>
-        <p14:section name="Method" id="{39adbcb0-19e4-965d-368d-05adc9b9373c}">
+        <p14:section name="Method" id="{f51bc367-464f-e305-8d48-698633642fe5}">
           <p14:sldIdLst>
             <p14:sldId id="259"/>
             <p14:sldId id="260"/>
             <p14:sldId id="261"/>
           </p14:sldIdLst>
         </p14:section>
-        <p14:section name="Findings" id="{c32e4738-3319-4576-37ac-3b0e31b466d2}">
+        <p14:section name="Findings" id="{c2ea525a-34f5-b0cc-cff8-52bda31e4f28}">
           <p14:sldIdLst>
             <p14:sldId id="262"/>
             <p14:sldId id="263"/>
@@ -145,7 +145,7 @@
             <p14:sldId id="265"/>
           </p14:sldIdLst>
         </p14:section>
-        <p14:section name="Takeaways" id="{9fd47a30-7223-9efc-a577-3b198366c1c1}">
+        <p14:section name="Takeaways" id="{30c4b332-1d2e-98be-2fbb-f6db93e5968d}">
           <p14:sldIdLst>
             <p14:sldId id="266"/>
             <p14:sldId id="267"/>
@@ -3704,7 +3704,7 @@
         <p:spPr>
           <a:xfrm>
             <a:off x="548640" y="3611880"/>
-            <a:ext cx="11064240" cy="822960"/>
+            <a:ext cx="6766560" cy="914400"/>
           </a:xfrm>
           <a:prstGeom prst="rect">
             <a:avLst/>
@@ -3742,8 +3742,8 @@
         </p:nvSpPr>
         <p:spPr>
           <a:xfrm>
-            <a:off x="548640" y="5074920"/>
-            <a:ext cx="10515600" cy="365760"/>
+            <a:off x="548640" y="4983480"/>
+            <a:ext cx="6949440" cy="731520"/>
           </a:xfrm>
           <a:prstGeom prst="rect">
             <a:avLst/>
@@ -3756,10 +3756,13 @@
           <a:lstStyle/>
           <a:p>
             <a:pPr indent="0" marL="0">
+              <a:lnSpc>
+                <a:spcPct val="130000"/>
+              </a:lnSpc>
               <a:buNone/>
             </a:pPr>
             <a:r>
-              <a:rPr lang="en-US" sz="1600" dirty="0">
+              <a:rPr lang="en-US" sz="1500" b="1" dirty="0">
                 <a:solidFill>
                   <a:srgbClr val="FFFFFF"/>
                 </a:solidFill>
@@ -3767,38 +3770,19 @@
                 <a:ea typeface="Lato" pitchFamily="34" charset="-122"/>
                 <a:cs typeface="Lato" pitchFamily="34" charset="-120"/>
               </a:rPr>
-              <a:t>Aryan Mittal*   Rohan Bhamidipati*   Chaitanya Palasamudrum   Bibhuti Swain</a:t>
-            </a:r>
-            <a:endParaRPr lang="en-US" sz="1600" dirty="0"/>
-          </a:p>
-        </p:txBody>
-      </p:sp>
-      <p:sp>
-        <p:nvSpPr>
-          <p:cNvPr id="5" name="Text 3"/>
-          <p:cNvSpPr txBox="1"/>
-          <p:nvPr/>
-        </p:nvSpPr>
-        <p:spPr>
-          <a:xfrm>
-            <a:off x="548640" y="5486400"/>
-            <a:ext cx="10515600" cy="320040"/>
-          </a:xfrm>
-          <a:prstGeom prst="rect">
-            <a:avLst/>
-          </a:prstGeom>
-          <a:noFill/>
-          <a:ln/>
-        </p:spPr>
-        <p:txBody>
-          <a:bodyPr wrap="square" lIns="0" tIns="0" rIns="0" bIns="0" rtlCol="0" anchor="ctr"/>
-          <a:lstStyle/>
+              <a:t>Aryan Mittal,  Rohan Bhamidipati,  Chaitanya Palasamudrum,  Bibhuti Swain</a:t>
+            </a:r>
+            <a:endParaRPr lang="en-US" sz="1500" dirty="0"/>
+          </a:p>
           <a:p>
             <a:pPr indent="0" marL="0">
+              <a:lnSpc>
+                <a:spcPct val="130000"/>
+              </a:lnSpc>
               <a:buNone/>
             </a:pPr>
             <a:r>
-              <a:rPr lang="en-US" sz="1200" dirty="0">
+              <a:rPr lang="en-US" sz="1500" dirty="0">
                 <a:solidFill>
                   <a:srgbClr val="B9C4BF"/>
                 </a:solidFill>
@@ -3806,12 +3790,42 @@
                 <a:ea typeface="Lato" pitchFamily="34" charset="-122"/>
                 <a:cs typeface="Lato" pitchFamily="34" charset="-120"/>
               </a:rPr>
-              <a:t>NJCCIC Advanced Cybersecurity Internship Program  ·  October 2026  ·  *equal contribution</a:t>
-            </a:r>
-            <a:endParaRPr lang="en-US" sz="1200" dirty="0"/>
-          </a:p>
-        </p:txBody>
-      </p:sp>
+              <a:t>Advisor: Patricia Tamburelli</a:t>
+            </a:r>
+            <a:endParaRPr lang="en-US" sz="1500" dirty="0"/>
+          </a:p>
+        </p:txBody>
+      </p:sp>
+      <p:pic>
+        <p:nvPicPr>
+          <p:cNvPr id="5" name="title-art" descr="preencoded.png">    </p:cNvPr>
+          <p:cNvPicPr>
+            <a:picLocks noChangeAspect="1"/>
+          </p:cNvPicPr>
+          <p:nvPr/>
+        </p:nvPicPr>
+        <p:blipFill>
+          <a:blip r:embed="rId1">
+            <a:extLst>
+              <a:ext uri="{96DAC541-7B7A-43D3-8B79-37D633B846F1}">
+                <asvg:svgBlip xmlns:asvg="http://schemas.microsoft.com/office/drawing/2016/SVG/main" r:embed="rId4"/>
+              </a:ext>
+            </a:extLst>
+          </a:blip>
+          <a:stretch>
+            <a:fillRect/>
+          </a:stretch>
+        </p:blipFill>
+        <p:spPr>
+          <a:xfrm>
+            <a:off x="7635240" y="1051560"/>
+            <a:ext cx="3931920" cy="4587240"/>
+          </a:xfrm>
+          <a:prstGeom prst="rect">
+            <a:avLst/>
+          </a:prstGeom>
+        </p:spPr>
+      </p:pic>
     </p:spTree>
   </p:cSld>
   <p:clrMapOvr>

</xml_diff>

<commit_message>
Slides: full paper title on the title slide in place of short name + subtitle
</commit_message>
<xml_diff>
--- a/presentation/eduinject-slides.pptx
+++ b/presentation/eduinject-slides.pptx
@@ -119,25 +119,25 @@
   <p:extLst>
     <p:ext uri="{521415D9-36F7-43E2-AB2F-B90AF26B5E84}">
       <p14:sectionLst xmlns:p14="http://schemas.microsoft.com/office/powerpoint/2010/main">
-        <p14:section name="Opening" id="{37223656-a70c-000c-17a1-dfa00d77e7d7}">
+        <p14:section name="Opening" id="{010025e6-24b6-5fcd-ac0a-5de39626cc49}">
           <p14:sldIdLst>
             <p14:sldId id="256"/>
           </p14:sldIdLst>
         </p14:section>
-        <p14:section name="Problem" id="{4a32b9d6-a272-6d8a-6ae6-ca28249bad77}">
+        <p14:section name="Problem" id="{60a85fce-a8c9-2c1f-430a-f903268fb1e5}">
           <p14:sldIdLst>
             <p14:sldId id="257"/>
             <p14:sldId id="258"/>
           </p14:sldIdLst>
         </p14:section>
-        <p14:section name="Method" id="{f51bc367-464f-e305-8d48-698633642fe5}">
+        <p14:section name="Method" id="{e28560ca-f3a3-f92a-2d8f-01346c9a493b}">
           <p14:sldIdLst>
             <p14:sldId id="259"/>
             <p14:sldId id="260"/>
             <p14:sldId id="261"/>
           </p14:sldIdLst>
         </p14:section>
-        <p14:section name="Findings" id="{c2ea525a-34f5-b0cc-cff8-52bda31e4f28}">
+        <p14:section name="Findings" id="{27fa555e-9a33-0a4b-108f-64a01e22004b}">
           <p14:sldIdLst>
             <p14:sldId id="262"/>
             <p14:sldId id="263"/>
@@ -145,7 +145,7 @@
             <p14:sldId id="265"/>
           </p14:sldIdLst>
         </p14:section>
-        <p14:section name="Takeaways" id="{30c4b332-1d2e-98be-2fbb-f6db93e5968d}">
+        <p14:section name="Takeaways" id="{02b3a5b5-1f36-c852-0ff5-8ff2bac16ef5}">
           <p14:sldIdLst>
             <p14:sldId id="266"/>
             <p14:sldId id="267"/>
@@ -2989,8 +2989,8 @@
         </p:nvSpPr>
         <p:spPr>
           <a:xfrm>
-            <a:off x="548640" y="2011680"/>
-            <a:ext cx="11094415" cy="1463040"/>
+            <a:off x="548640" y="1097280"/>
+            <a:ext cx="6858000" cy="3291840"/>
           </a:xfrm>
           <a:prstGeom prst="rect">
             <a:avLst/>
@@ -3003,7 +3003,7 @@
           <a:lstStyle>
             <a:lvl1pPr algn="l" indent="0" marL="0">
               <a:buNone/>
-              <a:defRPr lang="en-US" sz="6000" b="1" dirty="0">
+              <a:defRPr lang="en-US" sz="4000" b="1" dirty="0">
                 <a:solidFill>
                   <a:schemeClr val="bg1"/>
                 </a:solidFill>
@@ -3017,7 +3017,7 @@
             <a:pPr algn="l" indent="0" marL="0">
               <a:buNone/>
             </a:pPr>
-            <a:endParaRPr lang="en-US" sz="6000" dirty="0"/>
+            <a:endParaRPr lang="en-US" sz="4000" dirty="0"/>
           </a:p>
         </p:txBody>
       </p:sp>
@@ -3664,8 +3664,8 @@
         </p:nvSpPr>
         <p:spPr>
           <a:xfrm>
-            <a:off x="548640" y="2011680"/>
-            <a:ext cx="11094415" cy="1463040"/>
+            <a:off x="548640" y="1097280"/>
+            <a:ext cx="6858000" cy="3291840"/>
           </a:xfrm>
           <a:prstGeom prst="rect">
             <a:avLst/>
@@ -3681,7 +3681,7 @@
               <a:buNone/>
             </a:pPr>
             <a:r>
-              <a:rPr lang="en-US" sz="6000" b="1" dirty="0">
+              <a:rPr lang="en-US" sz="4000" b="1" dirty="0">
                 <a:solidFill>
                   <a:schemeClr val="bg1"/>
                 </a:solidFill>
@@ -3689,54 +3689,15 @@
                 <a:ea typeface="Lato" pitchFamily="34" charset="-122"/>
                 <a:cs typeface="Lato" pitchFamily="34" charset="-120"/>
               </a:rPr>
-              <a:t>EduInject</a:t>
-            </a:r>
-            <a:endParaRPr lang="en-US" sz="6000" dirty="0"/>
+              <a:t>EduInject: Indirect Prompt Injection in Staged AI Agents for School Administration</a:t>
+            </a:r>
+            <a:endParaRPr lang="en-US" sz="4000" dirty="0"/>
           </a:p>
         </p:txBody>
       </p:sp>
       <p:sp>
         <p:nvSpPr>
           <p:cNvPr id="3" name="Text 1"/>
-          <p:cNvSpPr txBox="1"/>
-          <p:nvPr/>
-        </p:nvSpPr>
-        <p:spPr>
-          <a:xfrm>
-            <a:off x="548640" y="3611880"/>
-            <a:ext cx="6766560" cy="914400"/>
-          </a:xfrm>
-          <a:prstGeom prst="rect">
-            <a:avLst/>
-          </a:prstGeom>
-          <a:noFill/>
-          <a:ln/>
-        </p:spPr>
-        <p:txBody>
-          <a:bodyPr wrap="square" lIns="0" tIns="0" rIns="0" bIns="0" rtlCol="0" anchor="ctr"/>
-          <a:lstStyle/>
-          <a:p>
-            <a:pPr indent="0" marL="0">
-              <a:buNone/>
-            </a:pPr>
-            <a:r>
-              <a:rPr lang="en-US" sz="2400" dirty="0">
-                <a:solidFill>
-                  <a:srgbClr val="FFFFFF"/>
-                </a:solidFill>
-                <a:latin typeface="Lato" pitchFamily="34" charset="0"/>
-                <a:ea typeface="Lato" pitchFamily="34" charset="-122"/>
-                <a:cs typeface="Lato" pitchFamily="34" charset="-120"/>
-              </a:rPr>
-              <a:t>Hidden instructions in school paperwork, and what they make AI agents do</a:t>
-            </a:r>
-            <a:endParaRPr lang="en-US" sz="2400" dirty="0"/>
-          </a:p>
-        </p:txBody>
-      </p:sp>
-      <p:sp>
-        <p:nvSpPr>
-          <p:cNvPr id="4" name="Text 2"/>
           <p:cNvSpPr txBox="1"/>
           <p:nvPr/>
         </p:nvSpPr>
@@ -3798,7 +3759,7 @@
       </p:sp>
       <p:pic>
         <p:nvPicPr>
-          <p:cNvPr id="5" name="title-art" descr="preencoded.png">    </p:cNvPr>
+          <p:cNvPr id="4" name="title-art" descr="preencoded.png">    </p:cNvPr>
           <p:cNvPicPr>
             <a:picLocks noChangeAspect="1"/>
           </p:cNvPicPr>
@@ -9468,8 +9429,8 @@
         </p:nvSpPr>
         <p:spPr>
           <a:xfrm>
-            <a:off x="548640" y="2011680"/>
-            <a:ext cx="11094415" cy="1463040"/>
+            <a:off x="548640" y="1097280"/>
+            <a:ext cx="6858000" cy="3291840"/>
           </a:xfrm>
           <a:prstGeom prst="rect">
             <a:avLst/>
@@ -9484,7 +9445,7 @@
             <a:pPr algn="l" indent="0" marL="0">
               <a:buNone/>
             </a:pPr>
-            <a:endParaRPr lang="en-US" sz="6000" dirty="0"/>
+            <a:endParaRPr lang="en-US" sz="4000" dirty="0"/>
           </a:p>
         </p:txBody>
       </p:sp>

</xml_diff>

<commit_message>
Slides: drop school names under the team photos
</commit_message>
<xml_diff>
--- a/presentation/eduinject-slides.pptx
+++ b/presentation/eduinject-slides.pptx
@@ -119,25 +119,25 @@
   <p:extLst>
     <p:ext uri="{521415D9-36F7-43E2-AB2F-B90AF26B5E84}">
       <p14:sectionLst xmlns:p14="http://schemas.microsoft.com/office/powerpoint/2010/main">
-        <p14:section name="Opening" id="{010025e6-24b6-5fcd-ac0a-5de39626cc49}">
+        <p14:section name="Opening" id="{55d7887e-6ba7-88c9-8d96-0df0091e00e7}">
           <p14:sldIdLst>
             <p14:sldId id="256"/>
           </p14:sldIdLst>
         </p14:section>
-        <p14:section name="Problem" id="{60a85fce-a8c9-2c1f-430a-f903268fb1e5}">
+        <p14:section name="Problem" id="{0a5833d3-27be-ece5-eda9-a7a35d3d69ed}">
           <p14:sldIdLst>
             <p14:sldId id="257"/>
             <p14:sldId id="258"/>
           </p14:sldIdLst>
         </p14:section>
-        <p14:section name="Method" id="{e28560ca-f3a3-f92a-2d8f-01346c9a493b}">
+        <p14:section name="Method" id="{944fe804-4a65-e294-1a4c-720ce656b4d9}">
           <p14:sldIdLst>
             <p14:sldId id="259"/>
             <p14:sldId id="260"/>
             <p14:sldId id="261"/>
           </p14:sldIdLst>
         </p14:section>
-        <p14:section name="Findings" id="{27fa555e-9a33-0a4b-108f-64a01e22004b}">
+        <p14:section name="Findings" id="{63dcfbbf-a76c-aa3b-c82b-5cfeac19f8b4}">
           <p14:sldIdLst>
             <p14:sldId id="262"/>
             <p14:sldId id="263"/>
@@ -145,7 +145,7 @@
             <p14:sldId id="265"/>
           </p14:sldIdLst>
         </p14:section>
-        <p14:section name="Takeaways" id="{02b3a5b5-1f36-c852-0ff5-8ff2bac16ef5}">
+        <p14:section name="Takeaways" id="{235742cd-faad-7b31-8411-d9a770021e1b}">
           <p14:sldIdLst>
             <p14:sldId id="266"/>
             <p14:sldId id="267"/>
@@ -8995,46 +8995,7 @@
       </p:sp>
       <p:sp>
         <p:nvSpPr>
-          <p:cNvPr id="24" name="Text 21"/>
-          <p:cNvSpPr txBox="1"/>
-          <p:nvPr/>
-        </p:nvSpPr>
-        <p:spPr>
-          <a:xfrm>
-            <a:off x="320040" y="5577840"/>
-            <a:ext cx="2743200" cy="320040"/>
-          </a:xfrm>
-          <a:prstGeom prst="rect">
-            <a:avLst/>
-          </a:prstGeom>
-          <a:noFill/>
-          <a:ln/>
-        </p:spPr>
-        <p:txBody>
-          <a:bodyPr wrap="square" lIns="0" tIns="0" rIns="0" bIns="0" rtlCol="0" anchor="ctr"/>
-          <a:lstStyle/>
-          <a:p>
-            <a:pPr algn="ctr" indent="0" marL="0">
-              <a:buNone/>
-            </a:pPr>
-            <a:r>
-              <a:rPr lang="en-US" sz="1200" dirty="0">
-                <a:solidFill>
-                  <a:srgbClr val="B9C4BF"/>
-                </a:solidFill>
-                <a:latin typeface="Lato" pitchFamily="34" charset="0"/>
-                <a:ea typeface="Lato" pitchFamily="34" charset="-122"/>
-                <a:cs typeface="Lato" pitchFamily="34" charset="-120"/>
-              </a:rPr>
-              <a:t>John P. Stevens HS</a:t>
-            </a:r>
-            <a:endParaRPr lang="en-US" sz="1200" dirty="0"/>
-          </a:p>
-        </p:txBody>
-      </p:sp>
-      <p:sp>
-        <p:nvSpPr>
-          <p:cNvPr id="25" name="photo-Rohan Bhamidipati"/>
+          <p:cNvPr id="24" name="photo-Rohan Bhamidipati"/>
           <p:cNvSpPr/>
           <p:nvPr/>
         </p:nvSpPr>
@@ -9059,7 +9020,7 @@
       </p:sp>
       <p:pic>
         <p:nvPicPr>
-          <p:cNvPr id="26" name="Image 1" descr="preencoded.png">    </p:cNvPr>
+          <p:cNvPr id="25" name="Image 1" descr="preencoded.png">    </p:cNvPr>
           <p:cNvPicPr>
             <a:picLocks noChangeAspect="1"/>
           </p:cNvPicPr>
@@ -9085,7 +9046,7 @@
       </p:pic>
       <p:sp>
         <p:nvSpPr>
-          <p:cNvPr id="27" name="Text 23"/>
+          <p:cNvPr id="26" name="Text 22"/>
           <p:cNvSpPr txBox="1"/>
           <p:nvPr/>
         </p:nvSpPr>
@@ -9124,46 +9085,7 @@
       </p:sp>
       <p:sp>
         <p:nvSpPr>
-          <p:cNvPr id="28" name="Text 24"/>
-          <p:cNvSpPr txBox="1"/>
-          <p:nvPr/>
-        </p:nvSpPr>
-        <p:spPr>
-          <a:xfrm>
-            <a:off x="3246120" y="5577840"/>
-            <a:ext cx="2743200" cy="320040"/>
-          </a:xfrm>
-          <a:prstGeom prst="rect">
-            <a:avLst/>
-          </a:prstGeom>
-          <a:noFill/>
-          <a:ln/>
-        </p:spPr>
-        <p:txBody>
-          <a:bodyPr wrap="square" lIns="0" tIns="0" rIns="0" bIns="0" rtlCol="0" anchor="ctr"/>
-          <a:lstStyle/>
-          <a:p>
-            <a:pPr algn="ctr" indent="0" marL="0">
-              <a:buNone/>
-            </a:pPr>
-            <a:r>
-              <a:rPr lang="en-US" sz="1200" dirty="0">
-                <a:solidFill>
-                  <a:srgbClr val="B9C4BF"/>
-                </a:solidFill>
-                <a:latin typeface="Lato" pitchFamily="34" charset="0"/>
-                <a:ea typeface="Lato" pitchFamily="34" charset="-122"/>
-                <a:cs typeface="Lato" pitchFamily="34" charset="-120"/>
-              </a:rPr>
-              <a:t>The Peddie School</a:t>
-            </a:r>
-            <a:endParaRPr lang="en-US" sz="1200" dirty="0"/>
-          </a:p>
-        </p:txBody>
-      </p:sp>
-      <p:sp>
-        <p:nvSpPr>
-          <p:cNvPr id="29" name="photo-Chaitanya Palasamudrum"/>
+          <p:cNvPr id="27" name="photo-Chaitanya Palasamudrum"/>
           <p:cNvSpPr/>
           <p:nvPr/>
         </p:nvSpPr>
@@ -9188,7 +9110,7 @@
       </p:sp>
       <p:pic>
         <p:nvPicPr>
-          <p:cNvPr id="30" name="Image 2" descr="preencoded.png">    </p:cNvPr>
+          <p:cNvPr id="28" name="Image 2" descr="preencoded.png">    </p:cNvPr>
           <p:cNvPicPr>
             <a:picLocks noChangeAspect="1"/>
           </p:cNvPicPr>
@@ -9214,7 +9136,7 @@
       </p:pic>
       <p:sp>
         <p:nvSpPr>
-          <p:cNvPr id="31" name="Text 26"/>
+          <p:cNvPr id="29" name="Text 24"/>
           <p:cNvSpPr txBox="1"/>
           <p:nvPr/>
         </p:nvSpPr>
@@ -9253,46 +9175,7 @@
       </p:sp>
       <p:sp>
         <p:nvSpPr>
-          <p:cNvPr id="32" name="Text 27"/>
-          <p:cNvSpPr txBox="1"/>
-          <p:nvPr/>
-        </p:nvSpPr>
-        <p:spPr>
-          <a:xfrm>
-            <a:off x="6172200" y="5577840"/>
-            <a:ext cx="2743200" cy="320040"/>
-          </a:xfrm>
-          <a:prstGeom prst="rect">
-            <a:avLst/>
-          </a:prstGeom>
-          <a:noFill/>
-          <a:ln/>
-        </p:spPr>
-        <p:txBody>
-          <a:bodyPr wrap="square" lIns="0" tIns="0" rIns="0" bIns="0" rtlCol="0" anchor="ctr"/>
-          <a:lstStyle/>
-          <a:p>
-            <a:pPr algn="ctr" indent="0" marL="0">
-              <a:buNone/>
-            </a:pPr>
-            <a:r>
-              <a:rPr lang="en-US" sz="1200" dirty="0">
-                <a:solidFill>
-                  <a:srgbClr val="B9C4BF"/>
-                </a:solidFill>
-                <a:latin typeface="Lato" pitchFamily="34" charset="0"/>
-                <a:ea typeface="Lato" pitchFamily="34" charset="-122"/>
-                <a:cs typeface="Lato" pitchFamily="34" charset="-120"/>
-              </a:rPr>
-              <a:t>John P. Stevens HS</a:t>
-            </a:r>
-            <a:endParaRPr lang="en-US" sz="1200" dirty="0"/>
-          </a:p>
-        </p:txBody>
-      </p:sp>
-      <p:sp>
-        <p:nvSpPr>
-          <p:cNvPr id="33" name="photo-Bibhuti Swain"/>
+          <p:cNvPr id="30" name="photo-Bibhuti Swain"/>
           <p:cNvSpPr/>
           <p:nvPr/>
         </p:nvSpPr>
@@ -9317,7 +9200,7 @@
       </p:sp>
       <p:pic>
         <p:nvPicPr>
-          <p:cNvPr id="34" name="Image 3" descr="preencoded.png">    </p:cNvPr>
+          <p:cNvPr id="31" name="Image 3" descr="preencoded.png">    </p:cNvPr>
           <p:cNvPicPr>
             <a:picLocks noChangeAspect="1"/>
           </p:cNvPicPr>
@@ -9343,7 +9226,7 @@
       </p:pic>
       <p:sp>
         <p:nvSpPr>
-          <p:cNvPr id="35" name="Text 29"/>
+          <p:cNvPr id="32" name="Text 26"/>
           <p:cNvSpPr txBox="1"/>
           <p:nvPr/>
         </p:nvSpPr>
@@ -9382,46 +9265,7 @@
       </p:sp>
       <p:sp>
         <p:nvSpPr>
-          <p:cNvPr id="36" name="Text 30"/>
-          <p:cNvSpPr txBox="1"/>
-          <p:nvPr/>
-        </p:nvSpPr>
-        <p:spPr>
-          <a:xfrm>
-            <a:off x="9098280" y="5577840"/>
-            <a:ext cx="2743200" cy="320040"/>
-          </a:xfrm>
-          <a:prstGeom prst="rect">
-            <a:avLst/>
-          </a:prstGeom>
-          <a:noFill/>
-          <a:ln/>
-        </p:spPr>
-        <p:txBody>
-          <a:bodyPr wrap="square" lIns="0" tIns="0" rIns="0" bIns="0" rtlCol="0" anchor="ctr"/>
-          <a:lstStyle/>
-          <a:p>
-            <a:pPr algn="ctr" indent="0" marL="0">
-              <a:buNone/>
-            </a:pPr>
-            <a:r>
-              <a:rPr lang="en-US" sz="1200" dirty="0">
-                <a:solidFill>
-                  <a:srgbClr val="B9C4BF"/>
-                </a:solidFill>
-                <a:latin typeface="Lato" pitchFamily="34" charset="0"/>
-                <a:ea typeface="Lato" pitchFamily="34" charset="-122"/>
-                <a:cs typeface="Lato" pitchFamily="34" charset="-120"/>
-              </a:rPr>
-              <a:t>John P. Stevens HS</a:t>
-            </a:r>
-            <a:endParaRPr lang="en-US" sz="1200" dirty="0"/>
-          </a:p>
-        </p:txBody>
-      </p:sp>
-      <p:sp>
-        <p:nvSpPr>
-          <p:cNvPr id="38" name="Text 0"/>
+          <p:cNvPr id="34" name="Text 0"/>
           <p:cNvSpPr/>
           <p:nvPr>
             <p:ph idx="100" type="title" hasCustomPrompt="1"/>

</xml_diff>